<commit_message>
Hapus slide jurnal dari PPT, tambah kesimpulan paragraf, bersihkan file template
</commit_message>
<xml_diff>
--- a/presentasi_ta.pptx
+++ b/presentasi_ta.pptx
@@ -36,11 +36,6 @@
     <p:sldId id="284" r:id="rId35"/>
     <p:sldId id="285" r:id="rId36"/>
     <p:sldId id="286" r:id="rId37"/>
-    <p:sldId id="287" r:id="rId38"/>
-    <p:sldId id="288" r:id="rId39"/>
-    <p:sldId id="289" r:id="rId40"/>
-    <p:sldId id="290" r:id="rId41"/>
-    <p:sldId id="291" r:id="rId42"/>
   </p:sldIdLst>
   <p:sldSz cx="12191695" cy="6858000" type="screen4x3"/>
   <p:notesSz cx="6858000" cy="9144000"/>
@@ -8082,23 +8077,7 @@
               </a:defRPr>
             </a:pPr>
             <a:r>
-              <a:t>9.  Publikasi Jurnal</a:t>
-            </a:r>
-          </a:p>
-          <a:p>
-            <a:pPr>
-              <a:spcAft>
-                <a:spcPts val="600"/>
-              </a:spcAft>
-              <a:defRPr sz="1800">
-                <a:solidFill>
-                  <a:srgbClr val="2C3E50"/>
-                </a:solidFill>
-                <a:latin typeface="Calibri"/>
-              </a:defRPr>
-            </a:pPr>
-            <a:r>
-              <a:t>10. Kesimpulan</a:t>
+              <a:t>9.  Kesimpulan</a:t>
             </a:r>
           </a:p>
         </p:txBody>
@@ -11720,111 +11699,6 @@
     <p:bg>
       <p:bgPr>
         <a:solidFill>
-          <a:srgbClr val="1A233B"/>
-        </a:solidFill>
-        <a:effectLst/>
-      </p:bgPr>
-    </p:bg>
-    <p:spTree>
-      <p:nvGrpSpPr>
-        <p:cNvPr id="1" name=""/>
-        <p:cNvGrpSpPr/>
-        <p:nvPr/>
-      </p:nvGrpSpPr>
-      <p:grpSpPr/>
-      <p:sp>
-        <p:nvSpPr>
-          <p:cNvPr id="2" name="Rectangle 1"/>
-          <p:cNvSpPr/>
-          <p:nvPr/>
-        </p:nvSpPr>
-        <p:spPr>
-          <a:xfrm>
-            <a:off x="0" y="3200400"/>
-            <a:ext cx="12191695" cy="54864"/>
-          </a:xfrm>
-          <a:prstGeom prst="rect">
-            <a:avLst/>
-          </a:prstGeom>
-          <a:solidFill>
-            <a:srgbClr val="3498DB"/>
-          </a:solidFill>
-          <a:ln>
-            <a:noFill/>
-          </a:ln>
-        </p:spPr>
-        <p:style>
-          <a:lnRef idx="1">
-            <a:schemeClr val="accent1"/>
-          </a:lnRef>
-          <a:fillRef idx="3">
-            <a:schemeClr val="accent1"/>
-          </a:fillRef>
-          <a:effectRef idx="2">
-            <a:schemeClr val="accent1"/>
-          </a:effectRef>
-          <a:fontRef idx="minor">
-            <a:schemeClr val="lt1"/>
-          </a:fontRef>
-        </p:style>
-        <p:txBody>
-          <a:bodyPr rtlCol="0" anchor="ctr"/>
-          <a:lstStyle/>
-          <a:p>
-            <a:pPr algn="ctr"/>
-          </a:p>
-        </p:txBody>
-      </p:sp>
-      <p:sp>
-        <p:nvSpPr>
-          <p:cNvPr id="3" name="TextBox 2"/>
-          <p:cNvSpPr txBox="1"/>
-          <p:nvPr/>
-        </p:nvSpPr>
-        <p:spPr>
-          <a:xfrm>
-            <a:off x="914400" y="2286000"/>
-            <a:ext cx="10058400" cy="914400"/>
-          </a:xfrm>
-          <a:prstGeom prst="rect">
-            <a:avLst/>
-          </a:prstGeom>
-          <a:noFill/>
-        </p:spPr>
-        <p:txBody>
-          <a:bodyPr wrap="square">
-            <a:spAutoFit/>
-          </a:bodyPr>
-          <a:lstStyle/>
-          <a:p>
-            <a:pPr algn="ctr">
-              <a:defRPr sz="3200" b="1">
-                <a:solidFill>
-                  <a:srgbClr val="FFFFFF"/>
-                </a:solidFill>
-                <a:latin typeface="Calibri"/>
-              </a:defRPr>
-            </a:pPr>
-            <a:r>
-              <a:t>Publikasi Jurnal</a:t>
-            </a:r>
-          </a:p>
-        </p:txBody>
-      </p:sp>
-    </p:spTree>
-  </p:cSld>
-  <p:clrMapOvr>
-    <a:masterClrMapping/>
-  </p:clrMapOvr>
-</p:sld>
-</file>
-
-<file path=ppt/slides/slide31.xml><?xml version="1.0" encoding="utf-8"?>
-<p:sld xmlns:a="http://schemas.openxmlformats.org/drawingml/2006/main" xmlns:p="http://schemas.openxmlformats.org/presentationml/2006/main" xmlns:r="http://schemas.openxmlformats.org/officeDocument/2006/relationships">
-  <p:cSld>
-    <p:bg>
-      <p:bgPr>
-        <a:solidFill>
           <a:srgbClr val="FFFFFF"/>
         </a:solidFill>
         <a:effectLst/>
@@ -11911,7 +11785,7 @@
               </a:defRPr>
             </a:pPr>
             <a:r>
-              <a:t>Paper Jurnal</a:t>
+              <a:t>Kesimpulan</a:t>
             </a:r>
           </a:p>
         </p:txBody>
@@ -11967,8 +11841,8 @@
         </p:nvSpPr>
         <p:spPr>
           <a:xfrm>
-            <a:off x="548640" y="1188720"/>
-            <a:ext cx="5303520" cy="365760"/>
+            <a:off x="548640" y="1097280"/>
+            <a:ext cx="10972800" cy="5029200"/>
           </a:xfrm>
           <a:prstGeom prst="rect">
             <a:avLst/>
@@ -11982,261 +11856,15 @@
           <a:lstStyle/>
           <a:p>
             <a:pPr algn="l">
-              <a:defRPr sz="1800" b="1">
-                <a:solidFill>
-                  <a:srgbClr val="2C3E6B"/>
+              <a:defRPr sz="1600" b="0">
+                <a:solidFill>
+                  <a:srgbClr val="2C3E50"/>
                 </a:solidFill>
                 <a:latin typeface="Calibri"/>
               </a:defRPr>
             </a:pPr>
             <a:r>
-              <a:t>Format &amp; Template</a:t>
-            </a:r>
-          </a:p>
-        </p:txBody>
-      </p:sp>
-      <p:sp>
-        <p:nvSpPr>
-          <p:cNvPr id="6" name="TextBox 5"/>
-          <p:cNvSpPr txBox="1"/>
-          <p:nvPr/>
-        </p:nvSpPr>
-        <p:spPr>
-          <a:xfrm>
-            <a:off x="548640" y="1645920"/>
-            <a:ext cx="5303520" cy="4572000"/>
-          </a:xfrm>
-          <a:prstGeom prst="rect">
-            <a:avLst/>
-          </a:prstGeom>
-          <a:noFill/>
-        </p:spPr>
-        <p:txBody>
-          <a:bodyPr wrap="square">
-            <a:spAutoFit/>
-          </a:bodyPr>
-          <a:lstStyle/>
-          <a:p>
-            <a:pPr>
-              <a:spcAft>
-                <a:spcPts val="600"/>
-              </a:spcAft>
-              <a:defRPr sz="1500">
-                <a:solidFill>
-                  <a:srgbClr val="2C3E50"/>
-                </a:solidFill>
-                <a:latin typeface="Calibri"/>
-              </a:defRPr>
-            </a:pPr>
-            <a:r>
-              <a:t>Jurnal: JJCIT (Jordanian Journal of Computers</a:t>
-            </a:r>
-            <a:br/>
-            <a:r>
-              <a:t>  and Information Technology)</a:t>
-            </a:r>
-          </a:p>
-          <a:p>
-            <a:pPr>
-              <a:spcAft>
-                <a:spcPts val="600"/>
-              </a:spcAft>
-              <a:defRPr sz="1500">
-                <a:solidFill>
-                  <a:srgbClr val="2C3E50"/>
-                </a:solidFill>
-                <a:latin typeface="Calibri"/>
-              </a:defRPr>
-            </a:pPr>
-            <a:r>
-              <a:t>Format: IEEE-style references</a:t>
-            </a:r>
-          </a:p>
-          <a:p>
-            <a:pPr>
-              <a:spcAft>
-                <a:spcPts val="600"/>
-              </a:spcAft>
-              <a:defRPr sz="1500">
-                <a:solidFill>
-                  <a:srgbClr val="2C3E50"/>
-                </a:solidFill>
-                <a:latin typeface="Calibri"/>
-              </a:defRPr>
-            </a:pPr>
-            <a:r>
-              <a:t>Template: MS Word .doc JJCIT</a:t>
-            </a:r>
-          </a:p>
-          <a:p>
-            <a:pPr>
-              <a:spcAft>
-                <a:spcPts val="600"/>
-              </a:spcAft>
-              <a:defRPr sz="1500">
-                <a:solidFill>
-                  <a:srgbClr val="2C3E50"/>
-                </a:solidFill>
-                <a:latin typeface="Calibri"/>
-              </a:defRPr>
-            </a:pPr>
-            <a:r>
-              <a:t>Maks: 16 halaman</a:t>
-            </a:r>
-          </a:p>
-          <a:p>
-            <a:pPr>
-              <a:spcAft>
-                <a:spcPts val="600"/>
-              </a:spcAft>
-              <a:defRPr sz="1500">
-                <a:solidFill>
-                  <a:srgbClr val="2C3E50"/>
-                </a:solidFill>
-                <a:latin typeface="Calibri"/>
-              </a:defRPr>
-            </a:pPr>
-            <a:r>
-              <a:t>Bahasa: English</a:t>
-            </a:r>
-          </a:p>
-        </p:txBody>
-      </p:sp>
-      <p:sp>
-        <p:nvSpPr>
-          <p:cNvPr id="7" name="TextBox 6"/>
-          <p:cNvSpPr txBox="1"/>
-          <p:nvPr/>
-        </p:nvSpPr>
-        <p:spPr>
-          <a:xfrm>
-            <a:off x="6217920" y="1188720"/>
-            <a:ext cx="5303520" cy="365760"/>
-          </a:xfrm>
-          <a:prstGeom prst="rect">
-            <a:avLst/>
-          </a:prstGeom>
-          <a:noFill/>
-        </p:spPr>
-        <p:txBody>
-          <a:bodyPr wrap="square">
-            <a:spAutoFit/>
-          </a:bodyPr>
-          <a:lstStyle/>
-          <a:p>
-            <a:pPr algn="l">
-              <a:defRPr sz="1800" b="1">
-                <a:solidFill>
-                  <a:srgbClr val="2C3E6B"/>
-                </a:solidFill>
-                <a:latin typeface="Calibri"/>
-              </a:defRPr>
-            </a:pPr>
-            <a:r>
-              <a:t>Konten Paper</a:t>
-            </a:r>
-          </a:p>
-        </p:txBody>
-      </p:sp>
-      <p:sp>
-        <p:nvSpPr>
-          <p:cNvPr id="8" name="TextBox 7"/>
-          <p:cNvSpPr txBox="1"/>
-          <p:nvPr/>
-        </p:nvSpPr>
-        <p:spPr>
-          <a:xfrm>
-            <a:off x="6217920" y="1645920"/>
-            <a:ext cx="5303520" cy="4572000"/>
-          </a:xfrm>
-          <a:prstGeom prst="rect">
-            <a:avLst/>
-          </a:prstGeom>
-          <a:noFill/>
-        </p:spPr>
-        <p:txBody>
-          <a:bodyPr wrap="square">
-            <a:spAutoFit/>
-          </a:bodyPr>
-          <a:lstStyle/>
-          <a:p>
-            <a:pPr>
-              <a:spcAft>
-                <a:spcPts val="600"/>
-              </a:spcAft>
-              <a:defRPr sz="1500">
-                <a:solidFill>
-                  <a:srgbClr val="2C3E50"/>
-                </a:solidFill>
-                <a:latin typeface="Calibri"/>
-              </a:defRPr>
-            </a:pPr>
-            <a:r>
-              <a:t>7 sections: Introduction s/d Conclusion</a:t>
-            </a:r>
-          </a:p>
-          <a:p>
-            <a:pPr>
-              <a:spcAft>
-                <a:spcPts val="600"/>
-              </a:spcAft>
-              <a:defRPr sz="1500">
-                <a:solidFill>
-                  <a:srgbClr val="2C3E50"/>
-                </a:solidFill>
-                <a:latin typeface="Calibri"/>
-              </a:defRPr>
-            </a:pPr>
-            <a:r>
-              <a:t>5 figure publikasi (300 DPI, print-ready)</a:t>
-            </a:r>
-          </a:p>
-          <a:p>
-            <a:pPr>
-              <a:spcAft>
-                <a:spcPts val="600"/>
-              </a:spcAft>
-              <a:defRPr sz="1500">
-                <a:solidFill>
-                  <a:srgbClr val="2C3E50"/>
-                </a:solidFill>
-                <a:latin typeface="Calibri"/>
-              </a:defRPr>
-            </a:pPr>
-            <a:r>
-              <a:t>3 tabel (parameter, hasil, statistik)</a:t>
-            </a:r>
-          </a:p>
-          <a:p>
-            <a:pPr>
-              <a:spcAft>
-                <a:spcPts val="600"/>
-              </a:spcAft>
-              <a:defRPr sz="1500">
-                <a:solidFill>
-                  <a:srgbClr val="2C3E50"/>
-                </a:solidFill>
-                <a:latin typeface="Calibri"/>
-              </a:defRPr>
-            </a:pPr>
-            <a:r>
-              <a:t>18 referensi (2022-2025, real &amp; terverifikasi)</a:t>
-            </a:r>
-          </a:p>
-          <a:p>
-            <a:pPr>
-              <a:spcAft>
-                <a:spcPts val="600"/>
-              </a:spcAft>
-              <a:defRPr sz="1500">
-                <a:solidFill>
-                  <a:srgbClr val="2C3E50"/>
-                </a:solidFill>
-                <a:latin typeface="Calibri"/>
-              </a:defRPr>
-            </a:pPr>
-            <a:r>
-              <a:t>Lokasi: paper/manuscript/paper_jjcit.docx</a:t>
+              <a:t>Penelitian ini berhasil mengembangkan model simulasi berbasis agen (Agent-Based Modeling) untuk menganalisis propagasi ancaman siber pada jaringan server lokal dengan dua strategi intervensi utama, yaitu patch management dan user training. Melalui simulasi Monte Carlo sebanyak 30 kali ulangan pada masing-masing dari empat skenario yang diuji, diperoleh hasil bahwa intervensi patch management mampu mereduksi puncak infeksi sebesar 20.0%, intervensi user training mereduksi sebesar 13.3%, dan kombinasi keduanya memberikan reduksi paling signifikan yaitu 33.3% dibandingkan dengan skenario baseline tanpa intervensi. Seluruh perbedaan antar skenario terkonfirmasi signifikan secara statistik melalui uji Mann-Whitney U dengan nilai p &lt; 0.001. Temuan ini membuktikan bahwa strategi keamanan berlapis (layered defense) yang menggabungkan intervensi teknis dan human-centered memberikan perlindungan yang jauh lebih efektif dibandingkan menerapkan salah satu intervensi secara terpisah. Selain itu, dashboard interaktif berbasis Streamlit yang dikembangkan memungkinkan eksplorasi parameter secara real-time dan visualisasi hasil yang komprehensif, sehingga dapat menjadi alat bantu pengambilan keputusan dalam alokasi sumber daya keamanan siber di lingkungan organisasi.</a:t>
             </a:r>
           </a:p>
         </p:txBody>
@@ -12249,2652 +11877,7 @@
 </p:sld>
 </file>
 
-<file path=ppt/slides/slide32.xml><?xml version="1.0" encoding="utf-8"?>
-<p:sld xmlns:a="http://schemas.openxmlformats.org/drawingml/2006/main" xmlns:p="http://schemas.openxmlformats.org/presentationml/2006/main" xmlns:r="http://schemas.openxmlformats.org/officeDocument/2006/relationships">
-  <p:cSld>
-    <p:bg>
-      <p:bgPr>
-        <a:solidFill>
-          <a:srgbClr val="FFFFFF"/>
-        </a:solidFill>
-        <a:effectLst/>
-      </p:bgPr>
-    </p:bg>
-    <p:spTree>
-      <p:nvGrpSpPr>
-        <p:cNvPr id="1" name=""/>
-        <p:cNvGrpSpPr/>
-        <p:nvPr/>
-      </p:nvGrpSpPr>
-      <p:grpSpPr/>
-      <p:sp>
-        <p:nvSpPr>
-          <p:cNvPr id="2" name="Rectangle 1"/>
-          <p:cNvSpPr/>
-          <p:nvPr/>
-        </p:nvSpPr>
-        <p:spPr>
-          <a:xfrm>
-            <a:off x="0" y="0"/>
-            <a:ext cx="12191695" cy="822960"/>
-          </a:xfrm>
-          <a:prstGeom prst="rect">
-            <a:avLst/>
-          </a:prstGeom>
-          <a:solidFill>
-            <a:srgbClr val="1A233B"/>
-          </a:solidFill>
-          <a:ln>
-            <a:noFill/>
-          </a:ln>
-        </p:spPr>
-        <p:style>
-          <a:lnRef idx="1">
-            <a:schemeClr val="accent1"/>
-          </a:lnRef>
-          <a:fillRef idx="3">
-            <a:schemeClr val="accent1"/>
-          </a:fillRef>
-          <a:effectRef idx="2">
-            <a:schemeClr val="accent1"/>
-          </a:effectRef>
-          <a:fontRef idx="minor">
-            <a:schemeClr val="lt1"/>
-          </a:fontRef>
-        </p:style>
-        <p:txBody>
-          <a:bodyPr rtlCol="0" anchor="ctr"/>
-          <a:lstStyle/>
-          <a:p>
-            <a:pPr algn="ctr"/>
-          </a:p>
-        </p:txBody>
-      </p:sp>
-      <p:sp>
-        <p:nvSpPr>
-          <p:cNvPr id="3" name="TextBox 2"/>
-          <p:cNvSpPr txBox="1"/>
-          <p:nvPr/>
-        </p:nvSpPr>
-        <p:spPr>
-          <a:xfrm>
-            <a:off x="548640" y="137160"/>
-            <a:ext cx="10972800" cy="548640"/>
-          </a:xfrm>
-          <a:prstGeom prst="rect">
-            <a:avLst/>
-          </a:prstGeom>
-          <a:noFill/>
-        </p:spPr>
-        <p:txBody>
-          <a:bodyPr wrap="square">
-            <a:spAutoFit/>
-          </a:bodyPr>
-          <a:lstStyle/>
-          <a:p>
-            <a:pPr algn="l">
-              <a:defRPr sz="2400" b="1">
-                <a:solidFill>
-                  <a:srgbClr val="FFFFFF"/>
-                </a:solidFill>
-                <a:latin typeface="Calibri"/>
-              </a:defRPr>
-            </a:pPr>
-            <a:r>
-              <a:t>Struktur Paper Jurnal</a:t>
-            </a:r>
-          </a:p>
-        </p:txBody>
-      </p:sp>
-      <p:sp>
-        <p:nvSpPr>
-          <p:cNvPr id="4" name="Rectangle 3"/>
-          <p:cNvSpPr/>
-          <p:nvPr/>
-        </p:nvSpPr>
-        <p:spPr>
-          <a:xfrm>
-            <a:off x="0" y="822960"/>
-            <a:ext cx="12191695" cy="36576"/>
-          </a:xfrm>
-          <a:prstGeom prst="rect">
-            <a:avLst/>
-          </a:prstGeom>
-          <a:solidFill>
-            <a:srgbClr val="3498DB"/>
-          </a:solidFill>
-          <a:ln>
-            <a:noFill/>
-          </a:ln>
-        </p:spPr>
-        <p:style>
-          <a:lnRef idx="1">
-            <a:schemeClr val="accent1"/>
-          </a:lnRef>
-          <a:fillRef idx="3">
-            <a:schemeClr val="accent1"/>
-          </a:fillRef>
-          <a:effectRef idx="2">
-            <a:schemeClr val="accent1"/>
-          </a:effectRef>
-          <a:fontRef idx="minor">
-            <a:schemeClr val="lt1"/>
-          </a:fontRef>
-        </p:style>
-        <p:txBody>
-          <a:bodyPr rtlCol="0" anchor="ctr"/>
-          <a:lstStyle/>
-          <a:p>
-            <a:pPr algn="ctr"/>
-          </a:p>
-        </p:txBody>
-      </p:sp>
-      <p:sp>
-        <p:nvSpPr>
-          <p:cNvPr id="5" name="Rectangle 4"/>
-          <p:cNvSpPr/>
-          <p:nvPr/>
-        </p:nvSpPr>
-        <p:spPr>
-          <a:xfrm>
-            <a:off x="548640" y="1280160"/>
-            <a:ext cx="10972800" cy="502920"/>
-          </a:xfrm>
-          <a:prstGeom prst="rect">
-            <a:avLst/>
-          </a:prstGeom>
-          <a:solidFill>
-            <a:srgbClr val="F8F9FA"/>
-          </a:solidFill>
-          <a:ln>
-            <a:noFill/>
-          </a:ln>
-        </p:spPr>
-        <p:style>
-          <a:lnRef idx="1">
-            <a:schemeClr val="accent1"/>
-          </a:lnRef>
-          <a:fillRef idx="3">
-            <a:schemeClr val="accent1"/>
-          </a:fillRef>
-          <a:effectRef idx="2">
-            <a:schemeClr val="accent1"/>
-          </a:effectRef>
-          <a:fontRef idx="minor">
-            <a:schemeClr val="lt1"/>
-          </a:fontRef>
-        </p:style>
-        <p:txBody>
-          <a:bodyPr rtlCol="0" anchor="ctr"/>
-          <a:lstStyle/>
-          <a:p>
-            <a:pPr algn="ctr"/>
-          </a:p>
-        </p:txBody>
-      </p:sp>
-      <p:sp>
-        <p:nvSpPr>
-          <p:cNvPr id="6" name="Rectangle 5"/>
-          <p:cNvSpPr/>
-          <p:nvPr/>
-        </p:nvSpPr>
-        <p:spPr>
-          <a:xfrm>
-            <a:off x="548640" y="1280160"/>
-            <a:ext cx="54864" cy="502920"/>
-          </a:xfrm>
-          <a:prstGeom prst="rect">
-            <a:avLst/>
-          </a:prstGeom>
-          <a:solidFill>
-            <a:srgbClr val="3498DB"/>
-          </a:solidFill>
-          <a:ln>
-            <a:noFill/>
-          </a:ln>
-        </p:spPr>
-        <p:style>
-          <a:lnRef idx="1">
-            <a:schemeClr val="accent1"/>
-          </a:lnRef>
-          <a:fillRef idx="3">
-            <a:schemeClr val="accent1"/>
-          </a:fillRef>
-          <a:effectRef idx="2">
-            <a:schemeClr val="accent1"/>
-          </a:effectRef>
-          <a:fontRef idx="minor">
-            <a:schemeClr val="lt1"/>
-          </a:fontRef>
-        </p:style>
-        <p:txBody>
-          <a:bodyPr rtlCol="0" anchor="ctr"/>
-          <a:lstStyle/>
-          <a:p>
-            <a:pPr algn="ctr"/>
-          </a:p>
-        </p:txBody>
-      </p:sp>
-      <p:sp>
-        <p:nvSpPr>
-          <p:cNvPr id="7" name="TextBox 6"/>
-          <p:cNvSpPr txBox="1"/>
-          <p:nvPr/>
-        </p:nvSpPr>
-        <p:spPr>
-          <a:xfrm>
-            <a:off x="822960" y="1353312"/>
-            <a:ext cx="10515600" cy="365760"/>
-          </a:xfrm>
-          <a:prstGeom prst="rect">
-            <a:avLst/>
-          </a:prstGeom>
-          <a:noFill/>
-        </p:spPr>
-        <p:txBody>
-          <a:bodyPr wrap="square">
-            <a:spAutoFit/>
-          </a:bodyPr>
-          <a:lstStyle/>
-          <a:p>
-            <a:pPr algn="l">
-              <a:defRPr sz="1500" b="0">
-                <a:solidFill>
-                  <a:srgbClr val="2C3E50"/>
-                </a:solidFill>
-                <a:latin typeface="Calibri"/>
-              </a:defRPr>
-            </a:pPr>
-            <a:r>
-              <a:t>1. Introduction - Latar belakang, motivasi, kontribusi</a:t>
-            </a:r>
-          </a:p>
-        </p:txBody>
-      </p:sp>
-      <p:sp>
-        <p:nvSpPr>
-          <p:cNvPr id="8" name="Rectangle 7"/>
-          <p:cNvSpPr/>
-          <p:nvPr/>
-        </p:nvSpPr>
-        <p:spPr>
-          <a:xfrm>
-            <a:off x="548640" y="1920240"/>
-            <a:ext cx="10972800" cy="502920"/>
-          </a:xfrm>
-          <a:prstGeom prst="rect">
-            <a:avLst/>
-          </a:prstGeom>
-          <a:solidFill>
-            <a:srgbClr val="F8F9FA"/>
-          </a:solidFill>
-          <a:ln>
-            <a:noFill/>
-          </a:ln>
-        </p:spPr>
-        <p:style>
-          <a:lnRef idx="1">
-            <a:schemeClr val="accent1"/>
-          </a:lnRef>
-          <a:fillRef idx="3">
-            <a:schemeClr val="accent1"/>
-          </a:fillRef>
-          <a:effectRef idx="2">
-            <a:schemeClr val="accent1"/>
-          </a:effectRef>
-          <a:fontRef idx="minor">
-            <a:schemeClr val="lt1"/>
-          </a:fontRef>
-        </p:style>
-        <p:txBody>
-          <a:bodyPr rtlCol="0" anchor="ctr"/>
-          <a:lstStyle/>
-          <a:p>
-            <a:pPr algn="ctr"/>
-          </a:p>
-        </p:txBody>
-      </p:sp>
-      <p:sp>
-        <p:nvSpPr>
-          <p:cNvPr id="9" name="Rectangle 8"/>
-          <p:cNvSpPr/>
-          <p:nvPr/>
-        </p:nvSpPr>
-        <p:spPr>
-          <a:xfrm>
-            <a:off x="548640" y="1920240"/>
-            <a:ext cx="54864" cy="502920"/>
-          </a:xfrm>
-          <a:prstGeom prst="rect">
-            <a:avLst/>
-          </a:prstGeom>
-          <a:solidFill>
-            <a:srgbClr val="3498DB"/>
-          </a:solidFill>
-          <a:ln>
-            <a:noFill/>
-          </a:ln>
-        </p:spPr>
-        <p:style>
-          <a:lnRef idx="1">
-            <a:schemeClr val="accent1"/>
-          </a:lnRef>
-          <a:fillRef idx="3">
-            <a:schemeClr val="accent1"/>
-          </a:fillRef>
-          <a:effectRef idx="2">
-            <a:schemeClr val="accent1"/>
-          </a:effectRef>
-          <a:fontRef idx="minor">
-            <a:schemeClr val="lt1"/>
-          </a:fontRef>
-        </p:style>
-        <p:txBody>
-          <a:bodyPr rtlCol="0" anchor="ctr"/>
-          <a:lstStyle/>
-          <a:p>
-            <a:pPr algn="ctr"/>
-          </a:p>
-        </p:txBody>
-      </p:sp>
-      <p:sp>
-        <p:nvSpPr>
-          <p:cNvPr id="10" name="TextBox 9"/>
-          <p:cNvSpPr txBox="1"/>
-          <p:nvPr/>
-        </p:nvSpPr>
-        <p:spPr>
-          <a:xfrm>
-            <a:off x="822960" y="1993392"/>
-            <a:ext cx="10515600" cy="365760"/>
-          </a:xfrm>
-          <a:prstGeom prst="rect">
-            <a:avLst/>
-          </a:prstGeom>
-          <a:noFill/>
-        </p:spPr>
-        <p:txBody>
-          <a:bodyPr wrap="square">
-            <a:spAutoFit/>
-          </a:bodyPr>
-          <a:lstStyle/>
-          <a:p>
-            <a:pPr algn="l">
-              <a:defRPr sz="1500" b="0">
-                <a:solidFill>
-                  <a:srgbClr val="2C3E50"/>
-                </a:solidFill>
-                <a:latin typeface="Calibri"/>
-              </a:defRPr>
-            </a:pPr>
-            <a:r>
-              <a:t>2. Related Work - ABM cybersecurity, patch mgmt, training, SIR models</a:t>
-            </a:r>
-          </a:p>
-        </p:txBody>
-      </p:sp>
-      <p:sp>
-        <p:nvSpPr>
-          <p:cNvPr id="11" name="Rectangle 10"/>
-          <p:cNvSpPr/>
-          <p:nvPr/>
-        </p:nvSpPr>
-        <p:spPr>
-          <a:xfrm>
-            <a:off x="548640" y="2560320"/>
-            <a:ext cx="10972800" cy="502920"/>
-          </a:xfrm>
-          <a:prstGeom prst="rect">
-            <a:avLst/>
-          </a:prstGeom>
-          <a:solidFill>
-            <a:srgbClr val="F8F9FA"/>
-          </a:solidFill>
-          <a:ln>
-            <a:noFill/>
-          </a:ln>
-        </p:spPr>
-        <p:style>
-          <a:lnRef idx="1">
-            <a:schemeClr val="accent1"/>
-          </a:lnRef>
-          <a:fillRef idx="3">
-            <a:schemeClr val="accent1"/>
-          </a:fillRef>
-          <a:effectRef idx="2">
-            <a:schemeClr val="accent1"/>
-          </a:effectRef>
-          <a:fontRef idx="minor">
-            <a:schemeClr val="lt1"/>
-          </a:fontRef>
-        </p:style>
-        <p:txBody>
-          <a:bodyPr rtlCol="0" anchor="ctr"/>
-          <a:lstStyle/>
-          <a:p>
-            <a:pPr algn="ctr"/>
-          </a:p>
-        </p:txBody>
-      </p:sp>
-      <p:sp>
-        <p:nvSpPr>
-          <p:cNvPr id="12" name="Rectangle 11"/>
-          <p:cNvSpPr/>
-          <p:nvPr/>
-        </p:nvSpPr>
-        <p:spPr>
-          <a:xfrm>
-            <a:off x="548640" y="2560320"/>
-            <a:ext cx="54864" cy="502920"/>
-          </a:xfrm>
-          <a:prstGeom prst="rect">
-            <a:avLst/>
-          </a:prstGeom>
-          <a:solidFill>
-            <a:srgbClr val="3498DB"/>
-          </a:solidFill>
-          <a:ln>
-            <a:noFill/>
-          </a:ln>
-        </p:spPr>
-        <p:style>
-          <a:lnRef idx="1">
-            <a:schemeClr val="accent1"/>
-          </a:lnRef>
-          <a:fillRef idx="3">
-            <a:schemeClr val="accent1"/>
-          </a:fillRef>
-          <a:effectRef idx="2">
-            <a:schemeClr val="accent1"/>
-          </a:effectRef>
-          <a:fontRef idx="minor">
-            <a:schemeClr val="lt1"/>
-          </a:fontRef>
-        </p:style>
-        <p:txBody>
-          <a:bodyPr rtlCol="0" anchor="ctr"/>
-          <a:lstStyle/>
-          <a:p>
-            <a:pPr algn="ctr"/>
-          </a:p>
-        </p:txBody>
-      </p:sp>
-      <p:sp>
-        <p:nvSpPr>
-          <p:cNvPr id="13" name="TextBox 12"/>
-          <p:cNvSpPr txBox="1"/>
-          <p:nvPr/>
-        </p:nvSpPr>
-        <p:spPr>
-          <a:xfrm>
-            <a:off x="822960" y="2633472"/>
-            <a:ext cx="10515600" cy="365760"/>
-          </a:xfrm>
-          <a:prstGeom prst="rect">
-            <a:avLst/>
-          </a:prstGeom>
-          <a:noFill/>
-        </p:spPr>
-        <p:txBody>
-          <a:bodyPr wrap="square">
-            <a:spAutoFit/>
-          </a:bodyPr>
-          <a:lstStyle/>
-          <a:p>
-            <a:pPr algn="l">
-              <a:defRPr sz="1500" b="0">
-                <a:solidFill>
-                  <a:srgbClr val="2C3E50"/>
-                </a:solidFill>
-                <a:latin typeface="Calibri"/>
-              </a:defRPr>
-            </a:pPr>
-            <a:r>
-              <a:t>3. Methodology - Model ABM, state machine, vulnerability equation</a:t>
-            </a:r>
-          </a:p>
-        </p:txBody>
-      </p:sp>
-      <p:sp>
-        <p:nvSpPr>
-          <p:cNvPr id="14" name="Rectangle 13"/>
-          <p:cNvSpPr/>
-          <p:nvPr/>
-        </p:nvSpPr>
-        <p:spPr>
-          <a:xfrm>
-            <a:off x="548640" y="3200399"/>
-            <a:ext cx="10972800" cy="502920"/>
-          </a:xfrm>
-          <a:prstGeom prst="rect">
-            <a:avLst/>
-          </a:prstGeom>
-          <a:solidFill>
-            <a:srgbClr val="F8F9FA"/>
-          </a:solidFill>
-          <a:ln>
-            <a:noFill/>
-          </a:ln>
-        </p:spPr>
-        <p:style>
-          <a:lnRef idx="1">
-            <a:schemeClr val="accent1"/>
-          </a:lnRef>
-          <a:fillRef idx="3">
-            <a:schemeClr val="accent1"/>
-          </a:fillRef>
-          <a:effectRef idx="2">
-            <a:schemeClr val="accent1"/>
-          </a:effectRef>
-          <a:fontRef idx="minor">
-            <a:schemeClr val="lt1"/>
-          </a:fontRef>
-        </p:style>
-        <p:txBody>
-          <a:bodyPr rtlCol="0" anchor="ctr"/>
-          <a:lstStyle/>
-          <a:p>
-            <a:pPr algn="ctr"/>
-          </a:p>
-        </p:txBody>
-      </p:sp>
-      <p:sp>
-        <p:nvSpPr>
-          <p:cNvPr id="15" name="Rectangle 14"/>
-          <p:cNvSpPr/>
-          <p:nvPr/>
-        </p:nvSpPr>
-        <p:spPr>
-          <a:xfrm>
-            <a:off x="548640" y="3200399"/>
-            <a:ext cx="54864" cy="502920"/>
-          </a:xfrm>
-          <a:prstGeom prst="rect">
-            <a:avLst/>
-          </a:prstGeom>
-          <a:solidFill>
-            <a:srgbClr val="3498DB"/>
-          </a:solidFill>
-          <a:ln>
-            <a:noFill/>
-          </a:ln>
-        </p:spPr>
-        <p:style>
-          <a:lnRef idx="1">
-            <a:schemeClr val="accent1"/>
-          </a:lnRef>
-          <a:fillRef idx="3">
-            <a:schemeClr val="accent1"/>
-          </a:fillRef>
-          <a:effectRef idx="2">
-            <a:schemeClr val="accent1"/>
-          </a:effectRef>
-          <a:fontRef idx="minor">
-            <a:schemeClr val="lt1"/>
-          </a:fontRef>
-        </p:style>
-        <p:txBody>
-          <a:bodyPr rtlCol="0" anchor="ctr"/>
-          <a:lstStyle/>
-          <a:p>
-            <a:pPr algn="ctr"/>
-          </a:p>
-        </p:txBody>
-      </p:sp>
-      <p:sp>
-        <p:nvSpPr>
-          <p:cNvPr id="16" name="TextBox 15"/>
-          <p:cNvSpPr txBox="1"/>
-          <p:nvPr/>
-        </p:nvSpPr>
-        <p:spPr>
-          <a:xfrm>
-            <a:off x="822960" y="3273551"/>
-            <a:ext cx="10515600" cy="365760"/>
-          </a:xfrm>
-          <a:prstGeom prst="rect">
-            <a:avLst/>
-          </a:prstGeom>
-          <a:noFill/>
-        </p:spPr>
-        <p:txBody>
-          <a:bodyPr wrap="square">
-            <a:spAutoFit/>
-          </a:bodyPr>
-          <a:lstStyle/>
-          <a:p>
-            <a:pPr algn="l">
-              <a:defRPr sz="1500" b="0">
-                <a:solidFill>
-                  <a:srgbClr val="2C3E50"/>
-                </a:solidFill>
-                <a:latin typeface="Calibri"/>
-              </a:defRPr>
-            </a:pPr>
-            <a:r>
-              <a:t>4. Experimental Setup - 4 skenario, parameter table</a:t>
-            </a:r>
-          </a:p>
-        </p:txBody>
-      </p:sp>
-      <p:sp>
-        <p:nvSpPr>
-          <p:cNvPr id="17" name="Rectangle 16"/>
-          <p:cNvSpPr/>
-          <p:nvPr/>
-        </p:nvSpPr>
-        <p:spPr>
-          <a:xfrm>
-            <a:off x="548640" y="3840480"/>
-            <a:ext cx="10972800" cy="502920"/>
-          </a:xfrm>
-          <a:prstGeom prst="rect">
-            <a:avLst/>
-          </a:prstGeom>
-          <a:solidFill>
-            <a:srgbClr val="F8F9FA"/>
-          </a:solidFill>
-          <a:ln>
-            <a:noFill/>
-          </a:ln>
-        </p:spPr>
-        <p:style>
-          <a:lnRef idx="1">
-            <a:schemeClr val="accent1"/>
-          </a:lnRef>
-          <a:fillRef idx="3">
-            <a:schemeClr val="accent1"/>
-          </a:fillRef>
-          <a:effectRef idx="2">
-            <a:schemeClr val="accent1"/>
-          </a:effectRef>
-          <a:fontRef idx="minor">
-            <a:schemeClr val="lt1"/>
-          </a:fontRef>
-        </p:style>
-        <p:txBody>
-          <a:bodyPr rtlCol="0" anchor="ctr"/>
-          <a:lstStyle/>
-          <a:p>
-            <a:pPr algn="ctr"/>
-          </a:p>
-        </p:txBody>
-      </p:sp>
-      <p:sp>
-        <p:nvSpPr>
-          <p:cNvPr id="18" name="Rectangle 17"/>
-          <p:cNvSpPr/>
-          <p:nvPr/>
-        </p:nvSpPr>
-        <p:spPr>
-          <a:xfrm>
-            <a:off x="548640" y="3840480"/>
-            <a:ext cx="54864" cy="502920"/>
-          </a:xfrm>
-          <a:prstGeom prst="rect">
-            <a:avLst/>
-          </a:prstGeom>
-          <a:solidFill>
-            <a:srgbClr val="3498DB"/>
-          </a:solidFill>
-          <a:ln>
-            <a:noFill/>
-          </a:ln>
-        </p:spPr>
-        <p:style>
-          <a:lnRef idx="1">
-            <a:schemeClr val="accent1"/>
-          </a:lnRef>
-          <a:fillRef idx="3">
-            <a:schemeClr val="accent1"/>
-          </a:fillRef>
-          <a:effectRef idx="2">
-            <a:schemeClr val="accent1"/>
-          </a:effectRef>
-          <a:fontRef idx="minor">
-            <a:schemeClr val="lt1"/>
-          </a:fontRef>
-        </p:style>
-        <p:txBody>
-          <a:bodyPr rtlCol="0" anchor="ctr"/>
-          <a:lstStyle/>
-          <a:p>
-            <a:pPr algn="ctr"/>
-          </a:p>
-        </p:txBody>
-      </p:sp>
-      <p:sp>
-        <p:nvSpPr>
-          <p:cNvPr id="19" name="TextBox 18"/>
-          <p:cNvSpPr txBox="1"/>
-          <p:nvPr/>
-        </p:nvSpPr>
-        <p:spPr>
-          <a:xfrm>
-            <a:off x="822960" y="3913632"/>
-            <a:ext cx="10515600" cy="365760"/>
-          </a:xfrm>
-          <a:prstGeom prst="rect">
-            <a:avLst/>
-          </a:prstGeom>
-          <a:noFill/>
-        </p:spPr>
-        <p:txBody>
-          <a:bodyPr wrap="square">
-            <a:spAutoFit/>
-          </a:bodyPr>
-          <a:lstStyle/>
-          <a:p>
-            <a:pPr algn="l">
-              <a:defRPr sz="1500" b="0">
-                <a:solidFill>
-                  <a:srgbClr val="2C3E50"/>
-                </a:solidFill>
-                <a:latin typeface="Calibri"/>
-              </a:defRPr>
-            </a:pPr>
-            <a:r>
-              <a:t>5. Results and Analysis - 5 figures + 3 tables + Mann-Whitney</a:t>
-            </a:r>
-          </a:p>
-        </p:txBody>
-      </p:sp>
-      <p:sp>
-        <p:nvSpPr>
-          <p:cNvPr id="20" name="Rectangle 19"/>
-          <p:cNvSpPr/>
-          <p:nvPr/>
-        </p:nvSpPr>
-        <p:spPr>
-          <a:xfrm>
-            <a:off x="548640" y="4480560"/>
-            <a:ext cx="10972800" cy="502920"/>
-          </a:xfrm>
-          <a:prstGeom prst="rect">
-            <a:avLst/>
-          </a:prstGeom>
-          <a:solidFill>
-            <a:srgbClr val="F8F9FA"/>
-          </a:solidFill>
-          <a:ln>
-            <a:noFill/>
-          </a:ln>
-        </p:spPr>
-        <p:style>
-          <a:lnRef idx="1">
-            <a:schemeClr val="accent1"/>
-          </a:lnRef>
-          <a:fillRef idx="3">
-            <a:schemeClr val="accent1"/>
-          </a:fillRef>
-          <a:effectRef idx="2">
-            <a:schemeClr val="accent1"/>
-          </a:effectRef>
-          <a:fontRef idx="minor">
-            <a:schemeClr val="lt1"/>
-          </a:fontRef>
-        </p:style>
-        <p:txBody>
-          <a:bodyPr rtlCol="0" anchor="ctr"/>
-          <a:lstStyle/>
-          <a:p>
-            <a:pPr algn="ctr"/>
-          </a:p>
-        </p:txBody>
-      </p:sp>
-      <p:sp>
-        <p:nvSpPr>
-          <p:cNvPr id="21" name="Rectangle 20"/>
-          <p:cNvSpPr/>
-          <p:nvPr/>
-        </p:nvSpPr>
-        <p:spPr>
-          <a:xfrm>
-            <a:off x="548640" y="4480560"/>
-            <a:ext cx="54864" cy="502920"/>
-          </a:xfrm>
-          <a:prstGeom prst="rect">
-            <a:avLst/>
-          </a:prstGeom>
-          <a:solidFill>
-            <a:srgbClr val="3498DB"/>
-          </a:solidFill>
-          <a:ln>
-            <a:noFill/>
-          </a:ln>
-        </p:spPr>
-        <p:style>
-          <a:lnRef idx="1">
-            <a:schemeClr val="accent1"/>
-          </a:lnRef>
-          <a:fillRef idx="3">
-            <a:schemeClr val="accent1"/>
-          </a:fillRef>
-          <a:effectRef idx="2">
-            <a:schemeClr val="accent1"/>
-          </a:effectRef>
-          <a:fontRef idx="minor">
-            <a:schemeClr val="lt1"/>
-          </a:fontRef>
-        </p:style>
-        <p:txBody>
-          <a:bodyPr rtlCol="0" anchor="ctr"/>
-          <a:lstStyle/>
-          <a:p>
-            <a:pPr algn="ctr"/>
-          </a:p>
-        </p:txBody>
-      </p:sp>
-      <p:sp>
-        <p:nvSpPr>
-          <p:cNvPr id="22" name="TextBox 21"/>
-          <p:cNvSpPr txBox="1"/>
-          <p:nvPr/>
-        </p:nvSpPr>
-        <p:spPr>
-          <a:xfrm>
-            <a:off x="822960" y="4553712"/>
-            <a:ext cx="10515600" cy="365760"/>
-          </a:xfrm>
-          <a:prstGeom prst="rect">
-            <a:avLst/>
-          </a:prstGeom>
-          <a:noFill/>
-        </p:spPr>
-        <p:txBody>
-          <a:bodyPr wrap="square">
-            <a:spAutoFit/>
-          </a:bodyPr>
-          <a:lstStyle/>
-          <a:p>
-            <a:pPr algn="l">
-              <a:defRPr sz="1500" b="0">
-                <a:solidFill>
-                  <a:srgbClr val="2C3E50"/>
-                </a:solidFill>
-                <a:latin typeface="Calibri"/>
-              </a:defRPr>
-            </a:pPr>
-            <a:r>
-              <a:t>6. Discussion - Implikasi, limitasi, future work</a:t>
-            </a:r>
-          </a:p>
-        </p:txBody>
-      </p:sp>
-      <p:sp>
-        <p:nvSpPr>
-          <p:cNvPr id="23" name="Rectangle 22"/>
-          <p:cNvSpPr/>
-          <p:nvPr/>
-        </p:nvSpPr>
-        <p:spPr>
-          <a:xfrm>
-            <a:off x="548640" y="5120639"/>
-            <a:ext cx="10972800" cy="502920"/>
-          </a:xfrm>
-          <a:prstGeom prst="rect">
-            <a:avLst/>
-          </a:prstGeom>
-          <a:solidFill>
-            <a:srgbClr val="F8F9FA"/>
-          </a:solidFill>
-          <a:ln>
-            <a:noFill/>
-          </a:ln>
-        </p:spPr>
-        <p:style>
-          <a:lnRef idx="1">
-            <a:schemeClr val="accent1"/>
-          </a:lnRef>
-          <a:fillRef idx="3">
-            <a:schemeClr val="accent1"/>
-          </a:fillRef>
-          <a:effectRef idx="2">
-            <a:schemeClr val="accent1"/>
-          </a:effectRef>
-          <a:fontRef idx="minor">
-            <a:schemeClr val="lt1"/>
-          </a:fontRef>
-        </p:style>
-        <p:txBody>
-          <a:bodyPr rtlCol="0" anchor="ctr"/>
-          <a:lstStyle/>
-          <a:p>
-            <a:pPr algn="ctr"/>
-          </a:p>
-        </p:txBody>
-      </p:sp>
-      <p:sp>
-        <p:nvSpPr>
-          <p:cNvPr id="24" name="Rectangle 23"/>
-          <p:cNvSpPr/>
-          <p:nvPr/>
-        </p:nvSpPr>
-        <p:spPr>
-          <a:xfrm>
-            <a:off x="548640" y="5120639"/>
-            <a:ext cx="54864" cy="502920"/>
-          </a:xfrm>
-          <a:prstGeom prst="rect">
-            <a:avLst/>
-          </a:prstGeom>
-          <a:solidFill>
-            <a:srgbClr val="3498DB"/>
-          </a:solidFill>
-          <a:ln>
-            <a:noFill/>
-          </a:ln>
-        </p:spPr>
-        <p:style>
-          <a:lnRef idx="1">
-            <a:schemeClr val="accent1"/>
-          </a:lnRef>
-          <a:fillRef idx="3">
-            <a:schemeClr val="accent1"/>
-          </a:fillRef>
-          <a:effectRef idx="2">
-            <a:schemeClr val="accent1"/>
-          </a:effectRef>
-          <a:fontRef idx="minor">
-            <a:schemeClr val="lt1"/>
-          </a:fontRef>
-        </p:style>
-        <p:txBody>
-          <a:bodyPr rtlCol="0" anchor="ctr"/>
-          <a:lstStyle/>
-          <a:p>
-            <a:pPr algn="ctr"/>
-          </a:p>
-        </p:txBody>
-      </p:sp>
-      <p:sp>
-        <p:nvSpPr>
-          <p:cNvPr id="25" name="TextBox 24"/>
-          <p:cNvSpPr txBox="1"/>
-          <p:nvPr/>
-        </p:nvSpPr>
-        <p:spPr>
-          <a:xfrm>
-            <a:off x="822960" y="5193791"/>
-            <a:ext cx="10515600" cy="365760"/>
-          </a:xfrm>
-          <a:prstGeom prst="rect">
-            <a:avLst/>
-          </a:prstGeom>
-          <a:noFill/>
-        </p:spPr>
-        <p:txBody>
-          <a:bodyPr wrap="square">
-            <a:spAutoFit/>
-          </a:bodyPr>
-          <a:lstStyle/>
-          <a:p>
-            <a:pPr algn="l">
-              <a:defRPr sz="1500" b="0">
-                <a:solidFill>
-                  <a:srgbClr val="2C3E50"/>
-                </a:solidFill>
-                <a:latin typeface="Calibri"/>
-              </a:defRPr>
-            </a:pPr>
-            <a:r>
-              <a:t>7. Conclusion - 4 temuan utama</a:t>
-            </a:r>
-          </a:p>
-        </p:txBody>
-      </p:sp>
-    </p:spTree>
-  </p:cSld>
-  <p:clrMapOvr>
-    <a:masterClrMapping/>
-  </p:clrMapOvr>
-</p:sld>
-</file>
-
-<file path=ppt/slides/slide33.xml><?xml version="1.0" encoding="utf-8"?>
-<p:sld xmlns:a="http://schemas.openxmlformats.org/drawingml/2006/main" xmlns:p="http://schemas.openxmlformats.org/presentationml/2006/main" xmlns:r="http://schemas.openxmlformats.org/officeDocument/2006/relationships">
-  <p:cSld>
-    <p:bg>
-      <p:bgPr>
-        <a:solidFill>
-          <a:srgbClr val="FFFFFF"/>
-        </a:solidFill>
-        <a:effectLst/>
-      </p:bgPr>
-    </p:bg>
-    <p:spTree>
-      <p:nvGrpSpPr>
-        <p:cNvPr id="1" name=""/>
-        <p:cNvGrpSpPr/>
-        <p:nvPr/>
-      </p:nvGrpSpPr>
-      <p:grpSpPr/>
-      <p:sp>
-        <p:nvSpPr>
-          <p:cNvPr id="2" name="Rectangle 1"/>
-          <p:cNvSpPr/>
-          <p:nvPr/>
-        </p:nvSpPr>
-        <p:spPr>
-          <a:xfrm>
-            <a:off x="0" y="0"/>
-            <a:ext cx="12191695" cy="822960"/>
-          </a:xfrm>
-          <a:prstGeom prst="rect">
-            <a:avLst/>
-          </a:prstGeom>
-          <a:solidFill>
-            <a:srgbClr val="1A233B"/>
-          </a:solidFill>
-          <a:ln>
-            <a:noFill/>
-          </a:ln>
-        </p:spPr>
-        <p:style>
-          <a:lnRef idx="1">
-            <a:schemeClr val="accent1"/>
-          </a:lnRef>
-          <a:fillRef idx="3">
-            <a:schemeClr val="accent1"/>
-          </a:fillRef>
-          <a:effectRef idx="2">
-            <a:schemeClr val="accent1"/>
-          </a:effectRef>
-          <a:fontRef idx="minor">
-            <a:schemeClr val="lt1"/>
-          </a:fontRef>
-        </p:style>
-        <p:txBody>
-          <a:bodyPr rtlCol="0" anchor="ctr"/>
-          <a:lstStyle/>
-          <a:p>
-            <a:pPr algn="ctr"/>
-          </a:p>
-        </p:txBody>
-      </p:sp>
-      <p:sp>
-        <p:nvSpPr>
-          <p:cNvPr id="3" name="TextBox 2"/>
-          <p:cNvSpPr txBox="1"/>
-          <p:nvPr/>
-        </p:nvSpPr>
-        <p:spPr>
-          <a:xfrm>
-            <a:off x="548640" y="137160"/>
-            <a:ext cx="10972800" cy="548640"/>
-          </a:xfrm>
-          <a:prstGeom prst="rect">
-            <a:avLst/>
-          </a:prstGeom>
-          <a:noFill/>
-        </p:spPr>
-        <p:txBody>
-          <a:bodyPr wrap="square">
-            <a:spAutoFit/>
-          </a:bodyPr>
-          <a:lstStyle/>
-          <a:p>
-            <a:pPr algn="l">
-              <a:defRPr sz="2400" b="1">
-                <a:solidFill>
-                  <a:srgbClr val="FFFFFF"/>
-                </a:solidFill>
-                <a:latin typeface="Calibri"/>
-              </a:defRPr>
-            </a:pPr>
-            <a:r>
-              <a:t>Referensi Kunci (2022-2025)</a:t>
-            </a:r>
-          </a:p>
-        </p:txBody>
-      </p:sp>
-      <p:sp>
-        <p:nvSpPr>
-          <p:cNvPr id="4" name="Rectangle 3"/>
-          <p:cNvSpPr/>
-          <p:nvPr/>
-        </p:nvSpPr>
-        <p:spPr>
-          <a:xfrm>
-            <a:off x="0" y="822960"/>
-            <a:ext cx="12191695" cy="36576"/>
-          </a:xfrm>
-          <a:prstGeom prst="rect">
-            <a:avLst/>
-          </a:prstGeom>
-          <a:solidFill>
-            <a:srgbClr val="3498DB"/>
-          </a:solidFill>
-          <a:ln>
-            <a:noFill/>
-          </a:ln>
-        </p:spPr>
-        <p:style>
-          <a:lnRef idx="1">
-            <a:schemeClr val="accent1"/>
-          </a:lnRef>
-          <a:fillRef idx="3">
-            <a:schemeClr val="accent1"/>
-          </a:fillRef>
-          <a:effectRef idx="2">
-            <a:schemeClr val="accent1"/>
-          </a:effectRef>
-          <a:fontRef idx="minor">
-            <a:schemeClr val="lt1"/>
-          </a:fontRef>
-        </p:style>
-        <p:txBody>
-          <a:bodyPr rtlCol="0" anchor="ctr"/>
-          <a:lstStyle/>
-          <a:p>
-            <a:pPr algn="ctr"/>
-          </a:p>
-        </p:txBody>
-      </p:sp>
-      <p:sp>
-        <p:nvSpPr>
-          <p:cNvPr id="5" name="Rectangle 4"/>
-          <p:cNvSpPr/>
-          <p:nvPr/>
-        </p:nvSpPr>
-        <p:spPr>
-          <a:xfrm>
-            <a:off x="548640" y="1280160"/>
-            <a:ext cx="10972800" cy="548640"/>
-          </a:xfrm>
-          <a:prstGeom prst="rect">
-            <a:avLst/>
-          </a:prstGeom>
-          <a:solidFill>
-            <a:srgbClr val="F8F9FA"/>
-          </a:solidFill>
-          <a:ln>
-            <a:noFill/>
-          </a:ln>
-        </p:spPr>
-        <p:style>
-          <a:lnRef idx="1">
-            <a:schemeClr val="accent1"/>
-          </a:lnRef>
-          <a:fillRef idx="3">
-            <a:schemeClr val="accent1"/>
-          </a:fillRef>
-          <a:effectRef idx="2">
-            <a:schemeClr val="accent1"/>
-          </a:effectRef>
-          <a:fontRef idx="minor">
-            <a:schemeClr val="lt1"/>
-          </a:fontRef>
-        </p:style>
-        <p:txBody>
-          <a:bodyPr rtlCol="0" anchor="ctr"/>
-          <a:lstStyle/>
-          <a:p>
-            <a:pPr algn="ctr"/>
-          </a:p>
-        </p:txBody>
-      </p:sp>
-      <p:sp>
-        <p:nvSpPr>
-          <p:cNvPr id="6" name="TextBox 5"/>
-          <p:cNvSpPr txBox="1"/>
-          <p:nvPr/>
-        </p:nvSpPr>
-        <p:spPr>
-          <a:xfrm>
-            <a:off x="731520" y="1353312"/>
-            <a:ext cx="10515600" cy="457200"/>
-          </a:xfrm>
-          <a:prstGeom prst="rect">
-            <a:avLst/>
-          </a:prstGeom>
-          <a:noFill/>
-        </p:spPr>
-        <p:txBody>
-          <a:bodyPr wrap="square">
-            <a:spAutoFit/>
-          </a:bodyPr>
-          <a:lstStyle/>
-          <a:p>
-            <a:pPr algn="l">
-              <a:defRPr sz="1300" b="0">
-                <a:solidFill>
-                  <a:srgbClr val="2C3E50"/>
-                </a:solidFill>
-                <a:latin typeface="Calibri"/>
-              </a:defRPr>
-            </a:pPr>
-            <a:r>
-              <a:t>[1] Chernikova et al. (2023) - Epidemiological malware models. Applied Network Science.</a:t>
-            </a:r>
-          </a:p>
-        </p:txBody>
-      </p:sp>
-      <p:sp>
-        <p:nvSpPr>
-          <p:cNvPr id="7" name="Rectangle 6"/>
-          <p:cNvSpPr/>
-          <p:nvPr/>
-        </p:nvSpPr>
-        <p:spPr>
-          <a:xfrm>
-            <a:off x="548640" y="1965960"/>
-            <a:ext cx="10972800" cy="548640"/>
-          </a:xfrm>
-          <a:prstGeom prst="rect">
-            <a:avLst/>
-          </a:prstGeom>
-          <a:solidFill>
-            <a:srgbClr val="F8F9FA"/>
-          </a:solidFill>
-          <a:ln>
-            <a:noFill/>
-          </a:ln>
-        </p:spPr>
-        <p:style>
-          <a:lnRef idx="1">
-            <a:schemeClr val="accent1"/>
-          </a:lnRef>
-          <a:fillRef idx="3">
-            <a:schemeClr val="accent1"/>
-          </a:fillRef>
-          <a:effectRef idx="2">
-            <a:schemeClr val="accent1"/>
-          </a:effectRef>
-          <a:fontRef idx="minor">
-            <a:schemeClr val="lt1"/>
-          </a:fontRef>
-        </p:style>
-        <p:txBody>
-          <a:bodyPr rtlCol="0" anchor="ctr"/>
-          <a:lstStyle/>
-          <a:p>
-            <a:pPr algn="ctr"/>
-          </a:p>
-        </p:txBody>
-      </p:sp>
-      <p:sp>
-        <p:nvSpPr>
-          <p:cNvPr id="8" name="TextBox 7"/>
-          <p:cNvSpPr txBox="1"/>
-          <p:nvPr/>
-        </p:nvSpPr>
-        <p:spPr>
-          <a:xfrm>
-            <a:off x="731520" y="2039112"/>
-            <a:ext cx="10515600" cy="457200"/>
-          </a:xfrm>
-          <a:prstGeom prst="rect">
-            <a:avLst/>
-          </a:prstGeom>
-          <a:noFill/>
-        </p:spPr>
-        <p:txBody>
-          <a:bodyPr wrap="square">
-            <a:spAutoFit/>
-          </a:bodyPr>
-          <a:lstStyle/>
-          <a:p>
-            <a:pPr algn="l">
-              <a:defRPr sz="1300" b="0">
-                <a:solidFill>
-                  <a:srgbClr val="2C3E50"/>
-                </a:solidFill>
-                <a:latin typeface="Calibri"/>
-              </a:defRPr>
-            </a:pPr>
-            <a:r>
-              <a:t>[3] Aftabi et al. (2025) - ABM framework for security management. Expert Systems with Applications.</a:t>
-            </a:r>
-          </a:p>
-        </p:txBody>
-      </p:sp>
-      <p:sp>
-        <p:nvSpPr>
-          <p:cNvPr id="9" name="Rectangle 8"/>
-          <p:cNvSpPr/>
-          <p:nvPr/>
-        </p:nvSpPr>
-        <p:spPr>
-          <a:xfrm>
-            <a:off x="548640" y="2651760"/>
-            <a:ext cx="10972800" cy="548640"/>
-          </a:xfrm>
-          <a:prstGeom prst="rect">
-            <a:avLst/>
-          </a:prstGeom>
-          <a:solidFill>
-            <a:srgbClr val="F8F9FA"/>
-          </a:solidFill>
-          <a:ln>
-            <a:noFill/>
-          </a:ln>
-        </p:spPr>
-        <p:style>
-          <a:lnRef idx="1">
-            <a:schemeClr val="accent1"/>
-          </a:lnRef>
-          <a:fillRef idx="3">
-            <a:schemeClr val="accent1"/>
-          </a:fillRef>
-          <a:effectRef idx="2">
-            <a:schemeClr val="accent1"/>
-          </a:effectRef>
-          <a:fontRef idx="minor">
-            <a:schemeClr val="lt1"/>
-          </a:fontRef>
-        </p:style>
-        <p:txBody>
-          <a:bodyPr rtlCol="0" anchor="ctr"/>
-          <a:lstStyle/>
-          <a:p>
-            <a:pPr algn="ctr"/>
-          </a:p>
-        </p:txBody>
-      </p:sp>
-      <p:sp>
-        <p:nvSpPr>
-          <p:cNvPr id="10" name="TextBox 9"/>
-          <p:cNvSpPr txBox="1"/>
-          <p:nvPr/>
-        </p:nvSpPr>
-        <p:spPr>
-          <a:xfrm>
-            <a:off x="731520" y="2724912"/>
-            <a:ext cx="10515600" cy="457200"/>
-          </a:xfrm>
-          <a:prstGeom prst="rect">
-            <a:avLst/>
-          </a:prstGeom>
-          <a:noFill/>
-        </p:spPr>
-        <p:txBody>
-          <a:bodyPr wrap="square">
-            <a:spAutoFit/>
-          </a:bodyPr>
-          <a:lstStyle/>
-          <a:p>
-            <a:pPr algn="l">
-              <a:defRPr sz="1300" b="0">
-                <a:solidFill>
-                  <a:srgbClr val="2C3E50"/>
-                </a:solidFill>
-                <a:latin typeface="Calibri"/>
-              </a:defRPr>
-            </a:pPr>
-            <a:r>
-              <a:t>[5] Do Xuan et al. (2025) - Two-stage APT malware propagation. Neural Computing &amp; Applications.</a:t>
-            </a:r>
-          </a:p>
-        </p:txBody>
-      </p:sp>
-      <p:sp>
-        <p:nvSpPr>
-          <p:cNvPr id="11" name="Rectangle 10"/>
-          <p:cNvSpPr/>
-          <p:nvPr/>
-        </p:nvSpPr>
-        <p:spPr>
-          <a:xfrm>
-            <a:off x="548640" y="3337560"/>
-            <a:ext cx="10972800" cy="548640"/>
-          </a:xfrm>
-          <a:prstGeom prst="rect">
-            <a:avLst/>
-          </a:prstGeom>
-          <a:solidFill>
-            <a:srgbClr val="F8F9FA"/>
-          </a:solidFill>
-          <a:ln>
-            <a:noFill/>
-          </a:ln>
-        </p:spPr>
-        <p:style>
-          <a:lnRef idx="1">
-            <a:schemeClr val="accent1"/>
-          </a:lnRef>
-          <a:fillRef idx="3">
-            <a:schemeClr val="accent1"/>
-          </a:fillRef>
-          <a:effectRef idx="2">
-            <a:schemeClr val="accent1"/>
-          </a:effectRef>
-          <a:fontRef idx="minor">
-            <a:schemeClr val="lt1"/>
-          </a:fontRef>
-        </p:style>
-        <p:txBody>
-          <a:bodyPr rtlCol="0" anchor="ctr"/>
-          <a:lstStyle/>
-          <a:p>
-            <a:pPr algn="ctr"/>
-          </a:p>
-        </p:txBody>
-      </p:sp>
-      <p:sp>
-        <p:nvSpPr>
-          <p:cNvPr id="12" name="TextBox 11"/>
-          <p:cNvSpPr txBox="1"/>
-          <p:nvPr/>
-        </p:nvSpPr>
-        <p:spPr>
-          <a:xfrm>
-            <a:off x="731520" y="3410712"/>
-            <a:ext cx="10515600" cy="457200"/>
-          </a:xfrm>
-          <a:prstGeom prst="rect">
-            <a:avLst/>
-          </a:prstGeom>
-          <a:noFill/>
-        </p:spPr>
-        <p:txBody>
-          <a:bodyPr wrap="square">
-            <a:spAutoFit/>
-          </a:bodyPr>
-          <a:lstStyle/>
-          <a:p>
-            <a:pPr algn="l">
-              <a:defRPr sz="1300" b="0">
-                <a:solidFill>
-                  <a:srgbClr val="2C3E50"/>
-                </a:solidFill>
-                <a:latin typeface="Calibri"/>
-              </a:defRPr>
-            </a:pPr>
-            <a:r>
-              <a:t>[12] Woods &amp; Seymour (2024) - Meta-review of security control effectiveness. J. Cyber Policy.</a:t>
-            </a:r>
-          </a:p>
-        </p:txBody>
-      </p:sp>
-      <p:sp>
-        <p:nvSpPr>
-          <p:cNvPr id="13" name="Rectangle 12"/>
-          <p:cNvSpPr/>
-          <p:nvPr/>
-        </p:nvSpPr>
-        <p:spPr>
-          <a:xfrm>
-            <a:off x="548640" y="4023360"/>
-            <a:ext cx="10972800" cy="548640"/>
-          </a:xfrm>
-          <a:prstGeom prst="rect">
-            <a:avLst/>
-          </a:prstGeom>
-          <a:solidFill>
-            <a:srgbClr val="F8F9FA"/>
-          </a:solidFill>
-          <a:ln>
-            <a:noFill/>
-          </a:ln>
-        </p:spPr>
-        <p:style>
-          <a:lnRef idx="1">
-            <a:schemeClr val="accent1"/>
-          </a:lnRef>
-          <a:fillRef idx="3">
-            <a:schemeClr val="accent1"/>
-          </a:fillRef>
-          <a:effectRef idx="2">
-            <a:schemeClr val="accent1"/>
-          </a:effectRef>
-          <a:fontRef idx="minor">
-            <a:schemeClr val="lt1"/>
-          </a:fontRef>
-        </p:style>
-        <p:txBody>
-          <a:bodyPr rtlCol="0" anchor="ctr"/>
-          <a:lstStyle/>
-          <a:p>
-            <a:pPr algn="ctr"/>
-          </a:p>
-        </p:txBody>
-      </p:sp>
-      <p:sp>
-        <p:nvSpPr>
-          <p:cNvPr id="14" name="TextBox 13"/>
-          <p:cNvSpPr txBox="1"/>
-          <p:nvPr/>
-        </p:nvSpPr>
-        <p:spPr>
-          <a:xfrm>
-            <a:off x="731520" y="4096512"/>
-            <a:ext cx="10515600" cy="457200"/>
-          </a:xfrm>
-          <a:prstGeom prst="rect">
-            <a:avLst/>
-          </a:prstGeom>
-          <a:noFill/>
-        </p:spPr>
-        <p:txBody>
-          <a:bodyPr wrap="square">
-            <a:spAutoFit/>
-          </a:bodyPr>
-          <a:lstStyle/>
-          <a:p>
-            <a:pPr algn="l">
-              <a:defRPr sz="1300" b="0">
-                <a:solidFill>
-                  <a:srgbClr val="2C3E50"/>
-                </a:solidFill>
-                <a:latin typeface="Calibri"/>
-              </a:defRPr>
-            </a:pPr>
-            <a:r>
-              <a:t>[15] Prummer et al. (2024) - Systematic review of cybersecurity training. Computers &amp; Security.</a:t>
-            </a:r>
-          </a:p>
-        </p:txBody>
-      </p:sp>
-      <p:sp>
-        <p:nvSpPr>
-          <p:cNvPr id="15" name="Rectangle 14"/>
-          <p:cNvSpPr/>
-          <p:nvPr/>
-        </p:nvSpPr>
-        <p:spPr>
-          <a:xfrm>
-            <a:off x="548640" y="4709160"/>
-            <a:ext cx="10972800" cy="548640"/>
-          </a:xfrm>
-          <a:prstGeom prst="rect">
-            <a:avLst/>
-          </a:prstGeom>
-          <a:solidFill>
-            <a:srgbClr val="F8F9FA"/>
-          </a:solidFill>
-          <a:ln>
-            <a:noFill/>
-          </a:ln>
-        </p:spPr>
-        <p:style>
-          <a:lnRef idx="1">
-            <a:schemeClr val="accent1"/>
-          </a:lnRef>
-          <a:fillRef idx="3">
-            <a:schemeClr val="accent1"/>
-          </a:fillRef>
-          <a:effectRef idx="2">
-            <a:schemeClr val="accent1"/>
-          </a:effectRef>
-          <a:fontRef idx="minor">
-            <a:schemeClr val="lt1"/>
-          </a:fontRef>
-        </p:style>
-        <p:txBody>
-          <a:bodyPr rtlCol="0" anchor="ctr"/>
-          <a:lstStyle/>
-          <a:p>
-            <a:pPr algn="ctr"/>
-          </a:p>
-        </p:txBody>
-      </p:sp>
-      <p:sp>
-        <p:nvSpPr>
-          <p:cNvPr id="16" name="TextBox 15"/>
-          <p:cNvSpPr txBox="1"/>
-          <p:nvPr/>
-        </p:nvSpPr>
-        <p:spPr>
-          <a:xfrm>
-            <a:off x="731520" y="4782312"/>
-            <a:ext cx="10515600" cy="457200"/>
-          </a:xfrm>
-          <a:prstGeom prst="rect">
-            <a:avLst/>
-          </a:prstGeom>
-          <a:noFill/>
-        </p:spPr>
-        <p:txBody>
-          <a:bodyPr wrap="square">
-            <a:spAutoFit/>
-          </a:bodyPr>
-          <a:lstStyle/>
-          <a:p>
-            <a:pPr algn="l">
-              <a:defRPr sz="1300" b="0">
-                <a:solidFill>
-                  <a:srgbClr val="2C3E50"/>
-                </a:solidFill>
-                <a:latin typeface="Calibri"/>
-              </a:defRPr>
-            </a:pPr>
-            <a:r>
-              <a:t>[18] ter Hoeven et al. (2025) - Mesa 3: ABM with Python. JOSS.</a:t>
-            </a:r>
-          </a:p>
-        </p:txBody>
-      </p:sp>
-      <p:sp>
-        <p:nvSpPr>
-          <p:cNvPr id="17" name="TextBox 16"/>
-          <p:cNvSpPr txBox="1"/>
-          <p:nvPr/>
-        </p:nvSpPr>
-        <p:spPr>
-          <a:xfrm>
-            <a:off x="548640" y="5669280"/>
-            <a:ext cx="10972800" cy="914400"/>
-          </a:xfrm>
-          <a:prstGeom prst="rect">
-            <a:avLst/>
-          </a:prstGeom>
-          <a:noFill/>
-        </p:spPr>
-        <p:txBody>
-          <a:bodyPr wrap="square">
-            <a:spAutoFit/>
-          </a:bodyPr>
-          <a:lstStyle/>
-          <a:p>
-            <a:pPr algn="l">
-              <a:defRPr sz="1400" b="1">
-                <a:solidFill>
-                  <a:srgbClr val="2C3E6B"/>
-                </a:solidFill>
-                <a:latin typeface="Calibri"/>
-              </a:defRPr>
-            </a:pPr>
-            <a:r>
-              <a:t>Total: 18 referensi dari 2022-2025 | Semua real dengan DOI terverifikasi</a:t>
-            </a:r>
-          </a:p>
-        </p:txBody>
-      </p:sp>
-    </p:spTree>
-  </p:cSld>
-  <p:clrMapOvr>
-    <a:masterClrMapping/>
-  </p:clrMapOvr>
-</p:sld>
-</file>
-
-<file path=ppt/slides/slide34.xml><?xml version="1.0" encoding="utf-8"?>
-<p:sld xmlns:a="http://schemas.openxmlformats.org/drawingml/2006/main" xmlns:p="http://schemas.openxmlformats.org/presentationml/2006/main" xmlns:r="http://schemas.openxmlformats.org/officeDocument/2006/relationships">
-  <p:cSld>
-    <p:bg>
-      <p:bgPr>
-        <a:solidFill>
-          <a:srgbClr val="1A233B"/>
-        </a:solidFill>
-        <a:effectLst/>
-      </p:bgPr>
-    </p:bg>
-    <p:spTree>
-      <p:nvGrpSpPr>
-        <p:cNvPr id="1" name=""/>
-        <p:cNvGrpSpPr/>
-        <p:nvPr/>
-      </p:nvGrpSpPr>
-      <p:grpSpPr/>
-      <p:sp>
-        <p:nvSpPr>
-          <p:cNvPr id="2" name="Rectangle 1"/>
-          <p:cNvSpPr/>
-          <p:nvPr/>
-        </p:nvSpPr>
-        <p:spPr>
-          <a:xfrm>
-            <a:off x="0" y="3200400"/>
-            <a:ext cx="12191695" cy="54864"/>
-          </a:xfrm>
-          <a:prstGeom prst="rect">
-            <a:avLst/>
-          </a:prstGeom>
-          <a:solidFill>
-            <a:srgbClr val="3498DB"/>
-          </a:solidFill>
-          <a:ln>
-            <a:noFill/>
-          </a:ln>
-        </p:spPr>
-        <p:style>
-          <a:lnRef idx="1">
-            <a:schemeClr val="accent1"/>
-          </a:lnRef>
-          <a:fillRef idx="3">
-            <a:schemeClr val="accent1"/>
-          </a:fillRef>
-          <a:effectRef idx="2">
-            <a:schemeClr val="accent1"/>
-          </a:effectRef>
-          <a:fontRef idx="minor">
-            <a:schemeClr val="lt1"/>
-          </a:fontRef>
-        </p:style>
-        <p:txBody>
-          <a:bodyPr rtlCol="0" anchor="ctr"/>
-          <a:lstStyle/>
-          <a:p>
-            <a:pPr algn="ctr"/>
-          </a:p>
-        </p:txBody>
-      </p:sp>
-      <p:sp>
-        <p:nvSpPr>
-          <p:cNvPr id="3" name="TextBox 2"/>
-          <p:cNvSpPr txBox="1"/>
-          <p:nvPr/>
-        </p:nvSpPr>
-        <p:spPr>
-          <a:xfrm>
-            <a:off x="914400" y="2286000"/>
-            <a:ext cx="10058400" cy="914400"/>
-          </a:xfrm>
-          <a:prstGeom prst="rect">
-            <a:avLst/>
-          </a:prstGeom>
-          <a:noFill/>
-        </p:spPr>
-        <p:txBody>
-          <a:bodyPr wrap="square">
-            <a:spAutoFit/>
-          </a:bodyPr>
-          <a:lstStyle/>
-          <a:p>
-            <a:pPr algn="ctr">
-              <a:defRPr sz="3200" b="1">
-                <a:solidFill>
-                  <a:srgbClr val="FFFFFF"/>
-                </a:solidFill>
-                <a:latin typeface="Calibri"/>
-              </a:defRPr>
-            </a:pPr>
-            <a:r>
-              <a:t>Kesimpulan</a:t>
-            </a:r>
-          </a:p>
-        </p:txBody>
-      </p:sp>
-    </p:spTree>
-  </p:cSld>
-  <p:clrMapOvr>
-    <a:masterClrMapping/>
-  </p:clrMapOvr>
-</p:sld>
-</file>
-
-<file path=ppt/slides/slide35.xml><?xml version="1.0" encoding="utf-8"?>
-<p:sld xmlns:a="http://schemas.openxmlformats.org/drawingml/2006/main" xmlns:p="http://schemas.openxmlformats.org/presentationml/2006/main" xmlns:r="http://schemas.openxmlformats.org/officeDocument/2006/relationships">
-  <p:cSld>
-    <p:bg>
-      <p:bgPr>
-        <a:solidFill>
-          <a:srgbClr val="FFFFFF"/>
-        </a:solidFill>
-        <a:effectLst/>
-      </p:bgPr>
-    </p:bg>
-    <p:spTree>
-      <p:nvGrpSpPr>
-        <p:cNvPr id="1" name=""/>
-        <p:cNvGrpSpPr/>
-        <p:nvPr/>
-      </p:nvGrpSpPr>
-      <p:grpSpPr/>
-      <p:sp>
-        <p:nvSpPr>
-          <p:cNvPr id="2" name="Rectangle 1"/>
-          <p:cNvSpPr/>
-          <p:nvPr/>
-        </p:nvSpPr>
-        <p:spPr>
-          <a:xfrm>
-            <a:off x="0" y="0"/>
-            <a:ext cx="12191695" cy="822960"/>
-          </a:xfrm>
-          <a:prstGeom prst="rect">
-            <a:avLst/>
-          </a:prstGeom>
-          <a:solidFill>
-            <a:srgbClr val="1A233B"/>
-          </a:solidFill>
-          <a:ln>
-            <a:noFill/>
-          </a:ln>
-        </p:spPr>
-        <p:style>
-          <a:lnRef idx="1">
-            <a:schemeClr val="accent1"/>
-          </a:lnRef>
-          <a:fillRef idx="3">
-            <a:schemeClr val="accent1"/>
-          </a:fillRef>
-          <a:effectRef idx="2">
-            <a:schemeClr val="accent1"/>
-          </a:effectRef>
-          <a:fontRef idx="minor">
-            <a:schemeClr val="lt1"/>
-          </a:fontRef>
-        </p:style>
-        <p:txBody>
-          <a:bodyPr rtlCol="0" anchor="ctr"/>
-          <a:lstStyle/>
-          <a:p>
-            <a:pPr algn="ctr"/>
-          </a:p>
-        </p:txBody>
-      </p:sp>
-      <p:sp>
-        <p:nvSpPr>
-          <p:cNvPr id="3" name="TextBox 2"/>
-          <p:cNvSpPr txBox="1"/>
-          <p:nvPr/>
-        </p:nvSpPr>
-        <p:spPr>
-          <a:xfrm>
-            <a:off x="548640" y="137160"/>
-            <a:ext cx="10972800" cy="548640"/>
-          </a:xfrm>
-          <a:prstGeom prst="rect">
-            <a:avLst/>
-          </a:prstGeom>
-          <a:noFill/>
-        </p:spPr>
-        <p:txBody>
-          <a:bodyPr wrap="square">
-            <a:spAutoFit/>
-          </a:bodyPr>
-          <a:lstStyle/>
-          <a:p>
-            <a:pPr algn="l">
-              <a:defRPr sz="2400" b="1">
-                <a:solidFill>
-                  <a:srgbClr val="FFFFFF"/>
-                </a:solidFill>
-                <a:latin typeface="Calibri"/>
-              </a:defRPr>
-            </a:pPr>
-            <a:r>
-              <a:t>Kesimpulan</a:t>
-            </a:r>
-          </a:p>
-        </p:txBody>
-      </p:sp>
-      <p:sp>
-        <p:nvSpPr>
-          <p:cNvPr id="4" name="Rectangle 3"/>
-          <p:cNvSpPr/>
-          <p:nvPr/>
-        </p:nvSpPr>
-        <p:spPr>
-          <a:xfrm>
-            <a:off x="0" y="822960"/>
-            <a:ext cx="12191695" cy="36576"/>
-          </a:xfrm>
-          <a:prstGeom prst="rect">
-            <a:avLst/>
-          </a:prstGeom>
-          <a:solidFill>
-            <a:srgbClr val="3498DB"/>
-          </a:solidFill>
-          <a:ln>
-            <a:noFill/>
-          </a:ln>
-        </p:spPr>
-        <p:style>
-          <a:lnRef idx="1">
-            <a:schemeClr val="accent1"/>
-          </a:lnRef>
-          <a:fillRef idx="3">
-            <a:schemeClr val="accent1"/>
-          </a:fillRef>
-          <a:effectRef idx="2">
-            <a:schemeClr val="accent1"/>
-          </a:effectRef>
-          <a:fontRef idx="minor">
-            <a:schemeClr val="lt1"/>
-          </a:fontRef>
-        </p:style>
-        <p:txBody>
-          <a:bodyPr rtlCol="0" anchor="ctr"/>
-          <a:lstStyle/>
-          <a:p>
-            <a:pPr algn="ctr"/>
-          </a:p>
-        </p:txBody>
-      </p:sp>
-      <p:sp>
-        <p:nvSpPr>
-          <p:cNvPr id="5" name="Rectangle 4"/>
-          <p:cNvSpPr/>
-          <p:nvPr/>
-        </p:nvSpPr>
-        <p:spPr>
-          <a:xfrm>
-            <a:off x="548640" y="1371600"/>
-            <a:ext cx="10972800" cy="548640"/>
-          </a:xfrm>
-          <a:prstGeom prst="rect">
-            <a:avLst/>
-          </a:prstGeom>
-          <a:solidFill>
-            <a:srgbClr val="F8F9FA"/>
-          </a:solidFill>
-          <a:ln>
-            <a:noFill/>
-          </a:ln>
-        </p:spPr>
-        <p:style>
-          <a:lnRef idx="1">
-            <a:schemeClr val="accent1"/>
-          </a:lnRef>
-          <a:fillRef idx="3">
-            <a:schemeClr val="accent1"/>
-          </a:fillRef>
-          <a:effectRef idx="2">
-            <a:schemeClr val="accent1"/>
-          </a:effectRef>
-          <a:fontRef idx="minor">
-            <a:schemeClr val="lt1"/>
-          </a:fontRef>
-        </p:style>
-        <p:txBody>
-          <a:bodyPr rtlCol="0" anchor="ctr"/>
-          <a:lstStyle/>
-          <a:p>
-            <a:pPr algn="ctr"/>
-          </a:p>
-        </p:txBody>
-      </p:sp>
-      <p:sp>
-        <p:nvSpPr>
-          <p:cNvPr id="6" name="Rectangle 5"/>
-          <p:cNvSpPr/>
-          <p:nvPr/>
-        </p:nvSpPr>
-        <p:spPr>
-          <a:xfrm>
-            <a:off x="548640" y="1371600"/>
-            <a:ext cx="54864" cy="548640"/>
-          </a:xfrm>
-          <a:prstGeom prst="rect">
-            <a:avLst/>
-          </a:prstGeom>
-          <a:solidFill>
-            <a:srgbClr val="27AE60"/>
-          </a:solidFill>
-          <a:ln>
-            <a:noFill/>
-          </a:ln>
-        </p:spPr>
-        <p:style>
-          <a:lnRef idx="1">
-            <a:schemeClr val="accent1"/>
-          </a:lnRef>
-          <a:fillRef idx="3">
-            <a:schemeClr val="accent1"/>
-          </a:fillRef>
-          <a:effectRef idx="2">
-            <a:schemeClr val="accent1"/>
-          </a:effectRef>
-          <a:fontRef idx="minor">
-            <a:schemeClr val="lt1"/>
-          </a:fontRef>
-        </p:style>
-        <p:txBody>
-          <a:bodyPr rtlCol="0" anchor="ctr"/>
-          <a:lstStyle/>
-          <a:p>
-            <a:pPr algn="ctr"/>
-          </a:p>
-        </p:txBody>
-      </p:sp>
-      <p:sp>
-        <p:nvSpPr>
-          <p:cNvPr id="7" name="TextBox 6"/>
-          <p:cNvSpPr txBox="1"/>
-          <p:nvPr/>
-        </p:nvSpPr>
-        <p:spPr>
-          <a:xfrm>
-            <a:off x="822960" y="1463040"/>
-            <a:ext cx="10515600" cy="365760"/>
-          </a:xfrm>
-          <a:prstGeom prst="rect">
-            <a:avLst/>
-          </a:prstGeom>
-          <a:noFill/>
-        </p:spPr>
-        <p:txBody>
-          <a:bodyPr wrap="square">
-            <a:spAutoFit/>
-          </a:bodyPr>
-          <a:lstStyle/>
-          <a:p>
-            <a:pPr algn="l">
-              <a:defRPr sz="1700" b="0">
-                <a:solidFill>
-                  <a:srgbClr val="2C3E50"/>
-                </a:solidFill>
-                <a:latin typeface="Calibri"/>
-              </a:defRPr>
-            </a:pPr>
-            <a:r>
-              <a:t>1. Patch Management reduksi peak infection 20.0% vs Baseline</a:t>
-            </a:r>
-          </a:p>
-        </p:txBody>
-      </p:sp>
-      <p:sp>
-        <p:nvSpPr>
-          <p:cNvPr id="8" name="Rectangle 7"/>
-          <p:cNvSpPr/>
-          <p:nvPr/>
-        </p:nvSpPr>
-        <p:spPr>
-          <a:xfrm>
-            <a:off x="548640" y="2103120"/>
-            <a:ext cx="10972800" cy="548640"/>
-          </a:xfrm>
-          <a:prstGeom prst="rect">
-            <a:avLst/>
-          </a:prstGeom>
-          <a:solidFill>
-            <a:srgbClr val="F8F9FA"/>
-          </a:solidFill>
-          <a:ln>
-            <a:noFill/>
-          </a:ln>
-        </p:spPr>
-        <p:style>
-          <a:lnRef idx="1">
-            <a:schemeClr val="accent1"/>
-          </a:lnRef>
-          <a:fillRef idx="3">
-            <a:schemeClr val="accent1"/>
-          </a:fillRef>
-          <a:effectRef idx="2">
-            <a:schemeClr val="accent1"/>
-          </a:effectRef>
-          <a:fontRef idx="minor">
-            <a:schemeClr val="lt1"/>
-          </a:fontRef>
-        </p:style>
-        <p:txBody>
-          <a:bodyPr rtlCol="0" anchor="ctr"/>
-          <a:lstStyle/>
-          <a:p>
-            <a:pPr algn="ctr"/>
-          </a:p>
-        </p:txBody>
-      </p:sp>
-      <p:sp>
-        <p:nvSpPr>
-          <p:cNvPr id="9" name="Rectangle 8"/>
-          <p:cNvSpPr/>
-          <p:nvPr/>
-        </p:nvSpPr>
-        <p:spPr>
-          <a:xfrm>
-            <a:off x="548640" y="2103120"/>
-            <a:ext cx="54864" cy="548640"/>
-          </a:xfrm>
-          <a:prstGeom prst="rect">
-            <a:avLst/>
-          </a:prstGeom>
-          <a:solidFill>
-            <a:srgbClr val="27AE60"/>
-          </a:solidFill>
-          <a:ln>
-            <a:noFill/>
-          </a:ln>
-        </p:spPr>
-        <p:style>
-          <a:lnRef idx="1">
-            <a:schemeClr val="accent1"/>
-          </a:lnRef>
-          <a:fillRef idx="3">
-            <a:schemeClr val="accent1"/>
-          </a:fillRef>
-          <a:effectRef idx="2">
-            <a:schemeClr val="accent1"/>
-          </a:effectRef>
-          <a:fontRef idx="minor">
-            <a:schemeClr val="lt1"/>
-          </a:fontRef>
-        </p:style>
-        <p:txBody>
-          <a:bodyPr rtlCol="0" anchor="ctr"/>
-          <a:lstStyle/>
-          <a:p>
-            <a:pPr algn="ctr"/>
-          </a:p>
-        </p:txBody>
-      </p:sp>
-      <p:sp>
-        <p:nvSpPr>
-          <p:cNvPr id="10" name="TextBox 9"/>
-          <p:cNvSpPr txBox="1"/>
-          <p:nvPr/>
-        </p:nvSpPr>
-        <p:spPr>
-          <a:xfrm>
-            <a:off x="822960" y="2194560"/>
-            <a:ext cx="10515600" cy="365760"/>
-          </a:xfrm>
-          <a:prstGeom prst="rect">
-            <a:avLst/>
-          </a:prstGeom>
-          <a:noFill/>
-        </p:spPr>
-        <p:txBody>
-          <a:bodyPr wrap="square">
-            <a:spAutoFit/>
-          </a:bodyPr>
-          <a:lstStyle/>
-          <a:p>
-            <a:pPr algn="l">
-              <a:defRPr sz="1700" b="0">
-                <a:solidFill>
-                  <a:srgbClr val="2C3E50"/>
-                </a:solidFill>
-                <a:latin typeface="Calibri"/>
-              </a:defRPr>
-            </a:pPr>
-            <a:r>
-              <a:t>2. User Training reduksi peak infection 13.3% vs Baseline</a:t>
-            </a:r>
-          </a:p>
-        </p:txBody>
-      </p:sp>
-      <p:sp>
-        <p:nvSpPr>
-          <p:cNvPr id="11" name="Rectangle 10"/>
-          <p:cNvSpPr/>
-          <p:nvPr/>
-        </p:nvSpPr>
-        <p:spPr>
-          <a:xfrm>
-            <a:off x="548640" y="2834640"/>
-            <a:ext cx="10972800" cy="548640"/>
-          </a:xfrm>
-          <a:prstGeom prst="rect">
-            <a:avLst/>
-          </a:prstGeom>
-          <a:solidFill>
-            <a:srgbClr val="F8F9FA"/>
-          </a:solidFill>
-          <a:ln>
-            <a:noFill/>
-          </a:ln>
-        </p:spPr>
-        <p:style>
-          <a:lnRef idx="1">
-            <a:schemeClr val="accent1"/>
-          </a:lnRef>
-          <a:fillRef idx="3">
-            <a:schemeClr val="accent1"/>
-          </a:fillRef>
-          <a:effectRef idx="2">
-            <a:schemeClr val="accent1"/>
-          </a:effectRef>
-          <a:fontRef idx="minor">
-            <a:schemeClr val="lt1"/>
-          </a:fontRef>
-        </p:style>
-        <p:txBody>
-          <a:bodyPr rtlCol="0" anchor="ctr"/>
-          <a:lstStyle/>
-          <a:p>
-            <a:pPr algn="ctr"/>
-          </a:p>
-        </p:txBody>
-      </p:sp>
-      <p:sp>
-        <p:nvSpPr>
-          <p:cNvPr id="12" name="Rectangle 11"/>
-          <p:cNvSpPr/>
-          <p:nvPr/>
-        </p:nvSpPr>
-        <p:spPr>
-          <a:xfrm>
-            <a:off x="548640" y="2834640"/>
-            <a:ext cx="54864" cy="548640"/>
-          </a:xfrm>
-          <a:prstGeom prst="rect">
-            <a:avLst/>
-          </a:prstGeom>
-          <a:solidFill>
-            <a:srgbClr val="27AE60"/>
-          </a:solidFill>
-          <a:ln>
-            <a:noFill/>
-          </a:ln>
-        </p:spPr>
-        <p:style>
-          <a:lnRef idx="1">
-            <a:schemeClr val="accent1"/>
-          </a:lnRef>
-          <a:fillRef idx="3">
-            <a:schemeClr val="accent1"/>
-          </a:fillRef>
-          <a:effectRef idx="2">
-            <a:schemeClr val="accent1"/>
-          </a:effectRef>
-          <a:fontRef idx="minor">
-            <a:schemeClr val="lt1"/>
-          </a:fontRef>
-        </p:style>
-        <p:txBody>
-          <a:bodyPr rtlCol="0" anchor="ctr"/>
-          <a:lstStyle/>
-          <a:p>
-            <a:pPr algn="ctr"/>
-          </a:p>
-        </p:txBody>
-      </p:sp>
-      <p:sp>
-        <p:nvSpPr>
-          <p:cNvPr id="13" name="TextBox 12"/>
-          <p:cNvSpPr txBox="1"/>
-          <p:nvPr/>
-        </p:nvSpPr>
-        <p:spPr>
-          <a:xfrm>
-            <a:off x="822960" y="2926080"/>
-            <a:ext cx="10515600" cy="365760"/>
-          </a:xfrm>
-          <a:prstGeom prst="rect">
-            <a:avLst/>
-          </a:prstGeom>
-          <a:noFill/>
-        </p:spPr>
-        <p:txBody>
-          <a:bodyPr wrap="square">
-            <a:spAutoFit/>
-          </a:bodyPr>
-          <a:lstStyle/>
-          <a:p>
-            <a:pPr algn="l">
-              <a:defRPr sz="1700" b="0">
-                <a:solidFill>
-                  <a:srgbClr val="2C3E50"/>
-                </a:solidFill>
-                <a:latin typeface="Calibri"/>
-              </a:defRPr>
-            </a:pPr>
-            <a:r>
-              <a:t>3. Combined Intervention reduksi 33.3% - terbaik &amp; sinergis</a:t>
-            </a:r>
-          </a:p>
-        </p:txBody>
-      </p:sp>
-      <p:sp>
-        <p:nvSpPr>
-          <p:cNvPr id="14" name="Rectangle 13"/>
-          <p:cNvSpPr/>
-          <p:nvPr/>
-        </p:nvSpPr>
-        <p:spPr>
-          <a:xfrm>
-            <a:off x="548640" y="3566160"/>
-            <a:ext cx="10972800" cy="548640"/>
-          </a:xfrm>
-          <a:prstGeom prst="rect">
-            <a:avLst/>
-          </a:prstGeom>
-          <a:solidFill>
-            <a:srgbClr val="F8F9FA"/>
-          </a:solidFill>
-          <a:ln>
-            <a:noFill/>
-          </a:ln>
-        </p:spPr>
-        <p:style>
-          <a:lnRef idx="1">
-            <a:schemeClr val="accent1"/>
-          </a:lnRef>
-          <a:fillRef idx="3">
-            <a:schemeClr val="accent1"/>
-          </a:fillRef>
-          <a:effectRef idx="2">
-            <a:schemeClr val="accent1"/>
-          </a:effectRef>
-          <a:fontRef idx="minor">
-            <a:schemeClr val="lt1"/>
-          </a:fontRef>
-        </p:style>
-        <p:txBody>
-          <a:bodyPr rtlCol="0" anchor="ctr"/>
-          <a:lstStyle/>
-          <a:p>
-            <a:pPr algn="ctr"/>
-          </a:p>
-        </p:txBody>
-      </p:sp>
-      <p:sp>
-        <p:nvSpPr>
-          <p:cNvPr id="15" name="Rectangle 14"/>
-          <p:cNvSpPr/>
-          <p:nvPr/>
-        </p:nvSpPr>
-        <p:spPr>
-          <a:xfrm>
-            <a:off x="548640" y="3566160"/>
-            <a:ext cx="54864" cy="548640"/>
-          </a:xfrm>
-          <a:prstGeom prst="rect">
-            <a:avLst/>
-          </a:prstGeom>
-          <a:solidFill>
-            <a:srgbClr val="27AE60"/>
-          </a:solidFill>
-          <a:ln>
-            <a:noFill/>
-          </a:ln>
-        </p:spPr>
-        <p:style>
-          <a:lnRef idx="1">
-            <a:schemeClr val="accent1"/>
-          </a:lnRef>
-          <a:fillRef idx="3">
-            <a:schemeClr val="accent1"/>
-          </a:fillRef>
-          <a:effectRef idx="2">
-            <a:schemeClr val="accent1"/>
-          </a:effectRef>
-          <a:fontRef idx="minor">
-            <a:schemeClr val="lt1"/>
-          </a:fontRef>
-        </p:style>
-        <p:txBody>
-          <a:bodyPr rtlCol="0" anchor="ctr"/>
-          <a:lstStyle/>
-          <a:p>
-            <a:pPr algn="ctr"/>
-          </a:p>
-        </p:txBody>
-      </p:sp>
-      <p:sp>
-        <p:nvSpPr>
-          <p:cNvPr id="16" name="TextBox 15"/>
-          <p:cNvSpPr txBox="1"/>
-          <p:nvPr/>
-        </p:nvSpPr>
-        <p:spPr>
-          <a:xfrm>
-            <a:off x="822960" y="3657600"/>
-            <a:ext cx="10515600" cy="365760"/>
-          </a:xfrm>
-          <a:prstGeom prst="rect">
-            <a:avLst/>
-          </a:prstGeom>
-          <a:noFill/>
-        </p:spPr>
-        <p:txBody>
-          <a:bodyPr wrap="square">
-            <a:spAutoFit/>
-          </a:bodyPr>
-          <a:lstStyle/>
-          <a:p>
-            <a:pPr algn="l">
-              <a:defRPr sz="1700" b="0">
-                <a:solidFill>
-                  <a:srgbClr val="2C3E50"/>
-                </a:solidFill>
-                <a:latin typeface="Calibri"/>
-              </a:defRPr>
-            </a:pPr>
-            <a:r>
-              <a:t>4. Semua pairwise signifikan (Mann-Whitney, p &lt; 0.001)</a:t>
-            </a:r>
-          </a:p>
-        </p:txBody>
-      </p:sp>
-      <p:sp>
-        <p:nvSpPr>
-          <p:cNvPr id="17" name="Rectangle 16"/>
-          <p:cNvSpPr/>
-          <p:nvPr/>
-        </p:nvSpPr>
-        <p:spPr>
-          <a:xfrm>
-            <a:off x="548640" y="4297680"/>
-            <a:ext cx="10972800" cy="548640"/>
-          </a:xfrm>
-          <a:prstGeom prst="rect">
-            <a:avLst/>
-          </a:prstGeom>
-          <a:solidFill>
-            <a:srgbClr val="F8F9FA"/>
-          </a:solidFill>
-          <a:ln>
-            <a:noFill/>
-          </a:ln>
-        </p:spPr>
-        <p:style>
-          <a:lnRef idx="1">
-            <a:schemeClr val="accent1"/>
-          </a:lnRef>
-          <a:fillRef idx="3">
-            <a:schemeClr val="accent1"/>
-          </a:fillRef>
-          <a:effectRef idx="2">
-            <a:schemeClr val="accent1"/>
-          </a:effectRef>
-          <a:fontRef idx="minor">
-            <a:schemeClr val="lt1"/>
-          </a:fontRef>
-        </p:style>
-        <p:txBody>
-          <a:bodyPr rtlCol="0" anchor="ctr"/>
-          <a:lstStyle/>
-          <a:p>
-            <a:pPr algn="ctr"/>
-          </a:p>
-        </p:txBody>
-      </p:sp>
-      <p:sp>
-        <p:nvSpPr>
-          <p:cNvPr id="18" name="Rectangle 17"/>
-          <p:cNvSpPr/>
-          <p:nvPr/>
-        </p:nvSpPr>
-        <p:spPr>
-          <a:xfrm>
-            <a:off x="548640" y="4297680"/>
-            <a:ext cx="54864" cy="548640"/>
-          </a:xfrm>
-          <a:prstGeom prst="rect">
-            <a:avLst/>
-          </a:prstGeom>
-          <a:solidFill>
-            <a:srgbClr val="27AE60"/>
-          </a:solidFill>
-          <a:ln>
-            <a:noFill/>
-          </a:ln>
-        </p:spPr>
-        <p:style>
-          <a:lnRef idx="1">
-            <a:schemeClr val="accent1"/>
-          </a:lnRef>
-          <a:fillRef idx="3">
-            <a:schemeClr val="accent1"/>
-          </a:fillRef>
-          <a:effectRef idx="2">
-            <a:schemeClr val="accent1"/>
-          </a:effectRef>
-          <a:fontRef idx="minor">
-            <a:schemeClr val="lt1"/>
-          </a:fontRef>
-        </p:style>
-        <p:txBody>
-          <a:bodyPr rtlCol="0" anchor="ctr"/>
-          <a:lstStyle/>
-          <a:p>
-            <a:pPr algn="ctr"/>
-          </a:p>
-        </p:txBody>
-      </p:sp>
-      <p:sp>
-        <p:nvSpPr>
-          <p:cNvPr id="19" name="TextBox 18"/>
-          <p:cNvSpPr txBox="1"/>
-          <p:nvPr/>
-        </p:nvSpPr>
-        <p:spPr>
-          <a:xfrm>
-            <a:off x="822960" y="4389120"/>
-            <a:ext cx="10515600" cy="365760"/>
-          </a:xfrm>
-          <a:prstGeom prst="rect">
-            <a:avLst/>
-          </a:prstGeom>
-          <a:noFill/>
-        </p:spPr>
-        <p:txBody>
-          <a:bodyPr wrap="square">
-            <a:spAutoFit/>
-          </a:bodyPr>
-          <a:lstStyle/>
-          <a:p>
-            <a:pPr algn="l">
-              <a:defRPr sz="1700" b="0">
-                <a:solidFill>
-                  <a:srgbClr val="2C3E50"/>
-                </a:solidFill>
-                <a:latin typeface="Calibri"/>
-              </a:defRPr>
-            </a:pPr>
-            <a:r>
-              <a:t>5. Dashboard interaktif untuk eksplorasi parameter real-time</a:t>
-            </a:r>
-          </a:p>
-        </p:txBody>
-      </p:sp>
-      <p:sp>
-        <p:nvSpPr>
-          <p:cNvPr id="20" name="Rectangle 19"/>
-          <p:cNvSpPr/>
-          <p:nvPr/>
-        </p:nvSpPr>
-        <p:spPr>
-          <a:xfrm>
-            <a:off x="548640" y="5029200"/>
-            <a:ext cx="10972800" cy="548640"/>
-          </a:xfrm>
-          <a:prstGeom prst="rect">
-            <a:avLst/>
-          </a:prstGeom>
-          <a:solidFill>
-            <a:srgbClr val="F8F9FA"/>
-          </a:solidFill>
-          <a:ln>
-            <a:noFill/>
-          </a:ln>
-        </p:spPr>
-        <p:style>
-          <a:lnRef idx="1">
-            <a:schemeClr val="accent1"/>
-          </a:lnRef>
-          <a:fillRef idx="3">
-            <a:schemeClr val="accent1"/>
-          </a:fillRef>
-          <a:effectRef idx="2">
-            <a:schemeClr val="accent1"/>
-          </a:effectRef>
-          <a:fontRef idx="minor">
-            <a:schemeClr val="lt1"/>
-          </a:fontRef>
-        </p:style>
-        <p:txBody>
-          <a:bodyPr rtlCol="0" anchor="ctr"/>
-          <a:lstStyle/>
-          <a:p>
-            <a:pPr algn="ctr"/>
-          </a:p>
-        </p:txBody>
-      </p:sp>
-      <p:sp>
-        <p:nvSpPr>
-          <p:cNvPr id="21" name="Rectangle 20"/>
-          <p:cNvSpPr/>
-          <p:nvPr/>
-        </p:nvSpPr>
-        <p:spPr>
-          <a:xfrm>
-            <a:off x="548640" y="5029200"/>
-            <a:ext cx="54864" cy="548640"/>
-          </a:xfrm>
-          <a:prstGeom prst="rect">
-            <a:avLst/>
-          </a:prstGeom>
-          <a:solidFill>
-            <a:srgbClr val="27AE60"/>
-          </a:solidFill>
-          <a:ln>
-            <a:noFill/>
-          </a:ln>
-        </p:spPr>
-        <p:style>
-          <a:lnRef idx="1">
-            <a:schemeClr val="accent1"/>
-          </a:lnRef>
-          <a:fillRef idx="3">
-            <a:schemeClr val="accent1"/>
-          </a:fillRef>
-          <a:effectRef idx="2">
-            <a:schemeClr val="accent1"/>
-          </a:effectRef>
-          <a:fontRef idx="minor">
-            <a:schemeClr val="lt1"/>
-          </a:fontRef>
-        </p:style>
-        <p:txBody>
-          <a:bodyPr rtlCol="0" anchor="ctr"/>
-          <a:lstStyle/>
-          <a:p>
-            <a:pPr algn="ctr"/>
-          </a:p>
-        </p:txBody>
-      </p:sp>
-      <p:sp>
-        <p:nvSpPr>
-          <p:cNvPr id="22" name="TextBox 21"/>
-          <p:cNvSpPr txBox="1"/>
-          <p:nvPr/>
-        </p:nvSpPr>
-        <p:spPr>
-          <a:xfrm>
-            <a:off x="822960" y="5120640"/>
-            <a:ext cx="10515600" cy="365760"/>
-          </a:xfrm>
-          <a:prstGeom prst="rect">
-            <a:avLst/>
-          </a:prstGeom>
-          <a:noFill/>
-        </p:spPr>
-        <p:txBody>
-          <a:bodyPr wrap="square">
-            <a:spAutoFit/>
-          </a:bodyPr>
-          <a:lstStyle/>
-          <a:p>
-            <a:pPr algn="l">
-              <a:defRPr sz="1700" b="0">
-                <a:solidFill>
-                  <a:srgbClr val="2C3E50"/>
-                </a:solidFill>
-                <a:latin typeface="Calibri"/>
-              </a:defRPr>
-            </a:pPr>
-            <a:r>
-              <a:t>6. Paper jurnal siap submit (format JJCIT, 18 referensi)</a:t>
-            </a:r>
-          </a:p>
-        </p:txBody>
-      </p:sp>
-    </p:spTree>
-  </p:cSld>
-  <p:clrMapOvr>
-    <a:masterClrMapping/>
-  </p:clrMapOvr>
-</p:sld>
-</file>
-
-<file path=ppt/slides/slide36.xml><?xml version="1.0" encoding="utf-8"?>
+<file path=ppt/slides/slide31.xml><?xml version="1.0" encoding="utf-8"?>
 <p:sld xmlns:a="http://schemas.openxmlformats.org/drawingml/2006/main" xmlns:p="http://schemas.openxmlformats.org/presentationml/2006/main" xmlns:r="http://schemas.openxmlformats.org/officeDocument/2006/relationships">
   <p:cSld>
     <p:bg>

</xml_diff>

<commit_message>
Update paper file dan cleanup generate scripts
</commit_message>
<xml_diff>
--- a/presentasi_ta.pptx
+++ b/presentasi_ta.pptx
@@ -5,39 +5,39 @@
     <p:sldMasterId id="2147483648" r:id="rId1"/>
   </p:sldMasterIdLst>
   <p:sldIdLst>
-    <p:sldId id="256" r:id="rId7"/>
-    <p:sldId id="257" r:id="rId8"/>
-    <p:sldId id="258" r:id="rId9"/>
-    <p:sldId id="259" r:id="rId10"/>
-    <p:sldId id="260" r:id="rId11"/>
-    <p:sldId id="261" r:id="rId12"/>
-    <p:sldId id="262" r:id="rId13"/>
-    <p:sldId id="263" r:id="rId14"/>
-    <p:sldId id="264" r:id="rId15"/>
-    <p:sldId id="265" r:id="rId16"/>
-    <p:sldId id="266" r:id="rId17"/>
-    <p:sldId id="267" r:id="rId18"/>
-    <p:sldId id="268" r:id="rId19"/>
-    <p:sldId id="269" r:id="rId20"/>
-    <p:sldId id="270" r:id="rId21"/>
-    <p:sldId id="271" r:id="rId22"/>
-    <p:sldId id="272" r:id="rId23"/>
-    <p:sldId id="273" r:id="rId24"/>
-    <p:sldId id="274" r:id="rId25"/>
-    <p:sldId id="275" r:id="rId26"/>
-    <p:sldId id="276" r:id="rId27"/>
-    <p:sldId id="277" r:id="rId28"/>
-    <p:sldId id="278" r:id="rId29"/>
-    <p:sldId id="279" r:id="rId30"/>
-    <p:sldId id="280" r:id="rId31"/>
-    <p:sldId id="281" r:id="rId32"/>
-    <p:sldId id="282" r:id="rId33"/>
-    <p:sldId id="283" r:id="rId34"/>
-    <p:sldId id="284" r:id="rId35"/>
-    <p:sldId id="285" r:id="rId36"/>
-    <p:sldId id="286" r:id="rId37"/>
+    <p:sldId id="256" r:id="rId2"/>
+    <p:sldId id="257" r:id="rId3"/>
+    <p:sldId id="258" r:id="rId4"/>
+    <p:sldId id="259" r:id="rId5"/>
+    <p:sldId id="260" r:id="rId6"/>
+    <p:sldId id="261" r:id="rId7"/>
+    <p:sldId id="262" r:id="rId8"/>
+    <p:sldId id="263" r:id="rId9"/>
+    <p:sldId id="264" r:id="rId10"/>
+    <p:sldId id="265" r:id="rId11"/>
+    <p:sldId id="266" r:id="rId12"/>
+    <p:sldId id="267" r:id="rId13"/>
+    <p:sldId id="268" r:id="rId14"/>
+    <p:sldId id="269" r:id="rId15"/>
+    <p:sldId id="270" r:id="rId16"/>
+    <p:sldId id="271" r:id="rId17"/>
+    <p:sldId id="272" r:id="rId18"/>
+    <p:sldId id="273" r:id="rId19"/>
+    <p:sldId id="274" r:id="rId20"/>
+    <p:sldId id="275" r:id="rId21"/>
+    <p:sldId id="276" r:id="rId22"/>
+    <p:sldId id="277" r:id="rId23"/>
+    <p:sldId id="278" r:id="rId24"/>
+    <p:sldId id="279" r:id="rId25"/>
+    <p:sldId id="280" r:id="rId26"/>
+    <p:sldId id="281" r:id="rId27"/>
+    <p:sldId id="282" r:id="rId28"/>
+    <p:sldId id="283" r:id="rId29"/>
+    <p:sldId id="284" r:id="rId30"/>
+    <p:sldId id="285" r:id="rId31"/>
+    <p:sldId id="286" r:id="rId32"/>
   </p:sldIdLst>
-  <p:sldSz cx="12191695" cy="6858000" type="screen4x3"/>
+  <p:sldSz cx="12192000" cy="6858000"/>
   <p:notesSz cx="6858000" cy="9144000"/>
   <p:defaultTextStyle>
     <a:defPPr>
@@ -134,6 +134,22 @@
       </a:defRPr>
     </a:lvl9pPr>
   </p:defaultTextStyle>
+  <p:extLst>
+    <p:ext uri="{EFAFB233-063F-42B5-8137-9DF3F51BA10A}">
+      <p15:sldGuideLst xmlns:p15="http://schemas.microsoft.com/office/powerpoint/2012/main">
+        <p15:guide id="1" orient="horz" pos="2160">
+          <p15:clr>
+            <a:srgbClr val="A4A3A4"/>
+          </p15:clr>
+        </p15:guide>
+        <p15:guide id="2" pos="2880">
+          <p15:clr>
+            <a:srgbClr val="A4A3A4"/>
+          </p15:clr>
+        </p15:guide>
+      </p15:sldGuideLst>
+    </p:ext>
+  </p:extLst>
 </p:presentation>
 </file>
 
@@ -175,10 +191,9 @@
           <a:lstStyle/>
           <a:p>
             <a:r>
-              <a:rPr lang="en-US" smtClean="0"/>
+              <a:rPr lang="en-US"/>
               <a:t>Click to edit Master title style</a:t>
             </a:r>
-            <a:endParaRPr lang="en-US"/>
           </a:p>
         </p:txBody>
       </p:sp>
@@ -294,10 +309,9 @@
           </a:lstStyle>
           <a:p>
             <a:r>
-              <a:rPr lang="en-US" smtClean="0"/>
+              <a:rPr lang="en-US"/>
               <a:t>Click to edit Master subtitle style</a:t>
             </a:r>
-            <a:endParaRPr lang="en-US"/>
           </a:p>
         </p:txBody>
       </p:sp>
@@ -318,7 +332,7 @@
           <a:p>
             <a:fld id="{5BCAD085-E8A6-8845-BD4E-CB4CCA059FC4}" type="datetimeFigureOut">
               <a:rPr lang="en-US" smtClean="0"/>
-              <a:t>1/27/13</a:t>
+              <a:t>7/12/2026</a:t>
             </a:fld>
             <a:endParaRPr lang="en-US"/>
           </a:p>
@@ -412,10 +426,9 @@
           <a:lstStyle/>
           <a:p>
             <a:r>
-              <a:rPr lang="en-US" smtClean="0"/>
+              <a:rPr lang="en-US"/>
               <a:t>Click to edit Master title style</a:t>
             </a:r>
-            <a:endParaRPr lang="en-US"/>
           </a:p>
         </p:txBody>
       </p:sp>
@@ -436,38 +449,37 @@
           <a:p>
             <a:pPr lvl="0"/>
             <a:r>
-              <a:rPr lang="en-US" smtClean="0"/>
+              <a:rPr lang="en-US"/>
               <a:t>Click to edit Master text styles</a:t>
             </a:r>
           </a:p>
           <a:p>
             <a:pPr lvl="1"/>
             <a:r>
-              <a:rPr lang="en-US" smtClean="0"/>
+              <a:rPr lang="en-US"/>
               <a:t>Second level</a:t>
             </a:r>
           </a:p>
           <a:p>
             <a:pPr lvl="2"/>
             <a:r>
-              <a:rPr lang="en-US" smtClean="0"/>
+              <a:rPr lang="en-US"/>
               <a:t>Third level</a:t>
             </a:r>
           </a:p>
           <a:p>
             <a:pPr lvl="3"/>
             <a:r>
-              <a:rPr lang="en-US" smtClean="0"/>
+              <a:rPr lang="en-US"/>
               <a:t>Fourth level</a:t>
             </a:r>
           </a:p>
           <a:p>
             <a:pPr lvl="4"/>
             <a:r>
-              <a:rPr lang="en-US" smtClean="0"/>
+              <a:rPr lang="en-US"/>
               <a:t>Fifth level</a:t>
             </a:r>
-            <a:endParaRPr lang="en-US"/>
           </a:p>
         </p:txBody>
       </p:sp>
@@ -488,7 +500,7 @@
           <a:p>
             <a:fld id="{5BCAD085-E8A6-8845-BD4E-CB4CCA059FC4}" type="datetimeFigureOut">
               <a:rPr lang="en-US" smtClean="0"/>
-              <a:t>1/27/13</a:t>
+              <a:t>7/12/2026</a:t>
             </a:fld>
             <a:endParaRPr lang="en-US"/>
           </a:p>
@@ -587,10 +599,9 @@
           <a:lstStyle/>
           <a:p>
             <a:r>
-              <a:rPr lang="en-US" smtClean="0"/>
+              <a:rPr lang="en-US"/>
               <a:t>Click to edit Master title style</a:t>
             </a:r>
-            <a:endParaRPr lang="en-US"/>
           </a:p>
         </p:txBody>
       </p:sp>
@@ -616,38 +627,37 @@
           <a:p>
             <a:pPr lvl="0"/>
             <a:r>
-              <a:rPr lang="en-US" smtClean="0"/>
+              <a:rPr lang="en-US"/>
               <a:t>Click to edit Master text styles</a:t>
             </a:r>
           </a:p>
           <a:p>
             <a:pPr lvl="1"/>
             <a:r>
-              <a:rPr lang="en-US" smtClean="0"/>
+              <a:rPr lang="en-US"/>
               <a:t>Second level</a:t>
             </a:r>
           </a:p>
           <a:p>
             <a:pPr lvl="2"/>
             <a:r>
-              <a:rPr lang="en-US" smtClean="0"/>
+              <a:rPr lang="en-US"/>
               <a:t>Third level</a:t>
             </a:r>
           </a:p>
           <a:p>
             <a:pPr lvl="3"/>
             <a:r>
-              <a:rPr lang="en-US" smtClean="0"/>
+              <a:rPr lang="en-US"/>
               <a:t>Fourth level</a:t>
             </a:r>
           </a:p>
           <a:p>
             <a:pPr lvl="4"/>
             <a:r>
-              <a:rPr lang="en-US" smtClean="0"/>
+              <a:rPr lang="en-US"/>
               <a:t>Fifth level</a:t>
             </a:r>
-            <a:endParaRPr lang="en-US"/>
           </a:p>
         </p:txBody>
       </p:sp>
@@ -668,7 +678,7 @@
           <a:p>
             <a:fld id="{5BCAD085-E8A6-8845-BD4E-CB4CCA059FC4}" type="datetimeFigureOut">
               <a:rPr lang="en-US" smtClean="0"/>
-              <a:t>1/27/13</a:t>
+              <a:t>7/12/2026</a:t>
             </a:fld>
             <a:endParaRPr lang="en-US"/>
           </a:p>
@@ -762,10 +772,9 @@
           <a:lstStyle/>
           <a:p>
             <a:r>
-              <a:rPr lang="en-US" smtClean="0"/>
+              <a:rPr lang="en-US"/>
               <a:t>Click to edit Master title style</a:t>
             </a:r>
-            <a:endParaRPr lang="en-US"/>
           </a:p>
         </p:txBody>
       </p:sp>
@@ -786,38 +795,37 @@
           <a:p>
             <a:pPr lvl="0"/>
             <a:r>
-              <a:rPr lang="en-US" smtClean="0"/>
+              <a:rPr lang="en-US"/>
               <a:t>Click to edit Master text styles</a:t>
             </a:r>
           </a:p>
           <a:p>
             <a:pPr lvl="1"/>
             <a:r>
-              <a:rPr lang="en-US" smtClean="0"/>
+              <a:rPr lang="en-US"/>
               <a:t>Second level</a:t>
             </a:r>
           </a:p>
           <a:p>
             <a:pPr lvl="2"/>
             <a:r>
-              <a:rPr lang="en-US" smtClean="0"/>
+              <a:rPr lang="en-US"/>
               <a:t>Third level</a:t>
             </a:r>
           </a:p>
           <a:p>
             <a:pPr lvl="3"/>
             <a:r>
-              <a:rPr lang="en-US" smtClean="0"/>
+              <a:rPr lang="en-US"/>
               <a:t>Fourth level</a:t>
             </a:r>
           </a:p>
           <a:p>
             <a:pPr lvl="4"/>
             <a:r>
-              <a:rPr lang="en-US" smtClean="0"/>
+              <a:rPr lang="en-US"/>
               <a:t>Fifth level</a:t>
             </a:r>
-            <a:endParaRPr lang="en-US"/>
           </a:p>
         </p:txBody>
       </p:sp>
@@ -838,7 +846,7 @@
           <a:p>
             <a:fld id="{5BCAD085-E8A6-8845-BD4E-CB4CCA059FC4}" type="datetimeFigureOut">
               <a:rPr lang="en-US" smtClean="0"/>
-              <a:t>1/27/13</a:t>
+              <a:t>7/12/2026</a:t>
             </a:fld>
             <a:endParaRPr lang="en-US"/>
           </a:p>
@@ -941,10 +949,9 @@
           </a:lstStyle>
           <a:p>
             <a:r>
-              <a:rPr lang="en-US" smtClean="0"/>
+              <a:rPr lang="en-US"/>
               <a:t>Click to edit Master title style</a:t>
             </a:r>
-            <a:endParaRPr lang="en-US"/>
           </a:p>
         </p:txBody>
       </p:sp>
@@ -1061,7 +1068,7 @@
           <a:p>
             <a:pPr lvl="0"/>
             <a:r>
-              <a:rPr lang="en-US" smtClean="0"/>
+              <a:rPr lang="en-US"/>
               <a:t>Click to edit Master text styles</a:t>
             </a:r>
           </a:p>
@@ -1084,7 +1091,7 @@
           <a:p>
             <a:fld id="{5BCAD085-E8A6-8845-BD4E-CB4CCA059FC4}" type="datetimeFigureOut">
               <a:rPr lang="en-US" smtClean="0"/>
-              <a:t>1/27/13</a:t>
+              <a:t>7/12/2026</a:t>
             </a:fld>
             <a:endParaRPr lang="en-US"/>
           </a:p>
@@ -1178,10 +1185,9 @@
           <a:lstStyle/>
           <a:p>
             <a:r>
-              <a:rPr lang="en-US" smtClean="0"/>
+              <a:rPr lang="en-US"/>
               <a:t>Click to edit Master title style</a:t>
             </a:r>
-            <a:endParaRPr lang="en-US"/>
           </a:p>
         </p:txBody>
       </p:sp>
@@ -1235,38 +1241,37 @@
           <a:p>
             <a:pPr lvl="0"/>
             <a:r>
-              <a:rPr lang="en-US" smtClean="0"/>
+              <a:rPr lang="en-US"/>
               <a:t>Click to edit Master text styles</a:t>
             </a:r>
           </a:p>
           <a:p>
             <a:pPr lvl="1"/>
             <a:r>
-              <a:rPr lang="en-US" smtClean="0"/>
+              <a:rPr lang="en-US"/>
               <a:t>Second level</a:t>
             </a:r>
           </a:p>
           <a:p>
             <a:pPr lvl="2"/>
             <a:r>
-              <a:rPr lang="en-US" smtClean="0"/>
+              <a:rPr lang="en-US"/>
               <a:t>Third level</a:t>
             </a:r>
           </a:p>
           <a:p>
             <a:pPr lvl="3"/>
             <a:r>
-              <a:rPr lang="en-US" smtClean="0"/>
+              <a:rPr lang="en-US"/>
               <a:t>Fourth level</a:t>
             </a:r>
           </a:p>
           <a:p>
             <a:pPr lvl="4"/>
             <a:r>
-              <a:rPr lang="en-US" smtClean="0"/>
+              <a:rPr lang="en-US"/>
               <a:t>Fifth level</a:t>
             </a:r>
-            <a:endParaRPr lang="en-US"/>
           </a:p>
         </p:txBody>
       </p:sp>
@@ -1320,38 +1325,37 @@
           <a:p>
             <a:pPr lvl="0"/>
             <a:r>
-              <a:rPr lang="en-US" smtClean="0"/>
+              <a:rPr lang="en-US"/>
               <a:t>Click to edit Master text styles</a:t>
             </a:r>
           </a:p>
           <a:p>
             <a:pPr lvl="1"/>
             <a:r>
-              <a:rPr lang="en-US" smtClean="0"/>
+              <a:rPr lang="en-US"/>
               <a:t>Second level</a:t>
             </a:r>
           </a:p>
           <a:p>
             <a:pPr lvl="2"/>
             <a:r>
-              <a:rPr lang="en-US" smtClean="0"/>
+              <a:rPr lang="en-US"/>
               <a:t>Third level</a:t>
             </a:r>
           </a:p>
           <a:p>
             <a:pPr lvl="3"/>
             <a:r>
-              <a:rPr lang="en-US" smtClean="0"/>
+              <a:rPr lang="en-US"/>
               <a:t>Fourth level</a:t>
             </a:r>
           </a:p>
           <a:p>
             <a:pPr lvl="4"/>
             <a:r>
-              <a:rPr lang="en-US" smtClean="0"/>
+              <a:rPr lang="en-US"/>
               <a:t>Fifth level</a:t>
             </a:r>
-            <a:endParaRPr lang="en-US"/>
           </a:p>
         </p:txBody>
       </p:sp>
@@ -1372,7 +1376,7 @@
           <a:p>
             <a:fld id="{5BCAD085-E8A6-8845-BD4E-CB4CCA059FC4}" type="datetimeFigureOut">
               <a:rPr lang="en-US" smtClean="0"/>
-              <a:t>1/27/13</a:t>
+              <a:t>7/12/2026</a:t>
             </a:fld>
             <a:endParaRPr lang="en-US"/>
           </a:p>
@@ -1470,10 +1474,9 @@
           </a:lstStyle>
           <a:p>
             <a:r>
-              <a:rPr lang="en-US" smtClean="0"/>
+              <a:rPr lang="en-US"/>
               <a:t>Click to edit Master title style</a:t>
             </a:r>
-            <a:endParaRPr lang="en-US"/>
           </a:p>
         </p:txBody>
       </p:sp>
@@ -1536,7 +1539,7 @@
           <a:p>
             <a:pPr lvl="0"/>
             <a:r>
-              <a:rPr lang="en-US" smtClean="0"/>
+              <a:rPr lang="en-US"/>
               <a:t>Click to edit Master text styles</a:t>
             </a:r>
           </a:p>
@@ -1592,38 +1595,37 @@
           <a:p>
             <a:pPr lvl="0"/>
             <a:r>
-              <a:rPr lang="en-US" smtClean="0"/>
+              <a:rPr lang="en-US"/>
               <a:t>Click to edit Master text styles</a:t>
             </a:r>
           </a:p>
           <a:p>
             <a:pPr lvl="1"/>
             <a:r>
-              <a:rPr lang="en-US" smtClean="0"/>
+              <a:rPr lang="en-US"/>
               <a:t>Second level</a:t>
             </a:r>
           </a:p>
           <a:p>
             <a:pPr lvl="2"/>
             <a:r>
-              <a:rPr lang="en-US" smtClean="0"/>
+              <a:rPr lang="en-US"/>
               <a:t>Third level</a:t>
             </a:r>
           </a:p>
           <a:p>
             <a:pPr lvl="3"/>
             <a:r>
-              <a:rPr lang="en-US" smtClean="0"/>
+              <a:rPr lang="en-US"/>
               <a:t>Fourth level</a:t>
             </a:r>
           </a:p>
           <a:p>
             <a:pPr lvl="4"/>
             <a:r>
-              <a:rPr lang="en-US" smtClean="0"/>
+              <a:rPr lang="en-US"/>
               <a:t>Fifth level</a:t>
             </a:r>
-            <a:endParaRPr lang="en-US"/>
           </a:p>
         </p:txBody>
       </p:sp>
@@ -1686,7 +1688,7 @@
           <a:p>
             <a:pPr lvl="0"/>
             <a:r>
-              <a:rPr lang="en-US" smtClean="0"/>
+              <a:rPr lang="en-US"/>
               <a:t>Click to edit Master text styles</a:t>
             </a:r>
           </a:p>
@@ -1742,38 +1744,37 @@
           <a:p>
             <a:pPr lvl="0"/>
             <a:r>
-              <a:rPr lang="en-US" smtClean="0"/>
+              <a:rPr lang="en-US"/>
               <a:t>Click to edit Master text styles</a:t>
             </a:r>
           </a:p>
           <a:p>
             <a:pPr lvl="1"/>
             <a:r>
-              <a:rPr lang="en-US" smtClean="0"/>
+              <a:rPr lang="en-US"/>
               <a:t>Second level</a:t>
             </a:r>
           </a:p>
           <a:p>
             <a:pPr lvl="2"/>
             <a:r>
-              <a:rPr lang="en-US" smtClean="0"/>
+              <a:rPr lang="en-US"/>
               <a:t>Third level</a:t>
             </a:r>
           </a:p>
           <a:p>
             <a:pPr lvl="3"/>
             <a:r>
-              <a:rPr lang="en-US" smtClean="0"/>
+              <a:rPr lang="en-US"/>
               <a:t>Fourth level</a:t>
             </a:r>
           </a:p>
           <a:p>
             <a:pPr lvl="4"/>
             <a:r>
-              <a:rPr lang="en-US" smtClean="0"/>
+              <a:rPr lang="en-US"/>
               <a:t>Fifth level</a:t>
             </a:r>
-            <a:endParaRPr lang="en-US"/>
           </a:p>
         </p:txBody>
       </p:sp>
@@ -1794,7 +1795,7 @@
           <a:p>
             <a:fld id="{5BCAD085-E8A6-8845-BD4E-CB4CCA059FC4}" type="datetimeFigureOut">
               <a:rPr lang="en-US" smtClean="0"/>
-              <a:t>1/27/13</a:t>
+              <a:t>7/12/2026</a:t>
             </a:fld>
             <a:endParaRPr lang="en-US"/>
           </a:p>
@@ -1888,10 +1889,9 @@
           <a:lstStyle/>
           <a:p>
             <a:r>
-              <a:rPr lang="en-US" smtClean="0"/>
+              <a:rPr lang="en-US"/>
               <a:t>Click to edit Master title style</a:t>
             </a:r>
-            <a:endParaRPr lang="en-US"/>
           </a:p>
         </p:txBody>
       </p:sp>
@@ -1912,7 +1912,7 @@
           <a:p>
             <a:fld id="{5BCAD085-E8A6-8845-BD4E-CB4CCA059FC4}" type="datetimeFigureOut">
               <a:rPr lang="en-US" smtClean="0"/>
-              <a:t>1/27/13</a:t>
+              <a:t>7/12/2026</a:t>
             </a:fld>
             <a:endParaRPr lang="en-US"/>
           </a:p>
@@ -2007,7 +2007,7 @@
           <a:p>
             <a:fld id="{5BCAD085-E8A6-8845-BD4E-CB4CCA059FC4}" type="datetimeFigureOut">
               <a:rPr lang="en-US" smtClean="0"/>
-              <a:t>1/27/13</a:t>
+              <a:t>7/12/2026</a:t>
             </a:fld>
             <a:endParaRPr lang="en-US"/>
           </a:p>
@@ -2110,10 +2110,9 @@
           </a:lstStyle>
           <a:p>
             <a:r>
-              <a:rPr lang="en-US" smtClean="0"/>
+              <a:rPr lang="en-US"/>
               <a:t>Click to edit Master title style</a:t>
             </a:r>
-            <a:endParaRPr lang="en-US"/>
           </a:p>
         </p:txBody>
       </p:sp>
@@ -2167,38 +2166,37 @@
           <a:p>
             <a:pPr lvl="0"/>
             <a:r>
-              <a:rPr lang="en-US" smtClean="0"/>
+              <a:rPr lang="en-US"/>
               <a:t>Click to edit Master text styles</a:t>
             </a:r>
           </a:p>
           <a:p>
             <a:pPr lvl="1"/>
             <a:r>
-              <a:rPr lang="en-US" smtClean="0"/>
+              <a:rPr lang="en-US"/>
               <a:t>Second level</a:t>
             </a:r>
           </a:p>
           <a:p>
             <a:pPr lvl="2"/>
             <a:r>
-              <a:rPr lang="en-US" smtClean="0"/>
+              <a:rPr lang="en-US"/>
               <a:t>Third level</a:t>
             </a:r>
           </a:p>
           <a:p>
             <a:pPr lvl="3"/>
             <a:r>
-              <a:rPr lang="en-US" smtClean="0"/>
+              <a:rPr lang="en-US"/>
               <a:t>Fourth level</a:t>
             </a:r>
           </a:p>
           <a:p>
             <a:pPr lvl="4"/>
             <a:r>
-              <a:rPr lang="en-US" smtClean="0"/>
+              <a:rPr lang="en-US"/>
               <a:t>Fifth level</a:t>
             </a:r>
-            <a:endParaRPr lang="en-US"/>
           </a:p>
         </p:txBody>
       </p:sp>
@@ -2261,7 +2259,7 @@
           <a:p>
             <a:pPr lvl="0"/>
             <a:r>
-              <a:rPr lang="en-US" smtClean="0"/>
+              <a:rPr lang="en-US"/>
               <a:t>Click to edit Master text styles</a:t>
             </a:r>
           </a:p>
@@ -2284,7 +2282,7 @@
           <a:p>
             <a:fld id="{5BCAD085-E8A6-8845-BD4E-CB4CCA059FC4}" type="datetimeFigureOut">
               <a:rPr lang="en-US" smtClean="0"/>
-              <a:t>1/27/13</a:t>
+              <a:t>7/12/2026</a:t>
             </a:fld>
             <a:endParaRPr lang="en-US"/>
           </a:p>
@@ -2387,10 +2385,9 @@
           </a:lstStyle>
           <a:p>
             <a:r>
-              <a:rPr lang="en-US" smtClean="0"/>
+              <a:rPr lang="en-US"/>
               <a:t>Click to edit Master title style</a:t>
             </a:r>
-            <a:endParaRPr lang="en-US"/>
           </a:p>
         </p:txBody>
       </p:sp>
@@ -2514,7 +2511,7 @@
           <a:p>
             <a:pPr lvl="0"/>
             <a:r>
-              <a:rPr lang="en-US" smtClean="0"/>
+              <a:rPr lang="en-US"/>
               <a:t>Click to edit Master text styles</a:t>
             </a:r>
           </a:p>
@@ -2537,7 +2534,7 @@
           <a:p>
             <a:fld id="{5BCAD085-E8A6-8845-BD4E-CB4CCA059FC4}" type="datetimeFigureOut">
               <a:rPr lang="en-US" smtClean="0"/>
-              <a:t>1/27/13</a:t>
+              <a:t>7/12/2026</a:t>
             </a:fld>
             <a:endParaRPr lang="en-US"/>
           </a:p>
@@ -2646,10 +2643,9 @@
           <a:lstStyle/>
           <a:p>
             <a:r>
-              <a:rPr lang="en-US" smtClean="0"/>
+              <a:rPr lang="en-US"/>
               <a:t>Click to edit Master title style</a:t>
             </a:r>
-            <a:endParaRPr lang="en-US"/>
           </a:p>
         </p:txBody>
       </p:sp>
@@ -2680,38 +2676,37 @@
           <a:p>
             <a:pPr lvl="0"/>
             <a:r>
-              <a:rPr lang="en-US" smtClean="0"/>
+              <a:rPr lang="en-US"/>
               <a:t>Click to edit Master text styles</a:t>
             </a:r>
           </a:p>
           <a:p>
             <a:pPr lvl="1"/>
             <a:r>
-              <a:rPr lang="en-US" smtClean="0"/>
+              <a:rPr lang="en-US"/>
               <a:t>Second level</a:t>
             </a:r>
           </a:p>
           <a:p>
             <a:pPr lvl="2"/>
             <a:r>
-              <a:rPr lang="en-US" smtClean="0"/>
+              <a:rPr lang="en-US"/>
               <a:t>Third level</a:t>
             </a:r>
           </a:p>
           <a:p>
             <a:pPr lvl="3"/>
             <a:r>
-              <a:rPr lang="en-US" smtClean="0"/>
+              <a:rPr lang="en-US"/>
               <a:t>Fourth level</a:t>
             </a:r>
           </a:p>
           <a:p>
             <a:pPr lvl="4"/>
             <a:r>
-              <a:rPr lang="en-US" smtClean="0"/>
+              <a:rPr lang="en-US"/>
               <a:t>Fifth level</a:t>
             </a:r>
-            <a:endParaRPr lang="en-US"/>
           </a:p>
         </p:txBody>
       </p:sp>
@@ -2750,7 +2745,7 @@
           <a:p>
             <a:fld id="{5BCAD085-E8A6-8845-BD4E-CB4CCA059FC4}" type="datetimeFigureOut">
               <a:rPr lang="en-US" smtClean="0"/>
-              <a:t>1/27/13</a:t>
+              <a:t>7/12/2026</a:t>
             </a:fld>
             <a:endParaRPr lang="en-US"/>
           </a:p>
@@ -3109,7 +3104,7 @@
 </file>
 
 <file path=ppt/slides/slide1.xml><?xml version="1.0" encoding="utf-8"?>
-<p:sld xmlns:a="http://schemas.openxmlformats.org/drawingml/2006/main" xmlns:p="http://schemas.openxmlformats.org/presentationml/2006/main" xmlns:r="http://schemas.openxmlformats.org/officeDocument/2006/relationships">
+<p:sld xmlns:a="http://schemas.openxmlformats.org/drawingml/2006/main" xmlns:r="http://schemas.openxmlformats.org/officeDocument/2006/relationships" xmlns:p="http://schemas.openxmlformats.org/presentationml/2006/main">
   <p:cSld>
     <p:bg>
       <p:bgPr>
@@ -3125,7 +3120,14 @@
         <p:cNvGrpSpPr/>
         <p:nvPr/>
       </p:nvGrpSpPr>
-      <p:grpSpPr/>
+      <p:grpSpPr>
+        <a:xfrm>
+          <a:off x="0" y="0"/>
+          <a:ext cx="0" cy="0"/>
+          <a:chOff x="0" y="0"/>
+          <a:chExt cx="0" cy="0"/>
+        </a:xfrm>
+      </p:grpSpPr>
       <p:sp>
         <p:nvSpPr>
           <p:cNvPr id="2" name="Rectangle 1"/>
@@ -3166,6 +3168,7 @@
           <a:lstStyle/>
           <a:p>
             <a:pPr algn="ctr"/>
+            <a:endParaRPr/>
           </a:p>
         </p:txBody>
       </p:sp>
@@ -3334,7 +3337,7 @@
 </file>
 
 <file path=ppt/slides/slide10.xml><?xml version="1.0" encoding="utf-8"?>
-<p:sld xmlns:a="http://schemas.openxmlformats.org/drawingml/2006/main" xmlns:p="http://schemas.openxmlformats.org/presentationml/2006/main" xmlns:r="http://schemas.openxmlformats.org/officeDocument/2006/relationships">
+<p:sld xmlns:a="http://schemas.openxmlformats.org/drawingml/2006/main" xmlns:r="http://schemas.openxmlformats.org/officeDocument/2006/relationships" xmlns:p="http://schemas.openxmlformats.org/presentationml/2006/main">
   <p:cSld>
     <p:bg>
       <p:bgPr>
@@ -3350,7 +3353,14 @@
         <p:cNvGrpSpPr/>
         <p:nvPr/>
       </p:nvGrpSpPr>
-      <p:grpSpPr/>
+      <p:grpSpPr>
+        <a:xfrm>
+          <a:off x="0" y="0"/>
+          <a:ext cx="0" cy="0"/>
+          <a:chOff x="0" y="0"/>
+          <a:chExt cx="0" cy="0"/>
+        </a:xfrm>
+      </p:grpSpPr>
       <p:sp>
         <p:nvSpPr>
           <p:cNvPr id="2" name="Rectangle 1"/>
@@ -3391,6 +3401,7 @@
           <a:lstStyle/>
           <a:p>
             <a:pPr algn="ctr"/>
+            <a:endParaRPr/>
           </a:p>
         </p:txBody>
       </p:sp>
@@ -3470,6 +3481,7 @@
           <a:lstStyle/>
           <a:p>
             <a:pPr algn="ctr"/>
+            <a:endParaRPr/>
           </a:p>
         </p:txBody>
       </p:sp>
@@ -3549,6 +3561,7 @@
           <a:lstStyle/>
           <a:p>
             <a:pPr algn="ctr"/>
+            <a:endParaRPr/>
           </a:p>
         </p:txBody>
       </p:sp>
@@ -3601,6 +3614,7 @@
                 <a:latin typeface="Consolas"/>
               </a:defRPr>
             </a:pPr>
+            <a:endParaRPr/>
           </a:p>
           <a:p>
             <a:pPr>
@@ -3710,6 +3724,7 @@
                 <a:latin typeface="Consolas"/>
               </a:defRPr>
             </a:pPr>
+            <a:endParaRPr/>
           </a:p>
           <a:p>
             <a:pPr>
@@ -3754,7 +3769,7 @@
 </file>
 
 <file path=ppt/slides/slide11.xml><?xml version="1.0" encoding="utf-8"?>
-<p:sld xmlns:a="http://schemas.openxmlformats.org/drawingml/2006/main" xmlns:p="http://schemas.openxmlformats.org/presentationml/2006/main" xmlns:r="http://schemas.openxmlformats.org/officeDocument/2006/relationships">
+<p:sld xmlns:a="http://schemas.openxmlformats.org/drawingml/2006/main" xmlns:r="http://schemas.openxmlformats.org/officeDocument/2006/relationships" xmlns:p="http://schemas.openxmlformats.org/presentationml/2006/main">
   <p:cSld>
     <p:bg>
       <p:bgPr>
@@ -3770,7 +3785,14 @@
         <p:cNvGrpSpPr/>
         <p:nvPr/>
       </p:nvGrpSpPr>
-      <p:grpSpPr/>
+      <p:grpSpPr>
+        <a:xfrm>
+          <a:off x="0" y="0"/>
+          <a:ext cx="0" cy="0"/>
+          <a:chOff x="0" y="0"/>
+          <a:chExt cx="0" cy="0"/>
+        </a:xfrm>
+      </p:grpSpPr>
       <p:sp>
         <p:nvSpPr>
           <p:cNvPr id="2" name="Rectangle 1"/>
@@ -3811,6 +3833,7 @@
           <a:lstStyle/>
           <a:p>
             <a:pPr algn="ctr"/>
+            <a:endParaRPr/>
           </a:p>
         </p:txBody>
       </p:sp>
@@ -3859,7 +3882,7 @@
 </file>
 
 <file path=ppt/slides/slide12.xml><?xml version="1.0" encoding="utf-8"?>
-<p:sld xmlns:a="http://schemas.openxmlformats.org/drawingml/2006/main" xmlns:p="http://schemas.openxmlformats.org/presentationml/2006/main" xmlns:r="http://schemas.openxmlformats.org/officeDocument/2006/relationships">
+<p:sld xmlns:a="http://schemas.openxmlformats.org/drawingml/2006/main" xmlns:r="http://schemas.openxmlformats.org/officeDocument/2006/relationships" xmlns:p="http://schemas.openxmlformats.org/presentationml/2006/main">
   <p:cSld>
     <p:bg>
       <p:bgPr>
@@ -3875,7 +3898,14 @@
         <p:cNvGrpSpPr/>
         <p:nvPr/>
       </p:nvGrpSpPr>
-      <p:grpSpPr/>
+      <p:grpSpPr>
+        <a:xfrm>
+          <a:off x="0" y="0"/>
+          <a:ext cx="0" cy="0"/>
+          <a:chOff x="0" y="0"/>
+          <a:chExt cx="0" cy="0"/>
+        </a:xfrm>
+      </p:grpSpPr>
       <p:sp>
         <p:nvSpPr>
           <p:cNvPr id="2" name="Rectangle 1"/>
@@ -3916,6 +3946,7 @@
           <a:lstStyle/>
           <a:p>
             <a:pPr algn="ctr"/>
+            <a:endParaRPr/>
           </a:p>
         </p:txBody>
       </p:sp>
@@ -3995,6 +4026,7 @@
           <a:lstStyle/>
           <a:p>
             <a:pPr algn="ctr"/>
+            <a:endParaRPr/>
           </a:p>
         </p:txBody>
       </p:sp>
@@ -4038,6 +4070,7 @@
           <a:lstStyle/>
           <a:p>
             <a:pPr algn="ctr"/>
+            <a:endParaRPr/>
           </a:p>
         </p:txBody>
       </p:sp>
@@ -4081,6 +4114,7 @@
           <a:lstStyle/>
           <a:p>
             <a:pPr algn="ctr"/>
+            <a:endParaRPr/>
           </a:p>
         </p:txBody>
       </p:sp>
@@ -4232,6 +4266,7 @@
           <a:lstStyle/>
           <a:p>
             <a:pPr algn="ctr"/>
+            <a:endParaRPr/>
           </a:p>
         </p:txBody>
       </p:sp>
@@ -4275,6 +4310,7 @@
           <a:lstStyle/>
           <a:p>
             <a:pPr algn="ctr"/>
+            <a:endParaRPr/>
           </a:p>
         </p:txBody>
       </p:sp>
@@ -4426,6 +4462,7 @@
           <a:lstStyle/>
           <a:p>
             <a:pPr algn="ctr"/>
+            <a:endParaRPr/>
           </a:p>
         </p:txBody>
       </p:sp>
@@ -4469,6 +4506,7 @@
           <a:lstStyle/>
           <a:p>
             <a:pPr algn="ctr"/>
+            <a:endParaRPr/>
           </a:p>
         </p:txBody>
       </p:sp>
@@ -4620,6 +4658,7 @@
           <a:lstStyle/>
           <a:p>
             <a:pPr algn="ctr"/>
+            <a:endParaRPr/>
           </a:p>
         </p:txBody>
       </p:sp>
@@ -4663,6 +4702,7 @@
           <a:lstStyle/>
           <a:p>
             <a:pPr algn="ctr"/>
+            <a:endParaRPr/>
           </a:p>
         </p:txBody>
       </p:sp>
@@ -4783,7 +4823,7 @@
 </file>
 
 <file path=ppt/slides/slide13.xml><?xml version="1.0" encoding="utf-8"?>
-<p:sld xmlns:a="http://schemas.openxmlformats.org/drawingml/2006/main" xmlns:p="http://schemas.openxmlformats.org/presentationml/2006/main" xmlns:r="http://schemas.openxmlformats.org/officeDocument/2006/relationships">
+<p:sld xmlns:a="http://schemas.openxmlformats.org/drawingml/2006/main" xmlns:r="http://schemas.openxmlformats.org/officeDocument/2006/relationships" xmlns:p="http://schemas.openxmlformats.org/presentationml/2006/main">
   <p:cSld>
     <p:bg>
       <p:bgPr>
@@ -4799,7 +4839,14 @@
         <p:cNvGrpSpPr/>
         <p:nvPr/>
       </p:nvGrpSpPr>
-      <p:grpSpPr/>
+      <p:grpSpPr>
+        <a:xfrm>
+          <a:off x="0" y="0"/>
+          <a:ext cx="0" cy="0"/>
+          <a:chOff x="0" y="0"/>
+          <a:chExt cx="0" cy="0"/>
+        </a:xfrm>
+      </p:grpSpPr>
       <p:sp>
         <p:nvSpPr>
           <p:cNvPr id="2" name="Rectangle 1"/>
@@ -4840,6 +4887,7 @@
           <a:lstStyle/>
           <a:p>
             <a:pPr algn="ctr"/>
+            <a:endParaRPr/>
           </a:p>
         </p:txBody>
       </p:sp>
@@ -4888,7 +4936,7 @@
 </file>
 
 <file path=ppt/slides/slide14.xml><?xml version="1.0" encoding="utf-8"?>
-<p:sld xmlns:a="http://schemas.openxmlformats.org/drawingml/2006/main" xmlns:p="http://schemas.openxmlformats.org/presentationml/2006/main" xmlns:r="http://schemas.openxmlformats.org/officeDocument/2006/relationships">
+<p:sld xmlns:a="http://schemas.openxmlformats.org/drawingml/2006/main" xmlns:r="http://schemas.openxmlformats.org/officeDocument/2006/relationships" xmlns:p="http://schemas.openxmlformats.org/presentationml/2006/main">
   <p:cSld>
     <p:bg>
       <p:bgPr>
@@ -4904,7 +4952,14 @@
         <p:cNvGrpSpPr/>
         <p:nvPr/>
       </p:nvGrpSpPr>
-      <p:grpSpPr/>
+      <p:grpSpPr>
+        <a:xfrm>
+          <a:off x="0" y="0"/>
+          <a:ext cx="0" cy="0"/>
+          <a:chOff x="0" y="0"/>
+          <a:chExt cx="0" cy="0"/>
+        </a:xfrm>
+      </p:grpSpPr>
       <p:sp>
         <p:nvSpPr>
           <p:cNvPr id="2" name="Rectangle 1"/>
@@ -4945,6 +5000,7 @@
           <a:lstStyle/>
           <a:p>
             <a:pPr algn="ctr"/>
+            <a:endParaRPr/>
           </a:p>
         </p:txBody>
       </p:sp>
@@ -5024,6 +5080,7 @@
           <a:lstStyle/>
           <a:p>
             <a:pPr algn="ctr"/>
+            <a:endParaRPr/>
           </a:p>
         </p:txBody>
       </p:sp>
@@ -5067,6 +5124,7 @@
           <a:lstStyle/>
           <a:p>
             <a:pPr algn="ctr"/>
+            <a:endParaRPr/>
           </a:p>
         </p:txBody>
       </p:sp>
@@ -5286,7 +5344,7 @@
 </file>
 
 <file path=ppt/slides/slide15.xml><?xml version="1.0" encoding="utf-8"?>
-<p:sld xmlns:a="http://schemas.openxmlformats.org/drawingml/2006/main" xmlns:p="http://schemas.openxmlformats.org/presentationml/2006/main" xmlns:r="http://schemas.openxmlformats.org/officeDocument/2006/relationships">
+<p:sld xmlns:a="http://schemas.openxmlformats.org/drawingml/2006/main" xmlns:r="http://schemas.openxmlformats.org/officeDocument/2006/relationships" xmlns:p="http://schemas.openxmlformats.org/presentationml/2006/main">
   <p:cSld>
     <p:bg>
       <p:bgPr>
@@ -5302,7 +5360,14 @@
         <p:cNvGrpSpPr/>
         <p:nvPr/>
       </p:nvGrpSpPr>
-      <p:grpSpPr/>
+      <p:grpSpPr>
+        <a:xfrm>
+          <a:off x="0" y="0"/>
+          <a:ext cx="0" cy="0"/>
+          <a:chOff x="0" y="0"/>
+          <a:chExt cx="0" cy="0"/>
+        </a:xfrm>
+      </p:grpSpPr>
       <p:sp>
         <p:nvSpPr>
           <p:cNvPr id="2" name="Rectangle 1"/>
@@ -5343,6 +5408,7 @@
           <a:lstStyle/>
           <a:p>
             <a:pPr algn="ctr"/>
+            <a:endParaRPr/>
           </a:p>
         </p:txBody>
       </p:sp>
@@ -5422,6 +5488,7 @@
           <a:lstStyle/>
           <a:p>
             <a:pPr algn="ctr"/>
+            <a:endParaRPr/>
           </a:p>
         </p:txBody>
       </p:sp>
@@ -5465,6 +5532,7 @@
           <a:lstStyle/>
           <a:p>
             <a:pPr algn="ctr"/>
+            <a:endParaRPr/>
           </a:p>
         </p:txBody>
       </p:sp>
@@ -5629,6 +5697,7 @@
                 <a:latin typeface="Consolas"/>
               </a:defRPr>
             </a:pPr>
+            <a:endParaRPr/>
           </a:p>
           <a:p>
             <a:pPr>
@@ -5738,6 +5807,7 @@
                 <a:latin typeface="Consolas"/>
               </a:defRPr>
             </a:pPr>
+            <a:endParaRPr/>
           </a:p>
           <a:p>
             <a:pPr>
@@ -5894,7 +5964,7 @@
 </file>
 
 <file path=ppt/slides/slide16.xml><?xml version="1.0" encoding="utf-8"?>
-<p:sld xmlns:a="http://schemas.openxmlformats.org/drawingml/2006/main" xmlns:p="http://schemas.openxmlformats.org/presentationml/2006/main" xmlns:r="http://schemas.openxmlformats.org/officeDocument/2006/relationships">
+<p:sld xmlns:a="http://schemas.openxmlformats.org/drawingml/2006/main" xmlns:r="http://schemas.openxmlformats.org/officeDocument/2006/relationships" xmlns:p="http://schemas.openxmlformats.org/presentationml/2006/main">
   <p:cSld>
     <p:bg>
       <p:bgPr>
@@ -5910,7 +5980,14 @@
         <p:cNvGrpSpPr/>
         <p:nvPr/>
       </p:nvGrpSpPr>
-      <p:grpSpPr/>
+      <p:grpSpPr>
+        <a:xfrm>
+          <a:off x="0" y="0"/>
+          <a:ext cx="0" cy="0"/>
+          <a:chOff x="0" y="0"/>
+          <a:chExt cx="0" cy="0"/>
+        </a:xfrm>
+      </p:grpSpPr>
       <p:sp>
         <p:nvSpPr>
           <p:cNvPr id="2" name="Rectangle 1"/>
@@ -5951,6 +6028,7 @@
           <a:lstStyle/>
           <a:p>
             <a:pPr algn="ctr"/>
+            <a:endParaRPr/>
           </a:p>
         </p:txBody>
       </p:sp>
@@ -6030,6 +6108,7 @@
           <a:lstStyle/>
           <a:p>
             <a:pPr algn="ctr"/>
+            <a:endParaRPr/>
           </a:p>
         </p:txBody>
       </p:sp>
@@ -6073,6 +6152,7 @@
           <a:lstStyle/>
           <a:p>
             <a:pPr algn="ctr"/>
+            <a:endParaRPr/>
           </a:p>
         </p:txBody>
       </p:sp>
@@ -6253,6 +6333,7 @@
                 <a:latin typeface="Consolas"/>
               </a:defRPr>
             </a:pPr>
+            <a:endParaRPr/>
           </a:p>
           <a:p>
             <a:pPr>
@@ -6330,6 +6411,7 @@
                 <a:latin typeface="Consolas"/>
               </a:defRPr>
             </a:pPr>
+            <a:endParaRPr/>
           </a:p>
           <a:p>
             <a:pPr>
@@ -6407,6 +6489,7 @@
                 <a:latin typeface="Consolas"/>
               </a:defRPr>
             </a:pPr>
+            <a:endParaRPr/>
           </a:p>
           <a:p>
             <a:pPr>
@@ -6451,7 +6534,7 @@
 </file>
 
 <file path=ppt/slides/slide17.xml><?xml version="1.0" encoding="utf-8"?>
-<p:sld xmlns:a="http://schemas.openxmlformats.org/drawingml/2006/main" xmlns:p="http://schemas.openxmlformats.org/presentationml/2006/main" xmlns:r="http://schemas.openxmlformats.org/officeDocument/2006/relationships">
+<p:sld xmlns:a="http://schemas.openxmlformats.org/drawingml/2006/main" xmlns:r="http://schemas.openxmlformats.org/officeDocument/2006/relationships" xmlns:p="http://schemas.openxmlformats.org/presentationml/2006/main">
   <p:cSld>
     <p:bg>
       <p:bgPr>
@@ -6467,7 +6550,14 @@
         <p:cNvGrpSpPr/>
         <p:nvPr/>
       </p:nvGrpSpPr>
-      <p:grpSpPr/>
+      <p:grpSpPr>
+        <a:xfrm>
+          <a:off x="0" y="0"/>
+          <a:ext cx="0" cy="0"/>
+          <a:chOff x="0" y="0"/>
+          <a:chExt cx="0" cy="0"/>
+        </a:xfrm>
+      </p:grpSpPr>
       <p:sp>
         <p:nvSpPr>
           <p:cNvPr id="2" name="Rectangle 1"/>
@@ -6508,6 +6598,7 @@
           <a:lstStyle/>
           <a:p>
             <a:pPr algn="ctr"/>
+            <a:endParaRPr/>
           </a:p>
         </p:txBody>
       </p:sp>
@@ -6587,6 +6678,7 @@
           <a:lstStyle/>
           <a:p>
             <a:pPr algn="ctr"/>
+            <a:endParaRPr/>
           </a:p>
         </p:txBody>
       </p:sp>
@@ -6630,6 +6722,7 @@
           <a:lstStyle/>
           <a:p>
             <a:pPr algn="ctr"/>
+            <a:endParaRPr/>
           </a:p>
         </p:txBody>
       </p:sp>
@@ -6698,6 +6791,7 @@
                 <a:latin typeface="Consolas"/>
               </a:defRPr>
             </a:pPr>
+            <a:endParaRPr/>
           </a:p>
           <a:p>
             <a:pPr>
@@ -6743,6 +6837,7 @@
                 <a:latin typeface="Consolas"/>
               </a:defRPr>
             </a:pPr>
+            <a:endParaRPr/>
           </a:p>
           <a:p>
             <a:pPr>
@@ -6788,6 +6883,7 @@
                 <a:latin typeface="Consolas"/>
               </a:defRPr>
             </a:pPr>
+            <a:endParaRPr/>
           </a:p>
           <a:p>
             <a:pPr>
@@ -6849,6 +6945,7 @@
                 <a:latin typeface="Consolas"/>
               </a:defRPr>
             </a:pPr>
+            <a:endParaRPr/>
           </a:p>
           <a:p>
             <a:pPr>
@@ -6949,7 +7046,7 @@
 </file>
 
 <file path=ppt/slides/slide18.xml><?xml version="1.0" encoding="utf-8"?>
-<p:sld xmlns:a="http://schemas.openxmlformats.org/drawingml/2006/main" xmlns:p="http://schemas.openxmlformats.org/presentationml/2006/main" xmlns:r="http://schemas.openxmlformats.org/officeDocument/2006/relationships">
+<p:sld xmlns:a="http://schemas.openxmlformats.org/drawingml/2006/main" xmlns:r="http://schemas.openxmlformats.org/officeDocument/2006/relationships" xmlns:p="http://schemas.openxmlformats.org/presentationml/2006/main">
   <p:cSld>
     <p:bg>
       <p:bgPr>
@@ -6965,7 +7062,14 @@
         <p:cNvGrpSpPr/>
         <p:nvPr/>
       </p:nvGrpSpPr>
-      <p:grpSpPr/>
+      <p:grpSpPr>
+        <a:xfrm>
+          <a:off x="0" y="0"/>
+          <a:ext cx="0" cy="0"/>
+          <a:chOff x="0" y="0"/>
+          <a:chExt cx="0" cy="0"/>
+        </a:xfrm>
+      </p:grpSpPr>
       <p:sp>
         <p:nvSpPr>
           <p:cNvPr id="2" name="Rectangle 1"/>
@@ -7006,6 +7110,7 @@
           <a:lstStyle/>
           <a:p>
             <a:pPr algn="ctr"/>
+            <a:endParaRPr/>
           </a:p>
         </p:txBody>
       </p:sp>
@@ -7054,7 +7159,7 @@
 </file>
 
 <file path=ppt/slides/slide19.xml><?xml version="1.0" encoding="utf-8"?>
-<p:sld xmlns:a="http://schemas.openxmlformats.org/drawingml/2006/main" xmlns:p="http://schemas.openxmlformats.org/presentationml/2006/main" xmlns:r="http://schemas.openxmlformats.org/officeDocument/2006/relationships">
+<p:sld xmlns:a="http://schemas.openxmlformats.org/drawingml/2006/main" xmlns:r="http://schemas.openxmlformats.org/officeDocument/2006/relationships" xmlns:p="http://schemas.openxmlformats.org/presentationml/2006/main">
   <p:cSld>
     <p:bg>
       <p:bgPr>
@@ -7070,7 +7175,14 @@
         <p:cNvGrpSpPr/>
         <p:nvPr/>
       </p:nvGrpSpPr>
-      <p:grpSpPr/>
+      <p:grpSpPr>
+        <a:xfrm>
+          <a:off x="0" y="0"/>
+          <a:ext cx="0" cy="0"/>
+          <a:chOff x="0" y="0"/>
+          <a:chExt cx="0" cy="0"/>
+        </a:xfrm>
+      </p:grpSpPr>
       <p:sp>
         <p:nvSpPr>
           <p:cNvPr id="2" name="Rectangle 1"/>
@@ -7111,6 +7223,7 @@
           <a:lstStyle/>
           <a:p>
             <a:pPr algn="ctr"/>
+            <a:endParaRPr/>
           </a:p>
         </p:txBody>
       </p:sp>
@@ -7190,6 +7303,7 @@
           <a:lstStyle/>
           <a:p>
             <a:pPr algn="ctr"/>
+            <a:endParaRPr/>
           </a:p>
         </p:txBody>
       </p:sp>
@@ -7212,11 +7326,41 @@
                 <a:tableStyleId>{5C22544A-7EE6-4342-B048-85BDC9FD1C3A}</a:tableStyleId>
               </a:tblPr>
               <a:tblGrid>
-                <a:gridCol w="1828800"/>
-                <a:gridCol w="1828800"/>
-                <a:gridCol w="1828800"/>
-                <a:gridCol w="1828800"/>
-                <a:gridCol w="1828800"/>
+                <a:gridCol w="1828800">
+                  <a:extLst>
+                    <a:ext uri="{9D8B030D-6E8A-4147-A177-3AD203B41FA5}">
+                      <a16:colId xmlns:a16="http://schemas.microsoft.com/office/drawing/2014/main" val="20000"/>
+                    </a:ext>
+                  </a:extLst>
+                </a:gridCol>
+                <a:gridCol w="1828800">
+                  <a:extLst>
+                    <a:ext uri="{9D8B030D-6E8A-4147-A177-3AD203B41FA5}">
+                      <a16:colId xmlns:a16="http://schemas.microsoft.com/office/drawing/2014/main" val="20001"/>
+                    </a:ext>
+                  </a:extLst>
+                </a:gridCol>
+                <a:gridCol w="1828800">
+                  <a:extLst>
+                    <a:ext uri="{9D8B030D-6E8A-4147-A177-3AD203B41FA5}">
+                      <a16:colId xmlns:a16="http://schemas.microsoft.com/office/drawing/2014/main" val="20002"/>
+                    </a:ext>
+                  </a:extLst>
+                </a:gridCol>
+                <a:gridCol w="1828800">
+                  <a:extLst>
+                    <a:ext uri="{9D8B030D-6E8A-4147-A177-3AD203B41FA5}">
+                      <a16:colId xmlns:a16="http://schemas.microsoft.com/office/drawing/2014/main" val="20003"/>
+                    </a:ext>
+                  </a:extLst>
+                </a:gridCol>
+                <a:gridCol w="1828800">
+                  <a:extLst>
+                    <a:ext uri="{9D8B030D-6E8A-4147-A177-3AD203B41FA5}">
+                      <a16:colId xmlns:a16="http://schemas.microsoft.com/office/drawing/2014/main" val="20004"/>
+                    </a:ext>
+                  </a:extLst>
+                </a:gridCol>
               </a:tblGrid>
               <a:tr h="548640">
                 <a:tc>
@@ -7238,7 +7382,7 @@
                   </a:txBody>
                   <a:tcPr>
                     <a:solidFill>
-                      <a:srgbClr val="1a233b"/>
+                      <a:srgbClr val="1A233B"/>
                     </a:solidFill>
                   </a:tcPr>
                 </a:tc>
@@ -7261,7 +7405,7 @@
                   </a:txBody>
                   <a:tcPr>
                     <a:solidFill>
-                      <a:srgbClr val="1a233b"/>
+                      <a:srgbClr val="1A233B"/>
                     </a:solidFill>
                   </a:tcPr>
                 </a:tc>
@@ -7284,7 +7428,7 @@
                   </a:txBody>
                   <a:tcPr>
                     <a:solidFill>
-                      <a:srgbClr val="1a233b"/>
+                      <a:srgbClr val="1A233B"/>
                     </a:solidFill>
                   </a:tcPr>
                 </a:tc>
@@ -7307,7 +7451,7 @@
                   </a:txBody>
                   <a:tcPr>
                     <a:solidFill>
-                      <a:srgbClr val="1a233b"/>
+                      <a:srgbClr val="1A233B"/>
                     </a:solidFill>
                   </a:tcPr>
                 </a:tc>
@@ -7330,10 +7474,15 @@
                   </a:txBody>
                   <a:tcPr>
                     <a:solidFill>
-                      <a:srgbClr val="1a233b"/>
+                      <a:srgbClr val="1A233B"/>
                     </a:solidFill>
                   </a:tcPr>
                 </a:tc>
+                <a:extLst>
+                  <a:ext uri="{0D108BD9-81ED-4DB2-BD59-A6C34878D82A}">
+                    <a16:rowId xmlns:a16="http://schemas.microsoft.com/office/drawing/2014/main" val="10000"/>
+                  </a:ext>
+                </a:extLst>
               </a:tr>
               <a:tr h="548640">
                 <a:tc>
@@ -7431,6 +7580,11 @@
                   </a:txBody>
                   <a:tcPr/>
                 </a:tc>
+                <a:extLst>
+                  <a:ext uri="{0D108BD9-81ED-4DB2-BD59-A6C34878D82A}">
+                    <a16:rowId xmlns:a16="http://schemas.microsoft.com/office/drawing/2014/main" val="10001"/>
+                  </a:ext>
+                </a:extLst>
               </a:tr>
               <a:tr h="548640">
                 <a:tc>
@@ -7528,6 +7682,11 @@
                   </a:txBody>
                   <a:tcPr/>
                 </a:tc>
+                <a:extLst>
+                  <a:ext uri="{0D108BD9-81ED-4DB2-BD59-A6C34878D82A}">
+                    <a16:rowId xmlns:a16="http://schemas.microsoft.com/office/drawing/2014/main" val="10002"/>
+                  </a:ext>
+                </a:extLst>
               </a:tr>
               <a:tr h="548640">
                 <a:tc>
@@ -7625,6 +7784,11 @@
                   </a:txBody>
                   <a:tcPr/>
                 </a:tc>
+                <a:extLst>
+                  <a:ext uri="{0D108BD9-81ED-4DB2-BD59-A6C34878D82A}">
+                    <a16:rowId xmlns:a16="http://schemas.microsoft.com/office/drawing/2014/main" val="10003"/>
+                  </a:ext>
+                </a:extLst>
               </a:tr>
               <a:tr h="548640">
                 <a:tc>
@@ -7722,6 +7886,11 @@
                   </a:txBody>
                   <a:tcPr/>
                 </a:tc>
+                <a:extLst>
+                  <a:ext uri="{0D108BD9-81ED-4DB2-BD59-A6C34878D82A}">
+                    <a16:rowId xmlns:a16="http://schemas.microsoft.com/office/drawing/2014/main" val="10004"/>
+                  </a:ext>
+                </a:extLst>
               </a:tr>
             </a:tbl>
           </a:graphicData>
@@ -7776,7 +7945,7 @@
 </file>
 
 <file path=ppt/slides/slide2.xml><?xml version="1.0" encoding="utf-8"?>
-<p:sld xmlns:a="http://schemas.openxmlformats.org/drawingml/2006/main" xmlns:p="http://schemas.openxmlformats.org/presentationml/2006/main" xmlns:r="http://schemas.openxmlformats.org/officeDocument/2006/relationships">
+<p:sld xmlns:a="http://schemas.openxmlformats.org/drawingml/2006/main" xmlns:r="http://schemas.openxmlformats.org/officeDocument/2006/relationships" xmlns:p="http://schemas.openxmlformats.org/presentationml/2006/main">
   <p:cSld>
     <p:bg>
       <p:bgPr>
@@ -7792,7 +7961,14 @@
         <p:cNvGrpSpPr/>
         <p:nvPr/>
       </p:nvGrpSpPr>
-      <p:grpSpPr/>
+      <p:grpSpPr>
+        <a:xfrm>
+          <a:off x="0" y="0"/>
+          <a:ext cx="0" cy="0"/>
+          <a:chOff x="0" y="0"/>
+          <a:chExt cx="0" cy="0"/>
+        </a:xfrm>
+      </p:grpSpPr>
       <p:sp>
         <p:nvSpPr>
           <p:cNvPr id="2" name="Rectangle 1"/>
@@ -7833,6 +8009,7 @@
           <a:lstStyle/>
           <a:p>
             <a:pPr algn="ctr"/>
+            <a:endParaRPr/>
           </a:p>
         </p:txBody>
       </p:sp>
@@ -7912,6 +8089,7 @@
           <a:lstStyle/>
           <a:p>
             <a:pPr algn="ctr"/>
+            <a:endParaRPr/>
           </a:p>
         </p:txBody>
       </p:sp>
@@ -8091,7 +8269,7 @@
 </file>
 
 <file path=ppt/slides/slide20.xml><?xml version="1.0" encoding="utf-8"?>
-<p:sld xmlns:a="http://schemas.openxmlformats.org/drawingml/2006/main" xmlns:p="http://schemas.openxmlformats.org/presentationml/2006/main" xmlns:r="http://schemas.openxmlformats.org/officeDocument/2006/relationships">
+<p:sld xmlns:a="http://schemas.openxmlformats.org/drawingml/2006/main" xmlns:r="http://schemas.openxmlformats.org/officeDocument/2006/relationships" xmlns:p="http://schemas.openxmlformats.org/presentationml/2006/main">
   <p:cSld>
     <p:bg>
       <p:bgPr>
@@ -8107,7 +8285,14 @@
         <p:cNvGrpSpPr/>
         <p:nvPr/>
       </p:nvGrpSpPr>
-      <p:grpSpPr/>
+      <p:grpSpPr>
+        <a:xfrm>
+          <a:off x="0" y="0"/>
+          <a:ext cx="0" cy="0"/>
+          <a:chOff x="0" y="0"/>
+          <a:chExt cx="0" cy="0"/>
+        </a:xfrm>
+      </p:grpSpPr>
       <p:sp>
         <p:nvSpPr>
           <p:cNvPr id="2" name="Rectangle 1"/>
@@ -8148,6 +8333,7 @@
           <a:lstStyle/>
           <a:p>
             <a:pPr algn="ctr"/>
+            <a:endParaRPr/>
           </a:p>
         </p:txBody>
       </p:sp>
@@ -8227,6 +8413,7 @@
           <a:lstStyle/>
           <a:p>
             <a:pPr algn="ctr"/>
+            <a:endParaRPr/>
           </a:p>
         </p:txBody>
       </p:sp>
@@ -8303,7 +8490,7 @@
 </file>
 
 <file path=ppt/slides/slide21.xml><?xml version="1.0" encoding="utf-8"?>
-<p:sld xmlns:a="http://schemas.openxmlformats.org/drawingml/2006/main" xmlns:p="http://schemas.openxmlformats.org/presentationml/2006/main" xmlns:r="http://schemas.openxmlformats.org/officeDocument/2006/relationships">
+<p:sld xmlns:a="http://schemas.openxmlformats.org/drawingml/2006/main" xmlns:r="http://schemas.openxmlformats.org/officeDocument/2006/relationships" xmlns:p="http://schemas.openxmlformats.org/presentationml/2006/main">
   <p:cSld>
     <p:bg>
       <p:bgPr>
@@ -8319,7 +8506,14 @@
         <p:cNvGrpSpPr/>
         <p:nvPr/>
       </p:nvGrpSpPr>
-      <p:grpSpPr/>
+      <p:grpSpPr>
+        <a:xfrm>
+          <a:off x="0" y="0"/>
+          <a:ext cx="0" cy="0"/>
+          <a:chOff x="0" y="0"/>
+          <a:chExt cx="0" cy="0"/>
+        </a:xfrm>
+      </p:grpSpPr>
       <p:sp>
         <p:nvSpPr>
           <p:cNvPr id="2" name="Rectangle 1"/>
@@ -8360,6 +8554,7 @@
           <a:lstStyle/>
           <a:p>
             <a:pPr algn="ctr"/>
+            <a:endParaRPr/>
           </a:p>
         </p:txBody>
       </p:sp>
@@ -8439,6 +8634,7 @@
           <a:lstStyle/>
           <a:p>
             <a:pPr algn="ctr"/>
+            <a:endParaRPr/>
           </a:p>
         </p:txBody>
       </p:sp>
@@ -8511,7 +8707,7 @@
 </file>
 
 <file path=ppt/slides/slide22.xml><?xml version="1.0" encoding="utf-8"?>
-<p:sld xmlns:a="http://schemas.openxmlformats.org/drawingml/2006/main" xmlns:p="http://schemas.openxmlformats.org/presentationml/2006/main" xmlns:r="http://schemas.openxmlformats.org/officeDocument/2006/relationships">
+<p:sld xmlns:a="http://schemas.openxmlformats.org/drawingml/2006/main" xmlns:r="http://schemas.openxmlformats.org/officeDocument/2006/relationships" xmlns:p="http://schemas.openxmlformats.org/presentationml/2006/main">
   <p:cSld>
     <p:bg>
       <p:bgPr>
@@ -8527,7 +8723,14 @@
         <p:cNvGrpSpPr/>
         <p:nvPr/>
       </p:nvGrpSpPr>
-      <p:grpSpPr/>
+      <p:grpSpPr>
+        <a:xfrm>
+          <a:off x="0" y="0"/>
+          <a:ext cx="0" cy="0"/>
+          <a:chOff x="0" y="0"/>
+          <a:chExt cx="0" cy="0"/>
+        </a:xfrm>
+      </p:grpSpPr>
       <p:sp>
         <p:nvSpPr>
           <p:cNvPr id="2" name="Rectangle 1"/>
@@ -8568,6 +8771,7 @@
           <a:lstStyle/>
           <a:p>
             <a:pPr algn="ctr"/>
+            <a:endParaRPr/>
           </a:p>
         </p:txBody>
       </p:sp>
@@ -8647,6 +8851,7 @@
           <a:lstStyle/>
           <a:p>
             <a:pPr algn="ctr"/>
+            <a:endParaRPr/>
           </a:p>
         </p:txBody>
       </p:sp>
@@ -8666,8 +8871,8 @@
         </p:blipFill>
         <p:spPr>
           <a:xfrm>
-            <a:off x="1371600" y="1097280"/>
-            <a:ext cx="9144000" cy="7067614"/>
+            <a:off x="3129116" y="1133856"/>
+            <a:ext cx="5933768" cy="4586350"/>
           </a:xfrm>
           <a:prstGeom prst="rect">
             <a:avLst/>
@@ -8719,7 +8924,7 @@
 </file>
 
 <file path=ppt/slides/slide23.xml><?xml version="1.0" encoding="utf-8"?>
-<p:sld xmlns:a="http://schemas.openxmlformats.org/drawingml/2006/main" xmlns:p="http://schemas.openxmlformats.org/presentationml/2006/main" xmlns:r="http://schemas.openxmlformats.org/officeDocument/2006/relationships">
+<p:sld xmlns:a="http://schemas.openxmlformats.org/drawingml/2006/main" xmlns:r="http://schemas.openxmlformats.org/officeDocument/2006/relationships" xmlns:p="http://schemas.openxmlformats.org/presentationml/2006/main">
   <p:cSld>
     <p:bg>
       <p:bgPr>
@@ -8735,7 +8940,14 @@
         <p:cNvGrpSpPr/>
         <p:nvPr/>
       </p:nvGrpSpPr>
-      <p:grpSpPr/>
+      <p:grpSpPr>
+        <a:xfrm>
+          <a:off x="0" y="0"/>
+          <a:ext cx="0" cy="0"/>
+          <a:chOff x="0" y="0"/>
+          <a:chExt cx="0" cy="0"/>
+        </a:xfrm>
+      </p:grpSpPr>
       <p:sp>
         <p:nvSpPr>
           <p:cNvPr id="2" name="Rectangle 1"/>
@@ -8776,6 +8988,7 @@
           <a:lstStyle/>
           <a:p>
             <a:pPr algn="ctr"/>
+            <a:endParaRPr/>
           </a:p>
         </p:txBody>
       </p:sp>
@@ -8855,6 +9068,7 @@
           <a:lstStyle/>
           <a:p>
             <a:pPr algn="ctr"/>
+            <a:endParaRPr/>
           </a:p>
         </p:txBody>
       </p:sp>
@@ -8927,7 +9141,7 @@
 </file>
 
 <file path=ppt/slides/slide24.xml><?xml version="1.0" encoding="utf-8"?>
-<p:sld xmlns:a="http://schemas.openxmlformats.org/drawingml/2006/main" xmlns:p="http://schemas.openxmlformats.org/presentationml/2006/main" xmlns:r="http://schemas.openxmlformats.org/officeDocument/2006/relationships">
+<p:sld xmlns:a="http://schemas.openxmlformats.org/drawingml/2006/main" xmlns:r="http://schemas.openxmlformats.org/officeDocument/2006/relationships" xmlns:p="http://schemas.openxmlformats.org/presentationml/2006/main">
   <p:cSld>
     <p:bg>
       <p:bgPr>
@@ -8943,7 +9157,14 @@
         <p:cNvGrpSpPr/>
         <p:nvPr/>
       </p:nvGrpSpPr>
-      <p:grpSpPr/>
+      <p:grpSpPr>
+        <a:xfrm>
+          <a:off x="0" y="0"/>
+          <a:ext cx="0" cy="0"/>
+          <a:chOff x="0" y="0"/>
+          <a:chExt cx="0" cy="0"/>
+        </a:xfrm>
+      </p:grpSpPr>
       <p:sp>
         <p:nvSpPr>
           <p:cNvPr id="2" name="Rectangle 1"/>
@@ -8984,6 +9205,7 @@
           <a:lstStyle/>
           <a:p>
             <a:pPr algn="ctr"/>
+            <a:endParaRPr/>
           </a:p>
         </p:txBody>
       </p:sp>
@@ -9063,6 +9285,7 @@
           <a:lstStyle/>
           <a:p>
             <a:pPr algn="ctr"/>
+            <a:endParaRPr/>
           </a:p>
         </p:txBody>
       </p:sp>
@@ -9135,7 +9358,7 @@
 </file>
 
 <file path=ppt/slides/slide25.xml><?xml version="1.0" encoding="utf-8"?>
-<p:sld xmlns:a="http://schemas.openxmlformats.org/drawingml/2006/main" xmlns:p="http://schemas.openxmlformats.org/presentationml/2006/main" xmlns:r="http://schemas.openxmlformats.org/officeDocument/2006/relationships">
+<p:sld xmlns:a="http://schemas.openxmlformats.org/drawingml/2006/main" xmlns:r="http://schemas.openxmlformats.org/officeDocument/2006/relationships" xmlns:p="http://schemas.openxmlformats.org/presentationml/2006/main">
   <p:cSld>
     <p:bg>
       <p:bgPr>
@@ -9151,7 +9374,14 @@
         <p:cNvGrpSpPr/>
         <p:nvPr/>
       </p:nvGrpSpPr>
-      <p:grpSpPr/>
+      <p:grpSpPr>
+        <a:xfrm>
+          <a:off x="0" y="0"/>
+          <a:ext cx="0" cy="0"/>
+          <a:chOff x="0" y="0"/>
+          <a:chExt cx="0" cy="0"/>
+        </a:xfrm>
+      </p:grpSpPr>
       <p:sp>
         <p:nvSpPr>
           <p:cNvPr id="2" name="Rectangle 1"/>
@@ -9192,6 +9422,7 @@
           <a:lstStyle/>
           <a:p>
             <a:pPr algn="ctr"/>
+            <a:endParaRPr/>
           </a:p>
         </p:txBody>
       </p:sp>
@@ -9271,6 +9502,7 @@
           <a:lstStyle/>
           <a:p>
             <a:pPr algn="ctr"/>
+            <a:endParaRPr/>
           </a:p>
         </p:txBody>
       </p:sp>
@@ -9329,10 +9561,34 @@
                 <a:tableStyleId>{5C22544A-7EE6-4342-B048-85BDC9FD1C3A}</a:tableStyleId>
               </a:tblPr>
               <a:tblGrid>
-                <a:gridCol w="2057400"/>
-                <a:gridCol w="2057400"/>
-                <a:gridCol w="2057400"/>
-                <a:gridCol w="2057400"/>
+                <a:gridCol w="2057400">
+                  <a:extLst>
+                    <a:ext uri="{9D8B030D-6E8A-4147-A177-3AD203B41FA5}">
+                      <a16:colId xmlns:a16="http://schemas.microsoft.com/office/drawing/2014/main" val="20000"/>
+                    </a:ext>
+                  </a:extLst>
+                </a:gridCol>
+                <a:gridCol w="2057400">
+                  <a:extLst>
+                    <a:ext uri="{9D8B030D-6E8A-4147-A177-3AD203B41FA5}">
+                      <a16:colId xmlns:a16="http://schemas.microsoft.com/office/drawing/2014/main" val="20001"/>
+                    </a:ext>
+                  </a:extLst>
+                </a:gridCol>
+                <a:gridCol w="2057400">
+                  <a:extLst>
+                    <a:ext uri="{9D8B030D-6E8A-4147-A177-3AD203B41FA5}">
+                      <a16:colId xmlns:a16="http://schemas.microsoft.com/office/drawing/2014/main" val="20002"/>
+                    </a:ext>
+                  </a:extLst>
+                </a:gridCol>
+                <a:gridCol w="2057400">
+                  <a:extLst>
+                    <a:ext uri="{9D8B030D-6E8A-4147-A177-3AD203B41FA5}">
+                      <a16:colId xmlns:a16="http://schemas.microsoft.com/office/drawing/2014/main" val="20003"/>
+                    </a:ext>
+                  </a:extLst>
+                </a:gridCol>
               </a:tblGrid>
               <a:tr h="571500">
                 <a:tc>
@@ -9354,7 +9610,7 @@
                   </a:txBody>
                   <a:tcPr>
                     <a:solidFill>
-                      <a:srgbClr val="1a233b"/>
+                      <a:srgbClr val="1A233B"/>
                     </a:solidFill>
                   </a:tcPr>
                 </a:tc>
@@ -9377,7 +9633,7 @@
                   </a:txBody>
                   <a:tcPr>
                     <a:solidFill>
-                      <a:srgbClr val="1a233b"/>
+                      <a:srgbClr val="1A233B"/>
                     </a:solidFill>
                   </a:tcPr>
                 </a:tc>
@@ -9400,7 +9656,7 @@
                   </a:txBody>
                   <a:tcPr>
                     <a:solidFill>
-                      <a:srgbClr val="1a233b"/>
+                      <a:srgbClr val="1A233B"/>
                     </a:solidFill>
                   </a:tcPr>
                 </a:tc>
@@ -9423,10 +9679,15 @@
                   </a:txBody>
                   <a:tcPr>
                     <a:solidFill>
-                      <a:srgbClr val="1a233b"/>
+                      <a:srgbClr val="1A233B"/>
                     </a:solidFill>
                   </a:tcPr>
                 </a:tc>
+                <a:extLst>
+                  <a:ext uri="{0D108BD9-81ED-4DB2-BD59-A6C34878D82A}">
+                    <a16:rowId xmlns:a16="http://schemas.microsoft.com/office/drawing/2014/main" val="10000"/>
+                  </a:ext>
+                </a:extLst>
               </a:tr>
               <a:tr h="571500">
                 <a:tc>
@@ -9505,6 +9766,11 @@
                   </a:txBody>
                   <a:tcPr/>
                 </a:tc>
+                <a:extLst>
+                  <a:ext uri="{0D108BD9-81ED-4DB2-BD59-A6C34878D82A}">
+                    <a16:rowId xmlns:a16="http://schemas.microsoft.com/office/drawing/2014/main" val="10001"/>
+                  </a:ext>
+                </a:extLst>
               </a:tr>
               <a:tr h="571500">
                 <a:tc>
@@ -9583,6 +9849,11 @@
                   </a:txBody>
                   <a:tcPr/>
                 </a:tc>
+                <a:extLst>
+                  <a:ext uri="{0D108BD9-81ED-4DB2-BD59-A6C34878D82A}">
+                    <a16:rowId xmlns:a16="http://schemas.microsoft.com/office/drawing/2014/main" val="10002"/>
+                  </a:ext>
+                </a:extLst>
               </a:tr>
               <a:tr h="571500">
                 <a:tc>
@@ -9661,6 +9932,11 @@
                   </a:txBody>
                   <a:tcPr/>
                 </a:tc>
+                <a:extLst>
+                  <a:ext uri="{0D108BD9-81ED-4DB2-BD59-A6C34878D82A}">
+                    <a16:rowId xmlns:a16="http://schemas.microsoft.com/office/drawing/2014/main" val="10003"/>
+                  </a:ext>
+                </a:extLst>
               </a:tr>
             </a:tbl>
           </a:graphicData>
@@ -9719,7 +9995,7 @@
 </file>
 
 <file path=ppt/slides/slide26.xml><?xml version="1.0" encoding="utf-8"?>
-<p:sld xmlns:a="http://schemas.openxmlformats.org/drawingml/2006/main" xmlns:p="http://schemas.openxmlformats.org/presentationml/2006/main" xmlns:r="http://schemas.openxmlformats.org/officeDocument/2006/relationships">
+<p:sld xmlns:a="http://schemas.openxmlformats.org/drawingml/2006/main" xmlns:r="http://schemas.openxmlformats.org/officeDocument/2006/relationships" xmlns:p="http://schemas.openxmlformats.org/presentationml/2006/main">
   <p:cSld>
     <p:bg>
       <p:bgPr>
@@ -9735,7 +10011,14 @@
         <p:cNvGrpSpPr/>
         <p:nvPr/>
       </p:nvGrpSpPr>
-      <p:grpSpPr/>
+      <p:grpSpPr>
+        <a:xfrm>
+          <a:off x="0" y="0"/>
+          <a:ext cx="0" cy="0"/>
+          <a:chOff x="0" y="0"/>
+          <a:chExt cx="0" cy="0"/>
+        </a:xfrm>
+      </p:grpSpPr>
       <p:sp>
         <p:nvSpPr>
           <p:cNvPr id="2" name="Rectangle 1"/>
@@ -9776,6 +10059,7 @@
           <a:lstStyle/>
           <a:p>
             <a:pPr algn="ctr"/>
+            <a:endParaRPr/>
           </a:p>
         </p:txBody>
       </p:sp>
@@ -9824,7 +10108,7 @@
 </file>
 
 <file path=ppt/slides/slide27.xml><?xml version="1.0" encoding="utf-8"?>
-<p:sld xmlns:a="http://schemas.openxmlformats.org/drawingml/2006/main" xmlns:p="http://schemas.openxmlformats.org/presentationml/2006/main" xmlns:r="http://schemas.openxmlformats.org/officeDocument/2006/relationships">
+<p:sld xmlns:a="http://schemas.openxmlformats.org/drawingml/2006/main" xmlns:r="http://schemas.openxmlformats.org/officeDocument/2006/relationships" xmlns:p="http://schemas.openxmlformats.org/presentationml/2006/main">
   <p:cSld>
     <p:bg>
       <p:bgPr>
@@ -9840,7 +10124,14 @@
         <p:cNvGrpSpPr/>
         <p:nvPr/>
       </p:nvGrpSpPr>
-      <p:grpSpPr/>
+      <p:grpSpPr>
+        <a:xfrm>
+          <a:off x="0" y="0"/>
+          <a:ext cx="0" cy="0"/>
+          <a:chOff x="0" y="0"/>
+          <a:chExt cx="0" cy="0"/>
+        </a:xfrm>
+      </p:grpSpPr>
       <p:sp>
         <p:nvSpPr>
           <p:cNvPr id="2" name="Rectangle 1"/>
@@ -9881,6 +10172,7 @@
           <a:lstStyle/>
           <a:p>
             <a:pPr algn="ctr"/>
+            <a:endParaRPr/>
           </a:p>
         </p:txBody>
       </p:sp>
@@ -9960,6 +10252,7 @@
           <a:lstStyle/>
           <a:p>
             <a:pPr algn="ctr"/>
+            <a:endParaRPr/>
           </a:p>
         </p:txBody>
       </p:sp>
@@ -10250,7 +10543,7 @@
 </file>
 
 <file path=ppt/slides/slide28.xml><?xml version="1.0" encoding="utf-8"?>
-<p:sld xmlns:a="http://schemas.openxmlformats.org/drawingml/2006/main" xmlns:p="http://schemas.openxmlformats.org/presentationml/2006/main" xmlns:r="http://schemas.openxmlformats.org/officeDocument/2006/relationships">
+<p:sld xmlns:a="http://schemas.openxmlformats.org/drawingml/2006/main" xmlns:r="http://schemas.openxmlformats.org/officeDocument/2006/relationships" xmlns:p="http://schemas.openxmlformats.org/presentationml/2006/main">
   <p:cSld>
     <p:bg>
       <p:bgPr>
@@ -10266,7 +10559,14 @@
         <p:cNvGrpSpPr/>
         <p:nvPr/>
       </p:nvGrpSpPr>
-      <p:grpSpPr/>
+      <p:grpSpPr>
+        <a:xfrm>
+          <a:off x="0" y="0"/>
+          <a:ext cx="0" cy="0"/>
+          <a:chOff x="0" y="0"/>
+          <a:chExt cx="0" cy="0"/>
+        </a:xfrm>
+      </p:grpSpPr>
       <p:sp>
         <p:nvSpPr>
           <p:cNvPr id="2" name="Rectangle 1"/>
@@ -10307,6 +10607,7 @@
           <a:lstStyle/>
           <a:p>
             <a:pPr algn="ctr"/>
+            <a:endParaRPr/>
           </a:p>
         </p:txBody>
       </p:sp>
@@ -10386,6 +10687,7 @@
           <a:lstStyle/>
           <a:p>
             <a:pPr algn="ctr"/>
+            <a:endParaRPr/>
           </a:p>
         </p:txBody>
       </p:sp>
@@ -10676,7 +10978,7 @@
 </file>
 
 <file path=ppt/slides/slide29.xml><?xml version="1.0" encoding="utf-8"?>
-<p:sld xmlns:a="http://schemas.openxmlformats.org/drawingml/2006/main" xmlns:p="http://schemas.openxmlformats.org/presentationml/2006/main" xmlns:r="http://schemas.openxmlformats.org/officeDocument/2006/relationships">
+<p:sld xmlns:a="http://schemas.openxmlformats.org/drawingml/2006/main" xmlns:r="http://schemas.openxmlformats.org/officeDocument/2006/relationships" xmlns:p="http://schemas.openxmlformats.org/presentationml/2006/main">
   <p:cSld>
     <p:bg>
       <p:bgPr>
@@ -10692,7 +10994,14 @@
         <p:cNvGrpSpPr/>
         <p:nvPr/>
       </p:nvGrpSpPr>
-      <p:grpSpPr/>
+      <p:grpSpPr>
+        <a:xfrm>
+          <a:off x="0" y="0"/>
+          <a:ext cx="0" cy="0"/>
+          <a:chOff x="0" y="0"/>
+          <a:chExt cx="0" cy="0"/>
+        </a:xfrm>
+      </p:grpSpPr>
       <p:sp>
         <p:nvSpPr>
           <p:cNvPr id="2" name="Rectangle 1"/>
@@ -10733,6 +11042,7 @@
           <a:lstStyle/>
           <a:p>
             <a:pPr algn="ctr"/>
+            <a:endParaRPr/>
           </a:p>
         </p:txBody>
       </p:sp>
@@ -10812,6 +11122,7 @@
           <a:lstStyle/>
           <a:p>
             <a:pPr algn="ctr"/>
+            <a:endParaRPr/>
           </a:p>
         </p:txBody>
       </p:sp>
@@ -10855,6 +11166,7 @@
           <a:lstStyle/>
           <a:p>
             <a:pPr algn="ctr"/>
+            <a:endParaRPr/>
           </a:p>
         </p:txBody>
       </p:sp>
@@ -10939,6 +11251,7 @@
                 <a:latin typeface="Consolas"/>
               </a:defRPr>
             </a:pPr>
+            <a:endParaRPr/>
           </a:p>
           <a:p>
             <a:pPr>
@@ -11144,6 +11457,7 @@
                 <a:latin typeface="Consolas"/>
               </a:defRPr>
             </a:pPr>
+            <a:endParaRPr/>
           </a:p>
           <a:p>
             <a:pPr>
@@ -11300,7 +11614,7 @@
 </file>
 
 <file path=ppt/slides/slide3.xml><?xml version="1.0" encoding="utf-8"?>
-<p:sld xmlns:a="http://schemas.openxmlformats.org/drawingml/2006/main" xmlns:p="http://schemas.openxmlformats.org/presentationml/2006/main" xmlns:r="http://schemas.openxmlformats.org/officeDocument/2006/relationships">
+<p:sld xmlns:a="http://schemas.openxmlformats.org/drawingml/2006/main" xmlns:r="http://schemas.openxmlformats.org/officeDocument/2006/relationships" xmlns:p="http://schemas.openxmlformats.org/presentationml/2006/main">
   <p:cSld>
     <p:bg>
       <p:bgPr>
@@ -11316,7 +11630,14 @@
         <p:cNvGrpSpPr/>
         <p:nvPr/>
       </p:nvGrpSpPr>
-      <p:grpSpPr/>
+      <p:grpSpPr>
+        <a:xfrm>
+          <a:off x="0" y="0"/>
+          <a:ext cx="0" cy="0"/>
+          <a:chOff x="0" y="0"/>
+          <a:chExt cx="0" cy="0"/>
+        </a:xfrm>
+      </p:grpSpPr>
       <p:sp>
         <p:nvSpPr>
           <p:cNvPr id="2" name="Rectangle 1"/>
@@ -11357,6 +11678,7 @@
           <a:lstStyle/>
           <a:p>
             <a:pPr algn="ctr"/>
+            <a:endParaRPr/>
           </a:p>
         </p:txBody>
       </p:sp>
@@ -11436,6 +11758,7 @@
           <a:lstStyle/>
           <a:p>
             <a:pPr algn="ctr"/>
+            <a:endParaRPr/>
           </a:p>
         </p:txBody>
       </p:sp>
@@ -11694,7 +12017,7 @@
 </file>
 
 <file path=ppt/slides/slide30.xml><?xml version="1.0" encoding="utf-8"?>
-<p:sld xmlns:a="http://schemas.openxmlformats.org/drawingml/2006/main" xmlns:p="http://schemas.openxmlformats.org/presentationml/2006/main" xmlns:r="http://schemas.openxmlformats.org/officeDocument/2006/relationships">
+<p:sld xmlns:a="http://schemas.openxmlformats.org/drawingml/2006/main" xmlns:r="http://schemas.openxmlformats.org/officeDocument/2006/relationships" xmlns:p="http://schemas.openxmlformats.org/presentationml/2006/main">
   <p:cSld>
     <p:bg>
       <p:bgPr>
@@ -11710,7 +12033,14 @@
         <p:cNvGrpSpPr/>
         <p:nvPr/>
       </p:nvGrpSpPr>
-      <p:grpSpPr/>
+      <p:grpSpPr>
+        <a:xfrm>
+          <a:off x="0" y="0"/>
+          <a:ext cx="0" cy="0"/>
+          <a:chOff x="0" y="0"/>
+          <a:chExt cx="0" cy="0"/>
+        </a:xfrm>
+      </p:grpSpPr>
       <p:sp>
         <p:nvSpPr>
           <p:cNvPr id="2" name="Rectangle 1"/>
@@ -11751,6 +12081,7 @@
           <a:lstStyle/>
           <a:p>
             <a:pPr algn="ctr"/>
+            <a:endParaRPr/>
           </a:p>
         </p:txBody>
       </p:sp>
@@ -11830,6 +12161,7 @@
           <a:lstStyle/>
           <a:p>
             <a:pPr algn="ctr"/>
+            <a:endParaRPr/>
           </a:p>
         </p:txBody>
       </p:sp>
@@ -11842,7 +12174,7 @@
         <p:spPr>
           <a:xfrm>
             <a:off x="548640" y="1097280"/>
-            <a:ext cx="10972800" cy="5029200"/>
+            <a:ext cx="10972800" cy="3293209"/>
           </a:xfrm>
           <a:prstGeom prst="rect">
             <a:avLst/>
@@ -11855,7 +12187,7 @@
           </a:bodyPr>
           <a:lstStyle/>
           <a:p>
-            <a:pPr algn="l">
+            <a:pPr algn="just">
               <a:defRPr sz="1600" b="0">
                 <a:solidFill>
                   <a:srgbClr val="2C3E50"/>
@@ -11864,7 +12196,874 @@
               </a:defRPr>
             </a:pPr>
             <a:r>
-              <a:t>Penelitian ini berhasil mengembangkan model simulasi berbasis agen (Agent-Based Modeling) untuk menganalisis propagasi ancaman siber pada jaringan server lokal dengan dua strategi intervensi utama, yaitu patch management dan user training. Melalui simulasi Monte Carlo sebanyak 30 kali ulangan pada masing-masing dari empat skenario yang diuji, diperoleh hasil bahwa intervensi patch management mampu mereduksi puncak infeksi sebesar 20.0%, intervensi user training mereduksi sebesar 13.3%, dan kombinasi keduanya memberikan reduksi paling signifikan yaitu 33.3% dibandingkan dengan skenario baseline tanpa intervensi. Seluruh perbedaan antar skenario terkonfirmasi signifikan secara statistik melalui uji Mann-Whitney U dengan nilai p &lt; 0.001. Temuan ini membuktikan bahwa strategi keamanan berlapis (layered defense) yang menggabungkan intervensi teknis dan human-centered memberikan perlindungan yang jauh lebih efektif dibandingkan menerapkan salah satu intervensi secara terpisah. Selain itu, dashboard interaktif berbasis Streamlit yang dikembangkan memungkinkan eksplorasi parameter secara real-time dan visualisasi hasil yang komprehensif, sehingga dapat menjadi alat bantu pengambilan keputusan dalam alokasi sumber daya keamanan siber di lingkungan organisasi.</a:t>
+              <a:rPr dirty="0" err="1"/>
+              <a:t>Penelitian</a:t>
+            </a:r>
+            <a:r>
+              <a:rPr dirty="0"/>
+              <a:t> </a:t>
+            </a:r>
+            <a:r>
+              <a:rPr dirty="0" err="1"/>
+              <a:t>ini</a:t>
+            </a:r>
+            <a:r>
+              <a:rPr dirty="0"/>
+              <a:t> </a:t>
+            </a:r>
+            <a:r>
+              <a:rPr dirty="0" err="1"/>
+              <a:t>berhasil</a:t>
+            </a:r>
+            <a:r>
+              <a:rPr dirty="0"/>
+              <a:t> </a:t>
+            </a:r>
+            <a:r>
+              <a:rPr dirty="0" err="1"/>
+              <a:t>mengembangkan</a:t>
+            </a:r>
+            <a:r>
+              <a:rPr dirty="0"/>
+              <a:t> model </a:t>
+            </a:r>
+            <a:r>
+              <a:rPr dirty="0" err="1"/>
+              <a:t>simulasi</a:t>
+            </a:r>
+            <a:r>
+              <a:rPr dirty="0"/>
+              <a:t> </a:t>
+            </a:r>
+            <a:r>
+              <a:rPr dirty="0" err="1"/>
+              <a:t>berbasis</a:t>
+            </a:r>
+            <a:r>
+              <a:rPr dirty="0"/>
+              <a:t> </a:t>
+            </a:r>
+            <a:r>
+              <a:rPr dirty="0" err="1"/>
+              <a:t>agen</a:t>
+            </a:r>
+            <a:r>
+              <a:rPr dirty="0"/>
+              <a:t> (Agent-Based Modeling) </a:t>
+            </a:r>
+            <a:r>
+              <a:rPr dirty="0" err="1"/>
+              <a:t>untuk</a:t>
+            </a:r>
+            <a:r>
+              <a:rPr dirty="0"/>
+              <a:t> </a:t>
+            </a:r>
+            <a:r>
+              <a:rPr dirty="0" err="1"/>
+              <a:t>menganalisis</a:t>
+            </a:r>
+            <a:r>
+              <a:rPr dirty="0"/>
+              <a:t> </a:t>
+            </a:r>
+            <a:r>
+              <a:rPr dirty="0" err="1"/>
+              <a:t>propagasi</a:t>
+            </a:r>
+            <a:r>
+              <a:rPr dirty="0"/>
+              <a:t> </a:t>
+            </a:r>
+            <a:r>
+              <a:rPr dirty="0" err="1"/>
+              <a:t>ancaman</a:t>
+            </a:r>
+            <a:r>
+              <a:rPr dirty="0"/>
+              <a:t> </a:t>
+            </a:r>
+            <a:r>
+              <a:rPr dirty="0" err="1"/>
+              <a:t>siber</a:t>
+            </a:r>
+            <a:r>
+              <a:rPr dirty="0"/>
+              <a:t> pada </a:t>
+            </a:r>
+            <a:r>
+              <a:rPr dirty="0" err="1"/>
+              <a:t>jaringan</a:t>
+            </a:r>
+            <a:r>
+              <a:rPr dirty="0"/>
+              <a:t> server </a:t>
+            </a:r>
+            <a:r>
+              <a:rPr dirty="0" err="1"/>
+              <a:t>lokal</a:t>
+            </a:r>
+            <a:r>
+              <a:rPr dirty="0"/>
+              <a:t> </a:t>
+            </a:r>
+            <a:r>
+              <a:rPr dirty="0" err="1"/>
+              <a:t>dengan</a:t>
+            </a:r>
+            <a:r>
+              <a:rPr dirty="0"/>
+              <a:t> dua strategi </a:t>
+            </a:r>
+            <a:r>
+              <a:rPr dirty="0" err="1"/>
+              <a:t>intervensi</a:t>
+            </a:r>
+            <a:r>
+              <a:rPr dirty="0"/>
+              <a:t> </a:t>
+            </a:r>
+            <a:r>
+              <a:rPr dirty="0" err="1"/>
+              <a:t>utama</a:t>
+            </a:r>
+            <a:r>
+              <a:rPr dirty="0"/>
+              <a:t>, </a:t>
+            </a:r>
+            <a:r>
+              <a:rPr dirty="0" err="1"/>
+              <a:t>yaitu</a:t>
+            </a:r>
+            <a:r>
+              <a:rPr dirty="0"/>
+              <a:t> patch management dan user training. </a:t>
+            </a:r>
+            <a:r>
+              <a:rPr dirty="0" err="1"/>
+              <a:t>Melalui</a:t>
+            </a:r>
+            <a:r>
+              <a:rPr dirty="0"/>
+              <a:t> </a:t>
+            </a:r>
+            <a:r>
+              <a:rPr dirty="0" err="1"/>
+              <a:t>simulasi</a:t>
+            </a:r>
+            <a:r>
+              <a:rPr dirty="0"/>
+              <a:t> Monte Carlo </a:t>
+            </a:r>
+            <a:r>
+              <a:rPr dirty="0" err="1"/>
+              <a:t>sebanyak</a:t>
+            </a:r>
+            <a:r>
+              <a:rPr dirty="0"/>
+              <a:t> 30 kali </a:t>
+            </a:r>
+            <a:r>
+              <a:rPr dirty="0" err="1"/>
+              <a:t>ulangan</a:t>
+            </a:r>
+            <a:r>
+              <a:rPr dirty="0"/>
+              <a:t> pada masing-masing </a:t>
+            </a:r>
+            <a:r>
+              <a:rPr dirty="0" err="1"/>
+              <a:t>dari</a:t>
+            </a:r>
+            <a:r>
+              <a:rPr dirty="0"/>
+              <a:t> </a:t>
+            </a:r>
+            <a:r>
+              <a:rPr dirty="0" err="1"/>
+              <a:t>empat</a:t>
+            </a:r>
+            <a:r>
+              <a:rPr dirty="0"/>
+              <a:t> </a:t>
+            </a:r>
+            <a:r>
+              <a:rPr dirty="0" err="1"/>
+              <a:t>skenario</a:t>
+            </a:r>
+            <a:r>
+              <a:rPr dirty="0"/>
+              <a:t> yang </a:t>
+            </a:r>
+            <a:r>
+              <a:rPr dirty="0" err="1"/>
+              <a:t>diuji</a:t>
+            </a:r>
+            <a:r>
+              <a:rPr dirty="0"/>
+              <a:t>, </a:t>
+            </a:r>
+            <a:r>
+              <a:rPr dirty="0" err="1"/>
+              <a:t>diperoleh</a:t>
+            </a:r>
+            <a:r>
+              <a:rPr dirty="0"/>
+              <a:t> </a:t>
+            </a:r>
+            <a:r>
+              <a:rPr dirty="0" err="1"/>
+              <a:t>hasil</a:t>
+            </a:r>
+            <a:r>
+              <a:rPr dirty="0"/>
+              <a:t> </a:t>
+            </a:r>
+            <a:r>
+              <a:rPr dirty="0" err="1"/>
+              <a:t>bahwa</a:t>
+            </a:r>
+            <a:r>
+              <a:rPr dirty="0"/>
+              <a:t> </a:t>
+            </a:r>
+            <a:r>
+              <a:rPr dirty="0" err="1"/>
+              <a:t>intervensi</a:t>
+            </a:r>
+            <a:r>
+              <a:rPr dirty="0"/>
+              <a:t> patch management </a:t>
+            </a:r>
+            <a:r>
+              <a:rPr dirty="0" err="1"/>
+              <a:t>mampu</a:t>
+            </a:r>
+            <a:r>
+              <a:rPr dirty="0"/>
+              <a:t> </a:t>
+            </a:r>
+            <a:r>
+              <a:rPr dirty="0" err="1"/>
+              <a:t>mereduksi</a:t>
+            </a:r>
+            <a:r>
+              <a:rPr dirty="0"/>
+              <a:t> </a:t>
+            </a:r>
+            <a:r>
+              <a:rPr dirty="0" err="1"/>
+              <a:t>puncak</a:t>
+            </a:r>
+            <a:r>
+              <a:rPr dirty="0"/>
+              <a:t> </a:t>
+            </a:r>
+            <a:r>
+              <a:rPr dirty="0" err="1"/>
+              <a:t>infeksi</a:t>
+            </a:r>
+            <a:r>
+              <a:rPr dirty="0"/>
+              <a:t> </a:t>
+            </a:r>
+            <a:r>
+              <a:rPr dirty="0" err="1"/>
+              <a:t>sebesar</a:t>
+            </a:r>
+            <a:r>
+              <a:rPr dirty="0"/>
+              <a:t> 20.0%, </a:t>
+            </a:r>
+            <a:r>
+              <a:rPr dirty="0" err="1"/>
+              <a:t>intervensi</a:t>
+            </a:r>
+            <a:r>
+              <a:rPr dirty="0"/>
+              <a:t> user training </a:t>
+            </a:r>
+            <a:r>
+              <a:rPr dirty="0" err="1"/>
+              <a:t>mereduksi</a:t>
+            </a:r>
+            <a:r>
+              <a:rPr dirty="0"/>
+              <a:t> </a:t>
+            </a:r>
+            <a:r>
+              <a:rPr dirty="0" err="1"/>
+              <a:t>sebesar</a:t>
+            </a:r>
+            <a:r>
+              <a:rPr dirty="0"/>
+              <a:t> 13.3%, dan </a:t>
+            </a:r>
+            <a:r>
+              <a:rPr dirty="0" err="1"/>
+              <a:t>kombinasi</a:t>
+            </a:r>
+            <a:r>
+              <a:rPr dirty="0"/>
+              <a:t> </a:t>
+            </a:r>
+            <a:r>
+              <a:rPr dirty="0" err="1"/>
+              <a:t>keduanya</a:t>
+            </a:r>
+            <a:r>
+              <a:rPr dirty="0"/>
+              <a:t> </a:t>
+            </a:r>
+            <a:r>
+              <a:rPr dirty="0" err="1"/>
+              <a:t>memberikan</a:t>
+            </a:r>
+            <a:r>
+              <a:rPr dirty="0"/>
+              <a:t> </a:t>
+            </a:r>
+            <a:r>
+              <a:rPr dirty="0" err="1"/>
+              <a:t>reduksi</a:t>
+            </a:r>
+            <a:r>
+              <a:rPr dirty="0"/>
+              <a:t> paling </a:t>
+            </a:r>
+            <a:r>
+              <a:rPr dirty="0" err="1"/>
+              <a:t>signifikan</a:t>
+            </a:r>
+            <a:r>
+              <a:rPr dirty="0"/>
+              <a:t> </a:t>
+            </a:r>
+            <a:r>
+              <a:rPr dirty="0" err="1"/>
+              <a:t>yaitu</a:t>
+            </a:r>
+            <a:r>
+              <a:rPr dirty="0"/>
+              <a:t> 33.3% </a:t>
+            </a:r>
+            <a:r>
+              <a:rPr dirty="0" err="1"/>
+              <a:t>dibandingkan</a:t>
+            </a:r>
+            <a:r>
+              <a:rPr dirty="0"/>
+              <a:t> </a:t>
+            </a:r>
+            <a:r>
+              <a:rPr dirty="0" err="1"/>
+              <a:t>dengan</a:t>
+            </a:r>
+            <a:r>
+              <a:rPr dirty="0"/>
+              <a:t> </a:t>
+            </a:r>
+            <a:r>
+              <a:rPr dirty="0" err="1"/>
+              <a:t>skenario</a:t>
+            </a:r>
+            <a:r>
+              <a:rPr dirty="0"/>
+              <a:t> baseline </a:t>
+            </a:r>
+            <a:r>
+              <a:rPr dirty="0" err="1"/>
+              <a:t>tanpa</a:t>
+            </a:r>
+            <a:r>
+              <a:rPr dirty="0"/>
+              <a:t> </a:t>
+            </a:r>
+            <a:r>
+              <a:rPr dirty="0" err="1"/>
+              <a:t>intervensi</a:t>
+            </a:r>
+            <a:r>
+              <a:rPr dirty="0"/>
+              <a:t>. </a:t>
+            </a:r>
+            <a:endParaRPr lang="en-US" dirty="0"/>
+          </a:p>
+          <a:p>
+            <a:pPr algn="just">
+              <a:defRPr sz="1600" b="0">
+                <a:solidFill>
+                  <a:srgbClr val="2C3E50"/>
+                </a:solidFill>
+                <a:latin typeface="Calibri"/>
+              </a:defRPr>
+            </a:pPr>
+            <a:endParaRPr lang="en-ID" dirty="0"/>
+          </a:p>
+          <a:p>
+            <a:pPr algn="just">
+              <a:defRPr sz="1600" b="0">
+                <a:solidFill>
+                  <a:srgbClr val="2C3E50"/>
+                </a:solidFill>
+                <a:latin typeface="Calibri"/>
+              </a:defRPr>
+            </a:pPr>
+            <a:r>
+              <a:rPr dirty="0" err="1"/>
+              <a:t>Seluruh</a:t>
+            </a:r>
+            <a:r>
+              <a:rPr dirty="0"/>
+              <a:t> </a:t>
+            </a:r>
+            <a:r>
+              <a:rPr dirty="0" err="1"/>
+              <a:t>perbedaan</a:t>
+            </a:r>
+            <a:r>
+              <a:rPr dirty="0"/>
+              <a:t> </a:t>
+            </a:r>
+            <a:r>
+              <a:rPr dirty="0" err="1"/>
+              <a:t>antar</a:t>
+            </a:r>
+            <a:r>
+              <a:rPr dirty="0"/>
+              <a:t> </a:t>
+            </a:r>
+            <a:r>
+              <a:rPr dirty="0" err="1"/>
+              <a:t>skenario</a:t>
+            </a:r>
+            <a:r>
+              <a:rPr dirty="0"/>
+              <a:t> </a:t>
+            </a:r>
+            <a:r>
+              <a:rPr dirty="0" err="1"/>
+              <a:t>terkonfirmasi</a:t>
+            </a:r>
+            <a:r>
+              <a:rPr dirty="0"/>
+              <a:t> </a:t>
+            </a:r>
+            <a:r>
+              <a:rPr dirty="0" err="1"/>
+              <a:t>signifikan</a:t>
+            </a:r>
+            <a:r>
+              <a:rPr dirty="0"/>
+              <a:t> </a:t>
+            </a:r>
+            <a:r>
+              <a:rPr dirty="0" err="1"/>
+              <a:t>secara</a:t>
+            </a:r>
+            <a:r>
+              <a:rPr dirty="0"/>
+              <a:t> </a:t>
+            </a:r>
+            <a:r>
+              <a:rPr dirty="0" err="1"/>
+              <a:t>statistik</a:t>
+            </a:r>
+            <a:r>
+              <a:rPr dirty="0"/>
+              <a:t> </a:t>
+            </a:r>
+            <a:r>
+              <a:rPr dirty="0" err="1"/>
+              <a:t>melalui</a:t>
+            </a:r>
+            <a:r>
+              <a:rPr dirty="0"/>
+              <a:t> uji Mann-Whitney U </a:t>
+            </a:r>
+            <a:r>
+              <a:rPr dirty="0" err="1"/>
+              <a:t>dengan</a:t>
+            </a:r>
+            <a:r>
+              <a:rPr dirty="0"/>
+              <a:t> </a:t>
+            </a:r>
+            <a:r>
+              <a:rPr dirty="0" err="1"/>
+              <a:t>nilai</a:t>
+            </a:r>
+            <a:r>
+              <a:rPr dirty="0"/>
+              <a:t> p &lt; 0.001. </a:t>
+            </a:r>
+            <a:r>
+              <a:rPr dirty="0" err="1"/>
+              <a:t>Temuan</a:t>
+            </a:r>
+            <a:r>
+              <a:rPr dirty="0"/>
+              <a:t> </a:t>
+            </a:r>
+            <a:r>
+              <a:rPr dirty="0" err="1"/>
+              <a:t>ini</a:t>
+            </a:r>
+            <a:r>
+              <a:rPr dirty="0"/>
+              <a:t> </a:t>
+            </a:r>
+            <a:r>
+              <a:rPr dirty="0" err="1"/>
+              <a:t>membuktikan</a:t>
+            </a:r>
+            <a:r>
+              <a:rPr dirty="0"/>
+              <a:t> </a:t>
+            </a:r>
+            <a:r>
+              <a:rPr dirty="0" err="1"/>
+              <a:t>bahwa</a:t>
+            </a:r>
+            <a:r>
+              <a:rPr dirty="0"/>
+              <a:t> strategi </a:t>
+            </a:r>
+            <a:r>
+              <a:rPr dirty="0" err="1"/>
+              <a:t>keamanan</a:t>
+            </a:r>
+            <a:r>
+              <a:rPr dirty="0"/>
+              <a:t> </a:t>
+            </a:r>
+            <a:r>
+              <a:rPr dirty="0" err="1"/>
+              <a:t>berlapis</a:t>
+            </a:r>
+            <a:r>
+              <a:rPr dirty="0"/>
+              <a:t> (layered defense) yang </a:t>
+            </a:r>
+            <a:r>
+              <a:rPr dirty="0" err="1"/>
+              <a:t>menggabungkan</a:t>
+            </a:r>
+            <a:r>
+              <a:rPr dirty="0"/>
+              <a:t> </a:t>
+            </a:r>
+            <a:r>
+              <a:rPr dirty="0" err="1"/>
+              <a:t>intervensi</a:t>
+            </a:r>
+            <a:r>
+              <a:rPr dirty="0"/>
+              <a:t> </a:t>
+            </a:r>
+            <a:r>
+              <a:rPr dirty="0" err="1"/>
+              <a:t>teknis</a:t>
+            </a:r>
+            <a:r>
+              <a:rPr dirty="0"/>
+              <a:t> dan human-centered </a:t>
+            </a:r>
+            <a:r>
+              <a:rPr dirty="0" err="1"/>
+              <a:t>memberikan</a:t>
+            </a:r>
+            <a:r>
+              <a:rPr dirty="0"/>
+              <a:t> </a:t>
+            </a:r>
+            <a:r>
+              <a:rPr dirty="0" err="1"/>
+              <a:t>perlindungan</a:t>
+            </a:r>
+            <a:r>
+              <a:rPr dirty="0"/>
+              <a:t> yang </a:t>
+            </a:r>
+            <a:r>
+              <a:rPr dirty="0" err="1"/>
+              <a:t>jauh</a:t>
+            </a:r>
+            <a:r>
+              <a:rPr dirty="0"/>
+              <a:t> </a:t>
+            </a:r>
+            <a:r>
+              <a:rPr dirty="0" err="1"/>
+              <a:t>lebih</a:t>
+            </a:r>
+            <a:r>
+              <a:rPr dirty="0"/>
+              <a:t> </a:t>
+            </a:r>
+            <a:r>
+              <a:rPr dirty="0" err="1"/>
+              <a:t>efektif</a:t>
+            </a:r>
+            <a:r>
+              <a:rPr dirty="0"/>
+              <a:t> </a:t>
+            </a:r>
+            <a:r>
+              <a:rPr dirty="0" err="1"/>
+              <a:t>dibandingkan</a:t>
+            </a:r>
+            <a:r>
+              <a:rPr dirty="0"/>
+              <a:t> </a:t>
+            </a:r>
+            <a:r>
+              <a:rPr dirty="0" err="1"/>
+              <a:t>menerapkan</a:t>
+            </a:r>
+            <a:r>
+              <a:rPr dirty="0"/>
+              <a:t> salah </a:t>
+            </a:r>
+            <a:r>
+              <a:rPr dirty="0" err="1"/>
+              <a:t>satu</a:t>
+            </a:r>
+            <a:r>
+              <a:rPr dirty="0"/>
+              <a:t> </a:t>
+            </a:r>
+            <a:r>
+              <a:rPr dirty="0" err="1"/>
+              <a:t>intervensi</a:t>
+            </a:r>
+            <a:r>
+              <a:rPr dirty="0"/>
+              <a:t> </a:t>
+            </a:r>
+            <a:r>
+              <a:rPr dirty="0" err="1"/>
+              <a:t>secara</a:t>
+            </a:r>
+            <a:r>
+              <a:rPr dirty="0"/>
+              <a:t> </a:t>
+            </a:r>
+            <a:r>
+              <a:rPr dirty="0" err="1"/>
+              <a:t>terpisah</a:t>
+            </a:r>
+            <a:r>
+              <a:rPr dirty="0"/>
+              <a:t>. Selain </a:t>
+            </a:r>
+            <a:r>
+              <a:rPr dirty="0" err="1"/>
+              <a:t>itu</a:t>
+            </a:r>
+            <a:r>
+              <a:rPr dirty="0"/>
+              <a:t>, dashboard </a:t>
+            </a:r>
+            <a:r>
+              <a:rPr dirty="0" err="1"/>
+              <a:t>interaktif</a:t>
+            </a:r>
+            <a:r>
+              <a:rPr dirty="0"/>
+              <a:t> </a:t>
+            </a:r>
+            <a:r>
+              <a:rPr dirty="0" err="1"/>
+              <a:t>berbasis</a:t>
+            </a:r>
+            <a:r>
+              <a:rPr dirty="0"/>
+              <a:t> </a:t>
+            </a:r>
+            <a:r>
+              <a:rPr dirty="0" err="1"/>
+              <a:t>Streamlit</a:t>
+            </a:r>
+            <a:r>
+              <a:rPr dirty="0"/>
+              <a:t> yang </a:t>
+            </a:r>
+            <a:r>
+              <a:rPr dirty="0" err="1"/>
+              <a:t>dikembangkan</a:t>
+            </a:r>
+            <a:r>
+              <a:rPr dirty="0"/>
+              <a:t> </a:t>
+            </a:r>
+            <a:r>
+              <a:rPr dirty="0" err="1"/>
+              <a:t>memungkinkan</a:t>
+            </a:r>
+            <a:r>
+              <a:rPr dirty="0"/>
+              <a:t> </a:t>
+            </a:r>
+            <a:r>
+              <a:rPr dirty="0" err="1"/>
+              <a:t>eksplorasi</a:t>
+            </a:r>
+            <a:r>
+              <a:rPr dirty="0"/>
+              <a:t> parameter </a:t>
+            </a:r>
+            <a:r>
+              <a:rPr dirty="0" err="1"/>
+              <a:t>secara</a:t>
+            </a:r>
+            <a:r>
+              <a:rPr dirty="0"/>
+              <a:t> real-time dan </a:t>
+            </a:r>
+            <a:r>
+              <a:rPr dirty="0" err="1"/>
+              <a:t>visualisasi</a:t>
+            </a:r>
+            <a:r>
+              <a:rPr dirty="0"/>
+              <a:t> </a:t>
+            </a:r>
+            <a:r>
+              <a:rPr dirty="0" err="1"/>
+              <a:t>hasil</a:t>
+            </a:r>
+            <a:r>
+              <a:rPr dirty="0"/>
+              <a:t> yang </a:t>
+            </a:r>
+            <a:r>
+              <a:rPr dirty="0" err="1"/>
+              <a:t>komprehensif</a:t>
+            </a:r>
+            <a:r>
+              <a:rPr dirty="0"/>
+              <a:t>, </a:t>
+            </a:r>
+            <a:r>
+              <a:rPr dirty="0" err="1"/>
+              <a:t>sehingga</a:t>
+            </a:r>
+            <a:r>
+              <a:rPr dirty="0"/>
+              <a:t> </a:t>
+            </a:r>
+            <a:r>
+              <a:rPr dirty="0" err="1"/>
+              <a:t>dapat</a:t>
+            </a:r>
+            <a:r>
+              <a:rPr dirty="0"/>
+              <a:t> </a:t>
+            </a:r>
+            <a:r>
+              <a:rPr dirty="0" err="1"/>
+              <a:t>menjadi</a:t>
+            </a:r>
+            <a:r>
+              <a:rPr dirty="0"/>
+              <a:t> </a:t>
+            </a:r>
+            <a:r>
+              <a:rPr dirty="0" err="1"/>
+              <a:t>alat</a:t>
+            </a:r>
+            <a:r>
+              <a:rPr dirty="0"/>
+              <a:t> </a:t>
+            </a:r>
+            <a:r>
+              <a:rPr dirty="0" err="1"/>
+              <a:t>bantu</a:t>
+            </a:r>
+            <a:r>
+              <a:rPr dirty="0"/>
+              <a:t> </a:t>
+            </a:r>
+            <a:r>
+              <a:rPr dirty="0" err="1"/>
+              <a:t>pengambilan</a:t>
+            </a:r>
+            <a:r>
+              <a:rPr dirty="0"/>
+              <a:t> </a:t>
+            </a:r>
+            <a:r>
+              <a:rPr dirty="0" err="1"/>
+              <a:t>keputusan</a:t>
+            </a:r>
+            <a:r>
+              <a:rPr dirty="0"/>
+              <a:t> </a:t>
+            </a:r>
+            <a:r>
+              <a:rPr dirty="0" err="1"/>
+              <a:t>dalam</a:t>
+            </a:r>
+            <a:r>
+              <a:rPr dirty="0"/>
+              <a:t> </a:t>
+            </a:r>
+            <a:r>
+              <a:rPr dirty="0" err="1"/>
+              <a:t>alokasi</a:t>
+            </a:r>
+            <a:r>
+              <a:rPr dirty="0"/>
+              <a:t> </a:t>
+            </a:r>
+            <a:r>
+              <a:rPr dirty="0" err="1"/>
+              <a:t>sumber</a:t>
+            </a:r>
+            <a:r>
+              <a:rPr dirty="0"/>
+              <a:t> </a:t>
+            </a:r>
+            <a:r>
+              <a:rPr dirty="0" err="1"/>
+              <a:t>daya</a:t>
+            </a:r>
+            <a:r>
+              <a:rPr dirty="0"/>
+              <a:t> </a:t>
+            </a:r>
+            <a:r>
+              <a:rPr dirty="0" err="1"/>
+              <a:t>keamanan</a:t>
+            </a:r>
+            <a:r>
+              <a:rPr dirty="0"/>
+              <a:t> </a:t>
+            </a:r>
+            <a:r>
+              <a:rPr dirty="0" err="1"/>
+              <a:t>siber</a:t>
+            </a:r>
+            <a:r>
+              <a:rPr dirty="0"/>
+              <a:t> di </a:t>
+            </a:r>
+            <a:r>
+              <a:rPr dirty="0" err="1"/>
+              <a:t>lingkungan</a:t>
+            </a:r>
+            <a:r>
+              <a:rPr dirty="0"/>
+              <a:t> </a:t>
+            </a:r>
+            <a:r>
+              <a:rPr dirty="0" err="1"/>
+              <a:t>organisasi</a:t>
+            </a:r>
+            <a:r>
+              <a:rPr dirty="0"/>
+              <a:t>.</a:t>
             </a:r>
           </a:p>
         </p:txBody>
@@ -11878,7 +13077,7 @@
 </file>
 
 <file path=ppt/slides/slide31.xml><?xml version="1.0" encoding="utf-8"?>
-<p:sld xmlns:a="http://schemas.openxmlformats.org/drawingml/2006/main" xmlns:p="http://schemas.openxmlformats.org/presentationml/2006/main" xmlns:r="http://schemas.openxmlformats.org/officeDocument/2006/relationships">
+<p:sld xmlns:a="http://schemas.openxmlformats.org/drawingml/2006/main" xmlns:r="http://schemas.openxmlformats.org/officeDocument/2006/relationships" xmlns:p="http://schemas.openxmlformats.org/presentationml/2006/main">
   <p:cSld>
     <p:bg>
       <p:bgPr>
@@ -11894,7 +13093,14 @@
         <p:cNvGrpSpPr/>
         <p:nvPr/>
       </p:nvGrpSpPr>
-      <p:grpSpPr/>
+      <p:grpSpPr>
+        <a:xfrm>
+          <a:off x="0" y="0"/>
+          <a:ext cx="0" cy="0"/>
+          <a:chOff x="0" y="0"/>
+          <a:chExt cx="0" cy="0"/>
+        </a:xfrm>
+      </p:grpSpPr>
       <p:sp>
         <p:nvSpPr>
           <p:cNvPr id="2" name="Rectangle 1"/>
@@ -11935,6 +13141,7 @@
           <a:lstStyle/>
           <a:p>
             <a:pPr algn="ctr"/>
+            <a:endParaRPr/>
           </a:p>
         </p:txBody>
       </p:sp>
@@ -12091,7 +13298,7 @@
 </file>
 
 <file path=ppt/slides/slide4.xml><?xml version="1.0" encoding="utf-8"?>
-<p:sld xmlns:a="http://schemas.openxmlformats.org/drawingml/2006/main" xmlns:p="http://schemas.openxmlformats.org/presentationml/2006/main" xmlns:r="http://schemas.openxmlformats.org/officeDocument/2006/relationships">
+<p:sld xmlns:a="http://schemas.openxmlformats.org/drawingml/2006/main" xmlns:r="http://schemas.openxmlformats.org/officeDocument/2006/relationships" xmlns:p="http://schemas.openxmlformats.org/presentationml/2006/main">
   <p:cSld>
     <p:bg>
       <p:bgPr>
@@ -12107,7 +13314,14 @@
         <p:cNvGrpSpPr/>
         <p:nvPr/>
       </p:nvGrpSpPr>
-      <p:grpSpPr/>
+      <p:grpSpPr>
+        <a:xfrm>
+          <a:off x="0" y="0"/>
+          <a:ext cx="0" cy="0"/>
+          <a:chOff x="0" y="0"/>
+          <a:chExt cx="0" cy="0"/>
+        </a:xfrm>
+      </p:grpSpPr>
       <p:sp>
         <p:nvSpPr>
           <p:cNvPr id="2" name="Rectangle 1"/>
@@ -12148,6 +13362,7 @@
           <a:lstStyle/>
           <a:p>
             <a:pPr algn="ctr"/>
+            <a:endParaRPr/>
           </a:p>
         </p:txBody>
       </p:sp>
@@ -12227,6 +13442,7 @@
           <a:lstStyle/>
           <a:p>
             <a:pPr algn="ctr"/>
+            <a:endParaRPr/>
           </a:p>
         </p:txBody>
       </p:sp>
@@ -12501,7 +13717,7 @@
 </file>
 
 <file path=ppt/slides/slide5.xml><?xml version="1.0" encoding="utf-8"?>
-<p:sld xmlns:a="http://schemas.openxmlformats.org/drawingml/2006/main" xmlns:p="http://schemas.openxmlformats.org/presentationml/2006/main" xmlns:r="http://schemas.openxmlformats.org/officeDocument/2006/relationships">
+<p:sld xmlns:a="http://schemas.openxmlformats.org/drawingml/2006/main" xmlns:r="http://schemas.openxmlformats.org/officeDocument/2006/relationships" xmlns:p="http://schemas.openxmlformats.org/presentationml/2006/main">
   <p:cSld>
     <p:bg>
       <p:bgPr>
@@ -12517,7 +13733,14 @@
         <p:cNvGrpSpPr/>
         <p:nvPr/>
       </p:nvGrpSpPr>
-      <p:grpSpPr/>
+      <p:grpSpPr>
+        <a:xfrm>
+          <a:off x="0" y="0"/>
+          <a:ext cx="0" cy="0"/>
+          <a:chOff x="0" y="0"/>
+          <a:chExt cx="0" cy="0"/>
+        </a:xfrm>
+      </p:grpSpPr>
       <p:sp>
         <p:nvSpPr>
           <p:cNvPr id="2" name="Rectangle 1"/>
@@ -12558,6 +13781,7 @@
           <a:lstStyle/>
           <a:p>
             <a:pPr algn="ctr"/>
+            <a:endParaRPr/>
           </a:p>
         </p:txBody>
       </p:sp>
@@ -12606,7 +13830,7 @@
 </file>
 
 <file path=ppt/slides/slide6.xml><?xml version="1.0" encoding="utf-8"?>
-<p:sld xmlns:a="http://schemas.openxmlformats.org/drawingml/2006/main" xmlns:p="http://schemas.openxmlformats.org/presentationml/2006/main" xmlns:r="http://schemas.openxmlformats.org/officeDocument/2006/relationships">
+<p:sld xmlns:a="http://schemas.openxmlformats.org/drawingml/2006/main" xmlns:r="http://schemas.openxmlformats.org/officeDocument/2006/relationships" xmlns:p="http://schemas.openxmlformats.org/presentationml/2006/main">
   <p:cSld>
     <p:bg>
       <p:bgPr>
@@ -12622,7 +13846,14 @@
         <p:cNvGrpSpPr/>
         <p:nvPr/>
       </p:nvGrpSpPr>
-      <p:grpSpPr/>
+      <p:grpSpPr>
+        <a:xfrm>
+          <a:off x="0" y="0"/>
+          <a:ext cx="0" cy="0"/>
+          <a:chOff x="0" y="0"/>
+          <a:chExt cx="0" cy="0"/>
+        </a:xfrm>
+      </p:grpSpPr>
       <p:sp>
         <p:nvSpPr>
           <p:cNvPr id="2" name="Rectangle 1"/>
@@ -12663,6 +13894,7 @@
           <a:lstStyle/>
           <a:p>
             <a:pPr algn="ctr"/>
+            <a:endParaRPr/>
           </a:p>
         </p:txBody>
       </p:sp>
@@ -12742,6 +13974,7 @@
           <a:lstStyle/>
           <a:p>
             <a:pPr algn="ctr"/>
+            <a:endParaRPr/>
           </a:p>
         </p:txBody>
       </p:sp>
@@ -12888,6 +14121,7 @@
           <a:lstStyle/>
           <a:p>
             <a:pPr algn="ctr"/>
+            <a:endParaRPr/>
           </a:p>
         </p:txBody>
       </p:sp>
@@ -13019,7 +14253,7 @@
 </file>
 
 <file path=ppt/slides/slide7.xml><?xml version="1.0" encoding="utf-8"?>
-<p:sld xmlns:a="http://schemas.openxmlformats.org/drawingml/2006/main" xmlns:p="http://schemas.openxmlformats.org/presentationml/2006/main" xmlns:r="http://schemas.openxmlformats.org/officeDocument/2006/relationships">
+<p:sld xmlns:a="http://schemas.openxmlformats.org/drawingml/2006/main" xmlns:r="http://schemas.openxmlformats.org/officeDocument/2006/relationships" xmlns:p="http://schemas.openxmlformats.org/presentationml/2006/main">
   <p:cSld>
     <p:bg>
       <p:bgPr>
@@ -13035,7 +14269,14 @@
         <p:cNvGrpSpPr/>
         <p:nvPr/>
       </p:nvGrpSpPr>
-      <p:grpSpPr/>
+      <p:grpSpPr>
+        <a:xfrm>
+          <a:off x="0" y="0"/>
+          <a:ext cx="0" cy="0"/>
+          <a:chOff x="0" y="0"/>
+          <a:chExt cx="0" cy="0"/>
+        </a:xfrm>
+      </p:grpSpPr>
       <p:sp>
         <p:nvSpPr>
           <p:cNvPr id="2" name="Rectangle 1"/>
@@ -13076,6 +14317,7 @@
           <a:lstStyle/>
           <a:p>
             <a:pPr algn="ctr"/>
+            <a:endParaRPr/>
           </a:p>
         </p:txBody>
       </p:sp>
@@ -13155,6 +14397,7 @@
           <a:lstStyle/>
           <a:p>
             <a:pPr algn="ctr"/>
+            <a:endParaRPr/>
           </a:p>
         </p:txBody>
       </p:sp>
@@ -13275,6 +14518,7 @@
                 <a:latin typeface="Calibri"/>
               </a:defRPr>
             </a:pPr>
+            <a:endParaRPr/>
           </a:p>
           <a:p>
             <a:pPr>
@@ -13458,7 +14702,7 @@
 </file>
 
 <file path=ppt/slides/slide8.xml><?xml version="1.0" encoding="utf-8"?>
-<p:sld xmlns:a="http://schemas.openxmlformats.org/drawingml/2006/main" xmlns:p="http://schemas.openxmlformats.org/presentationml/2006/main" xmlns:r="http://schemas.openxmlformats.org/officeDocument/2006/relationships">
+<p:sld xmlns:a="http://schemas.openxmlformats.org/drawingml/2006/main" xmlns:r="http://schemas.openxmlformats.org/officeDocument/2006/relationships" xmlns:p="http://schemas.openxmlformats.org/presentationml/2006/main">
   <p:cSld>
     <p:bg>
       <p:bgPr>
@@ -13474,7 +14718,14 @@
         <p:cNvGrpSpPr/>
         <p:nvPr/>
       </p:nvGrpSpPr>
-      <p:grpSpPr/>
+      <p:grpSpPr>
+        <a:xfrm>
+          <a:off x="0" y="0"/>
+          <a:ext cx="0" cy="0"/>
+          <a:chOff x="0" y="0"/>
+          <a:chExt cx="0" cy="0"/>
+        </a:xfrm>
+      </p:grpSpPr>
       <p:sp>
         <p:nvSpPr>
           <p:cNvPr id="2" name="Rectangle 1"/>
@@ -13515,6 +14766,7 @@
           <a:lstStyle/>
           <a:p>
             <a:pPr algn="ctr"/>
+            <a:endParaRPr/>
           </a:p>
         </p:txBody>
       </p:sp>
@@ -13563,7 +14815,7 @@
 </file>
 
 <file path=ppt/slides/slide9.xml><?xml version="1.0" encoding="utf-8"?>
-<p:sld xmlns:a="http://schemas.openxmlformats.org/drawingml/2006/main" xmlns:p="http://schemas.openxmlformats.org/presentationml/2006/main" xmlns:r="http://schemas.openxmlformats.org/officeDocument/2006/relationships">
+<p:sld xmlns:a="http://schemas.openxmlformats.org/drawingml/2006/main" xmlns:r="http://schemas.openxmlformats.org/officeDocument/2006/relationships" xmlns:p="http://schemas.openxmlformats.org/presentationml/2006/main">
   <p:cSld>
     <p:bg>
       <p:bgPr>
@@ -13579,7 +14831,14 @@
         <p:cNvGrpSpPr/>
         <p:nvPr/>
       </p:nvGrpSpPr>
-      <p:grpSpPr/>
+      <p:grpSpPr>
+        <a:xfrm>
+          <a:off x="0" y="0"/>
+          <a:ext cx="0" cy="0"/>
+          <a:chOff x="0" y="0"/>
+          <a:chExt cx="0" cy="0"/>
+        </a:xfrm>
+      </p:grpSpPr>
       <p:sp>
         <p:nvSpPr>
           <p:cNvPr id="2" name="Rectangle 1"/>
@@ -13620,6 +14879,7 @@
           <a:lstStyle/>
           <a:p>
             <a:pPr algn="ctr"/>
+            <a:endParaRPr/>
           </a:p>
         </p:txBody>
       </p:sp>
@@ -13699,6 +14959,7 @@
           <a:lstStyle/>
           <a:p>
             <a:pPr algn="ctr"/>
+            <a:endParaRPr/>
           </a:p>
         </p:txBody>
       </p:sp>
@@ -13778,6 +15039,7 @@
           <a:lstStyle/>
           <a:p>
             <a:pPr algn="ctr"/>
+            <a:endParaRPr/>
           </a:p>
         </p:txBody>
       </p:sp>
@@ -13893,6 +15155,7 @@
           <a:lstStyle/>
           <a:p>
             <a:pPr algn="ctr"/>
+            <a:endParaRPr/>
           </a:p>
         </p:txBody>
       </p:sp>
@@ -14008,6 +15271,7 @@
           <a:lstStyle/>
           <a:p>
             <a:pPr algn="ctr"/>
+            <a:endParaRPr/>
           </a:p>
         </p:txBody>
       </p:sp>
@@ -14123,6 +15387,7 @@
           <a:lstStyle/>
           <a:p>
             <a:pPr algn="ctr"/>
+            <a:endParaRPr/>
           </a:p>
         </p:txBody>
       </p:sp>

</xml_diff>